<commit_message>
Revise presentation prose for natural Greek
</commit_message>
<xml_diff>
--- a/ensights-thesis-defense.pptx
+++ b/ensights-thesis-defense.pptx
@@ -4144,7 +4144,7 @@
                 <a:ea typeface="Calibri" pitchFamily="34" charset="-122"/>
                 <a:cs typeface="Calibri" pitchFamily="34" charset="-120"/>
               </a:rPr>
-              <a:t>Ensights — Extraction of Intelligent Analytics from E-Commerce Data</a:t>
+              <a:t>Ensights: Extraction of Intelligent Analytics from E-Commerce Data</a:t>
             </a:r>
             <a:endParaRPr lang="en-US" sz="1600" dirty="0"/>
           </a:p>
@@ -4237,7 +4237,7 @@
                   <a:srgbClr val="CADCFC"/>
                 </a:solidFill>
               </a:rPr>
-              <a:t>Εθνικό και Καποδιστριακό Πανεπιστήμιο Αθηνών — Τμήμα Πληροφορικής και Τηλεπικοινωνιών</a:t>
+              <a:t>Εθνικό και Καποδιστριακό Πανεπιστήμιο Αθηνών, Τμήμα Πληροφορικής και Τηλεπικοινωνιών</a:t>
             </a:r>
             <a:endParaRPr lang="en-US" sz="1700" dirty="0"/>
           </a:p>
@@ -4612,7 +4612,7 @@
                 <a:ea typeface="Calibri" pitchFamily="34" charset="-122"/>
                 <a:cs typeface="Calibri" pitchFamily="34" charset="-120"/>
               </a:rPr>
-              <a:t>RFM: Recency (προσφατότητα) · Frequency (συχνότητα) · Monetary (χρηματική αξία) — απλό, άμεσα ερμηνεύσιμο μοντέλο πελάτη.</a:t>
+              <a:t>Το μοντέλο RFM περιγράφει έναν πελάτη με τρία μεγέθη: πόσο πρόσφατα αγόρασε (Recency), πόσο συχνά αγοράζει (Frequency) και πόσα ξοδεύει (Monetary). Απλό και άμεσα ερμηνεύσιμο.</a:t>
             </a:r>
             <a:endParaRPr lang="en-US" sz="1400" dirty="0"/>
           </a:p>
@@ -4636,7 +4636,7 @@
                 <a:ea typeface="Calibri" pitchFamily="34" charset="-122"/>
                 <a:cs typeface="Calibri" pitchFamily="34" charset="-120"/>
               </a:rPr>
-              <a:t>Chen, Sain &amp; Guo (2012) εφαρμόζουν RFM με συσταδοποίηση στο ίδιο dataset — βάση της συσταδοποίησης 2ου επιπέδου.</a:t>
+              <a:t>Οι Chen, Sain και Guo (2012) το συνδύασαν με συσταδοποίηση πάνω στο ίδιο dataset, κάτι που αποτέλεσε τη βάση για τη συσταδοποίηση δεύτερου επιπέδου εδώ.</a:t>
             </a:r>
             <a:endParaRPr lang="en-US" sz="1400" dirty="0"/>
           </a:p>
@@ -4660,7 +4660,7 @@
                 <a:ea typeface="Calibri" pitchFamily="34" charset="-122"/>
                 <a:cs typeface="Calibri" pitchFamily="34" charset="-120"/>
               </a:rPr>
-              <a:t>Η χρηματική διάσταση είναι παρατηρούμενη αξία μέχρι σήμερα, όχι πρόβλεψη αξίας διάρκειας ζωής — σύγχυση συνήθης, οδηγεί σε υπερεκτίμηση.</a:t>
+              <a:t>Προσοχή: η χρηματική αξία είναι όσα έχει ήδη ξοδέψει ο πελάτης μέχρι σήμερα, όχι πρόβλεψη της μελλοντικής του αξίας. Η σύγχυση των δύο είναι συχνή και οδηγεί σε υπερεκτίμηση.</a:t>
             </a:r>
             <a:endParaRPr lang="en-US" sz="1400" dirty="0"/>
           </a:p>
@@ -4898,7 +4898,7 @@
                 <a:ea typeface="Calibri" pitchFamily="34" charset="-122"/>
                 <a:cs typeface="Calibri" pitchFamily="34" charset="-120"/>
               </a:rPr>
-              <a:t>CLV, CAC, LTV:CAC — απαιτούν περιθώριο κέρδους &amp; δαπάνες marketing.</a:t>
+              <a:t>Το CLV, το CAC και ο λόγος LTV:CAC χρειάζονται περιθώριο κέρδους και δαπάνες marketing.</a:t>
             </a:r>
             <a:endParaRPr lang="en-US" sz="1200" dirty="0"/>
           </a:p>
@@ -5272,7 +5272,7 @@
                 <a:ea typeface="Calibri" pitchFamily="34" charset="-122"/>
                 <a:cs typeface="Calibri" pitchFamily="34" charset="-120"/>
               </a:rPr>
-              <a:t>ENSIGHTS — Διπλωματική Εργασία</a:t>
+              <a:t>ENSIGHTS · Διπλωματική εργασία</a:t>
             </a:r>
             <a:endParaRPr lang="en-US" sz="900" dirty="0"/>
           </a:p>
@@ -5491,7 +5491,7 @@
                 <a:ea typeface="Calibri" pitchFamily="34" charset="-122"/>
                 <a:cs typeface="Calibri" pitchFamily="34" charset="-120"/>
               </a:rPr>
-              <a:t>Δημόσιο &amp; αναπαραγώγιμο· ίδιο dataset με τη μελέτη των Chen, Sain &amp; Guo (2012)· περιέχει ακυρωμένα παραστατικά — απαραίτητο για το ερώτημα των επιστροφών.</a:t>
+              <a:t>Είναι δημόσιο και αναπαραγώγιμο, το ίδιο dataset που χρησιμοποίησαν οι Chen, Sain και Guo (2012), και περιέχει ακυρωμένα παραστατικά, χωρίς τα οποία δεν θα απαντιόταν το ερώτημα των επιστροφών.</a:t>
             </a:r>
             <a:endParaRPr lang="en-US" sz="1350" dirty="0"/>
           </a:p>
@@ -6461,7 +6461,7 @@
                 <a:ea typeface="Calibri" pitchFamily="34" charset="-122"/>
                 <a:cs typeface="Calibri" pitchFamily="34" charset="-120"/>
               </a:rPr>
-              <a:t>Οι αλγόριθμοι mining/ML ζουν σε ανεξάρτητο επίπεδο, χωρίς εξάρτηση από βάση ή framework — ελέγξιμοι με δεδομένα υπολογίσιμα με το χέρι, ίδιος κώδικας αξιοποιήσιμος από σημειωματάρια Jupyter.</a:t>
+              <a:t>Οι αλγόριθμοι mining και μηχανικής μάθησης ζουν σε δικό τους επίπεδο, χωρίς καμία εξάρτηση από τη βάση ή το framework. Έτσι ελέγχονται με δεδομένα υπολογίσιμα με το χέρι, και ο ίδιος κώδικας τρέχει κατευθείαν από τα σημειωματάρια Jupyter.</a:t>
             </a:r>
             <a:endParaRPr lang="en-US" sz="1350" dirty="0"/>
           </a:p>
@@ -6954,7 +6954,7 @@
                 <a:ea typeface="Calibri" pitchFamily="34" charset="-122"/>
                 <a:cs typeface="Calibri" pitchFamily="34" charset="-120"/>
               </a:rPr>
-              <a:t>Ίδιες συναρτήσεις τροφοδοτούν και τις τρεις — ένα κάρτα και το αντίστοιχο endpoint επιστρέφουν πάντα τον ίδιο αριθμό.</a:t>
+              <a:t>Και οι τρεις τροφοδοτούνται από τις ίδιες ακριβώς συναρτήσεις, οπότε μια κάρτα του Metabase και το αντίστοιχο endpoint δίνουν πάντα τον ίδιο αριθμό.</a:t>
             </a:r>
             <a:endParaRPr lang="en-US" sz="1150" dirty="0"/>
           </a:p>
@@ -7586,7 +7586,7 @@
                 <a:ea typeface="Cambria" pitchFamily="34" charset="-122"/>
                 <a:cs typeface="Cambria" pitchFamily="34" charset="-120"/>
               </a:rPr>
-              <a:t>Τρεις οδοί παράδοσης δεδομένων — μόνο η πρώτη γράφει κώδικα</a:t>
+              <a:t>Τρεις οδοί παράδοσης δεδομένων, μόνο η πρώτη χρειάζεται κώδικα</a:t>
             </a:r>
             <a:endParaRPr lang="en-US" sz="1400" dirty="0"/>
           </a:p>
@@ -7971,7 +7971,7 @@
                 <a:ea typeface="Calibri" pitchFamily="34" charset="-122"/>
                 <a:cs typeface="Calibri" pitchFamily="34" charset="-120"/>
               </a:rPr>
-              <a:t>Η περιοχή αποθηκεύεται στην παραγγελία, όχι μόνο στον πελάτη — ιδιότητα της πώλησης.</a:t>
+              <a:t>Η περιοχή αποθηκεύεται στην ίδια την παραγγελία, γιατί είναι ιδιότητα της πώλησης και όχι μόνο του πελάτη.</a:t>
             </a:r>
             <a:endParaRPr lang="en-US" sz="1200" dirty="0"/>
           </a:p>
@@ -7995,7 +7995,7 @@
                 <a:ea typeface="Calibri" pitchFamily="34" charset="-122"/>
                 <a:cs typeface="Calibri" pitchFamily="34" charset="-120"/>
               </a:rPr>
-              <a:t>Οι επιστροφές είναι αυτοτελείς εγγραφές με θετικά μεγέθη — καθιστά αδύνατη τη σιωπηρή αφαίρεσή τους από τα έσοδα.</a:t>
+              <a:t>Οι επιστροφές καταγράφονται ως ξεχωριστές εγγραφές με θετικά μεγέθη, ώστε να μην μπορούν ποτέ να αφαιρεθούν σιωπηρά από τα έσοδα.</a:t>
             </a:r>
             <a:endParaRPr lang="en-US" sz="1200" dirty="0"/>
           </a:p>
@@ -8019,7 +8019,7 @@
                 <a:ea typeface="Calibri" pitchFamily="34" charset="-122"/>
                 <a:cs typeface="Calibri" pitchFamily="34" charset="-120"/>
               </a:rPr>
-              <a:t>Η τιμή αποθηκεύεται ανά γραμμή παραγγελίας — κάθε πώληση προσμετράται εκεί όπου πράγματι πραγματοποιήθηκε.</a:t>
+              <a:t>Η τιμή αποθηκεύεται ανά γραμμή παραγγελίας, ώστε κάθε πώληση να προσμετράται στην τιμή που πράγματι χρεώθηκε.</a:t>
             </a:r>
             <a:endParaRPr lang="en-US" sz="1200" dirty="0"/>
           </a:p>
@@ -8445,7 +8445,7 @@
                 <a:ea typeface="Calibri" pitchFamily="34" charset="-122"/>
                 <a:cs typeface="Calibri" pitchFamily="34" charset="-120"/>
               </a:rPr>
-              <a:t>Ηνωμένο Βασίλειο ≈ 86% των εσόδων· στην Ιρλανδία 5 πελάτες παράγουν περισσότερα έσοδα από τους 107 πελάτες της Γερμανίας — ένδειξη χονδρικής σχέσης.</a:t>
+              <a:t>Το Ηνωμένο Βασίλειο συγκεντρώνει περίπου το 86% των εσόδων. Στην Ιρλανδία μόλις 5 πελάτες παράγουν περισσότερα έσοδα από τους 107 της Γερμανίας, κάτι που δείχνει χονδρική και όχι λιανική σχέση.</a:t>
             </a:r>
             <a:endParaRPr lang="en-US" sz="1150" dirty="0"/>
           </a:p>
@@ -8717,7 +8717,7 @@
                 <a:ea typeface="Calibri" pitchFamily="34" charset="-122"/>
                 <a:cs typeface="Calibri" pitchFamily="34" charset="-120"/>
               </a:rPr>
-              <a:t>Μηνιαία κατανομή εσόδων — κορύφωση Νοεμβρίου και στα δύο έτη, ο τελευταίος μήνας είναι ημιτελής</a:t>
+              <a:t>Μηνιαία κατανομή εσόδων: κορύφωση τον Νοέμβριο και τις δύο χρονιές, ο τελευταίος μήνας είναι ημιτελής</a:t>
             </a:r>
             <a:endParaRPr lang="en-US" sz="1050" dirty="0"/>
           </a:p>
@@ -9227,7 +9227,7 @@
                 <a:ea typeface="Calibri" pitchFamily="34" charset="-122"/>
                 <a:cs typeface="Calibri" pitchFamily="34" charset="-120"/>
               </a:rPr>
-              <a:t>Το 38,9% των εσόδων παραμένει “uncategorised” — δηλωμένο ρητά ως το ειλικρινές μέτρο ακρίβειας της μεθόδου, όχι απόκρυψη.</a:t>
+              <a:t>Το 38,9% των εσόδων μένει “uncategorised”. Δεν κρύβεται, δηλώνεται ανοιχτά ως το πραγματικό μέτρο ακρίβειας της μεθόδου.</a:t>
             </a:r>
             <a:endParaRPr lang="en-US" sz="1150" dirty="0"/>
           </a:p>
@@ -9752,7 +9752,7 @@
                 <a:ea typeface="Cambria" pitchFamily="34" charset="-122"/>
                 <a:cs typeface="Cambria" pitchFamily="34" charset="-120"/>
               </a:rPr>
-              <a:t>Σύγκριση Apriori vs. FP-Growth — υποστήριξη 0,02</a:t>
+              <a:t>Σύγκριση Apriori και FP-Growth στο κατώφλι υποστήριξης 0,02</a:t>
             </a:r>
             <a:endParaRPr lang="en-US" sz="1300" dirty="0"/>
           </a:p>
@@ -10645,7 +10645,7 @@
                 <a:ea typeface="Calibri" pitchFamily="34" charset="-122"/>
                 <a:cs typeface="Calibri" pitchFamily="34" charset="-120"/>
               </a:rPr>
-              <a:t>Ταυτόσημα αποτελέσματα — η διαφορά είναι μόνο υπολογιστική (FP-Growth ~2,6× ταχύτερος).</a:t>
+              <a:t>Τα αποτελέσματα βγαίνουν ταυτόσημα, διαφέρουν μόνο στον χρόνο εκτέλεσης: ο FP-Growth είναι περίπου 2,6 φορές ταχύτερος.</a:t>
             </a:r>
             <a:endParaRPr lang="en-US" sz="1050" dirty="0"/>
           </a:p>
@@ -11069,7 +11069,7 @@
                 <a:ea typeface="Calibri" pitchFamily="34" charset="-122"/>
                 <a:cs typeface="Calibri" pitchFamily="34" charset="-120"/>
               </a:rPr>
-              <a:t>Ισχυρότερος κανόνας: χρωματικές παραλλαγές του REGENCY TEACUP AND SAUCER — άρση ≈ 25,2 (25× αναμενόμενη συνεμφάνιση υπό ανεξαρτησία).</a:t>
+              <a:t>Ο ισχυρότερος κανόνας αφορά τις χρωματικές παραλλαγές του REGENCY TEACUP AND SAUCER, με άρση περίπου 25,2, δηλαδή 25 φορές πάνω από ό,τι θα περίμενε κανείς αν τα προϊόντα ήταν ανεξάρτητα.</a:t>
             </a:r>
             <a:endParaRPr lang="en-US" sz="1250" dirty="0"/>
           </a:p>
@@ -11093,7 +11093,7 @@
                 <a:ea typeface="Calibri" pitchFamily="34" charset="-122"/>
                 <a:cs typeface="Calibri" pitchFamily="34" charset="-120"/>
               </a:rPr>
-              <a:t>Εμπορικά αξιοποιήσιμο: οι παραλλαγές αξίζει να προωθηθούν ως συλλογή, όχι ως ανεξάρτητοι κωδικοί.</a:t>
+              <a:t>Αυτό μεταφράζεται εύκολα σε δράση: αξίζει οι παραλλαγές να προωθηθούν μαζί, ως συλλογή.</a:t>
             </a:r>
             <a:endParaRPr lang="en-US" sz="1250" dirty="0"/>
           </a:p>
@@ -12141,7 +12141,7 @@
                 <a:ea typeface="Cambria" pitchFamily="34" charset="-122"/>
                 <a:cs typeface="Cambria" pitchFamily="34" charset="-120"/>
               </a:rPr>
-              <a:t>Πρώτο επίπεδο — Περιοχή &amp; Χρόνος</a:t>
+              <a:t>Πρώτο επίπεδο: Περιοχή και Χρόνος</a:t>
             </a:r>
             <a:endParaRPr lang="en-US" sz="3000" dirty="0"/>
           </a:p>
@@ -13164,7 +13164,7 @@
                 <a:ea typeface="Calibri" pitchFamily="34" charset="-122"/>
                 <a:cs typeface="Calibri" pitchFamily="34" charset="-120"/>
               </a:rPr>
-              <a:t>Το Ηνωμένο Βασίλειο απομονώνεται σε ιδιαίτερη συστάδα — όχι μόνο λόγω μεγέθους, αλλά λόγω χρονικής συνέχειας: δραστηριότητα σε όλους τους 25 μήνες έναντι 12,8 κατά μέσο όρο.</a:t>
+              <a:t>Το Ηνωμένο Βασίλειο βγαίνει μόνο του σε ξεχωριστή συστάδα, και όχι μόνο λόγω μεγέθους: έχει δραστηριότητα σε όλους τους 25 μήνες, ενώ οι αγορές εξαγωγής κατά μέσο όρο μόλις σε 12,8.</a:t>
             </a:r>
             <a:endParaRPr lang="en-US" sz="1250" dirty="0"/>
           </a:p>
@@ -13352,7 +13352,7 @@
                 <a:ea typeface="Cambria" pitchFamily="34" charset="-122"/>
                 <a:cs typeface="Cambria" pitchFamily="34" charset="-120"/>
               </a:rPr>
-              <a:t>Δεύτερο επίπεδο — Υποσυστάδες RFM</a:t>
+              <a:t>Δεύτερο επίπεδο: Υποσυστάδες RFM</a:t>
             </a:r>
             <a:endParaRPr lang="en-US" sz="3000" dirty="0"/>
           </a:p>
@@ -14908,7 +14908,7 @@
                 <a:ea typeface="Calibri" pitchFamily="34" charset="-122"/>
                 <a:cs typeface="Calibri" pitchFamily="34" charset="-120"/>
               </a:rPr>
-              <a:t>Επιβεβαιώνει ποσοτικά το εύρημα της Ιρλανδίας: χονδρικός πυρήνας, λιανική ουρά — ανεξαρτήτως γεωγραφικής αγοράς.</a:t>
+              <a:t>Επιβεβαιώνει με νούμερα αυτό που είδαμε στην Ιρλανδία: υπάρχει χονδρικός πυρήνας και λιανική ουρά, ανεξάρτητα από τη γεωγραφική αγορά.</a:t>
             </a:r>
             <a:endParaRPr lang="en-US" sz="1200" dirty="0"/>
           </a:p>
@@ -15057,7 +15057,7 @@
                 <a:ea typeface="Calibri" pitchFamily="34" charset="-122"/>
                 <a:cs typeface="Calibri" pitchFamily="34" charset="-120"/>
               </a:rPr>
-              <a:t>ΠΡΟΒΛΕΨΗ — HOLT-WINTERS ΕΚΘΕΤΙΚΗ ΕΞΟΜΑΛΥΝΣΗ</a:t>
+              <a:t>ΠΡΟΒΛΕΨΗ: HOLT-WINTERS ΕΚΘΕΤΙΚΗ ΕΞΟΜΑΛΥΝΣΗ</a:t>
             </a:r>
             <a:endParaRPr lang="en-US" sz="1200" dirty="0"/>
           </a:p>
@@ -15180,7 +15180,7 @@
                 <a:ea typeface="Calibri" pitchFamily="34" charset="-122"/>
                 <a:cs typeface="Calibri" pitchFamily="34" charset="-120"/>
               </a:rPr>
-              <a:t>Καθαρή αξία πωλήσεων ανά μήνα και πρόβλεψη τριμήνου — ο ημιτελής Δεκέμβριος 2011 εξαιρείται από την προσαρμογή</a:t>
+              <a:t>Καθαρή αξία πωλήσεων ανά μήνα και πρόβλεψη τριμήνου. Ο ημιτελής Δεκέμβριος του 2011 εξαιρείται από την προσαρμογή</a:t>
             </a:r>
             <a:endParaRPr lang="en-US" sz="1050" dirty="0"/>
           </a:p>
@@ -16331,7 +16331,7 @@
                 <a:ea typeface="Calibri" pitchFamily="34" charset="-122"/>
                 <a:cs typeface="Calibri" pitchFamily="34" charset="-120"/>
               </a:rPr>
-              <a:t>Αιτία: ο τελευταίος μήνας έχει μόνο 9 ημέρες (dataset ως 9/12/2011) — αποκοπή, όχι πτώση.</a:t>
+              <a:t>Ο λόγος: ο τελευταίος μήνας έχει μόνο 9 ημέρες, αφού το dataset σταματά στις 9/12/2011. Δεν είναι πτώση, είναι αποκοπή.</a:t>
             </a:r>
             <a:endParaRPr lang="en-US" sz="1150" dirty="0"/>
           </a:p>
@@ -16711,7 +16711,7 @@
                 <a:ea typeface="Calibri" pitchFamily="34" charset="-122"/>
                 <a:cs typeface="Calibri" pitchFamily="34" charset="-120"/>
               </a:rPr>
-              <a:t>Ταχύς λόγος ανά μήνα — τιμή κάτω της μονάδας σημαίνει συρρίκνωση</a:t>
+              <a:t>Ταχύς λόγος ανά μήνα. Τιμή κάτω από τη μονάδα σημαίνει ότι τα έσοδα συρρικνώνονται</a:t>
             </a:r>
             <a:endParaRPr lang="en-US" sz="1050" dirty="0"/>
           </a:p>
@@ -18185,7 +18185,7 @@
                 <a:ea typeface="Calibri" pitchFamily="34" charset="-122"/>
                 <a:cs typeface="Calibri" pitchFamily="34" charset="-120"/>
               </a:rPr>
-              <a:t>Το top πεμπτημόριο παράγει το 77% των εσόδων — έντονη ασυμμετρία.</a:t>
+              <a:t>Το κορυφαίο 20% των πελατών παράγει το 77% των εσόδων, μια πολύ έντονη ασυμμετρία.</a:t>
             </a:r>
             <a:endParaRPr lang="en-US" sz="1250" dirty="0"/>
           </a:p>
@@ -20242,7 +20242,7 @@
                 <a:ea typeface="Calibri" pitchFamily="34" charset="-122"/>
                 <a:cs typeface="Calibri" pitchFamily="34" charset="-120"/>
               </a:rPr>
-              <a:t>8 από τα 16 κελιά του πλέγματος πληρούν το σημείο αναφοράς 3:1, 8 όχι — τα ίδια ακριβώς δεδομένα οδηγούν σε αντίθετα συμπεράσματα, ανάλογα μόνο με το υποτιθέμενο περιθώριο κέρδους.</a:t>
+              <a:t>Στα 16 κελιά του πλέγματος, τα 8 περνάνε το όριο 3:1 και τα άλλα 8 όχι. Τα ίδια ακριβώς δεδομένα οδηγούν σε αντίθετα συμπεράσματα, ανάλογα μόνο με το ποιο περιθώριο κέρδους υποθέσουμε.</a:t>
             </a:r>
             <a:endParaRPr lang="en-US" sz="1150" dirty="0"/>
           </a:p>
@@ -20592,7 +20592,7 @@
                 <a:ea typeface="Calibri" pitchFamily="34" charset="-122"/>
                 <a:cs typeface="Calibri" pitchFamily="34" charset="-120"/>
               </a:rPr>
-              <a:t>Πραγματικές αποκρίσεις πάνω στο πλήρες σύνολο δεδομένων — API &amp; Metabase</a:t>
+              <a:t>Πραγματικές αποκρίσεις πάνω στο πλήρες σύνολο δεδομένων, από το API και το Metabase</a:t>
             </a:r>
             <a:endParaRPr lang="en-US" sz="1400" dirty="0"/>
           </a:p>
@@ -20631,7 +20631,7 @@
                 <a:ea typeface="Calibri" pitchFamily="34" charset="-122"/>
                 <a:cs typeface="Calibri" pitchFamily="34" charset="-120"/>
               </a:rPr>
-              <a:t>ENSIGHTS — Διπλωματική Εργασία</a:t>
+              <a:t>ENSIGHTS · Διπλωματική εργασία</a:t>
             </a:r>
             <a:endParaRPr lang="en-US" sz="900" dirty="0"/>
           </a:p>
@@ -20819,7 +20819,7 @@
                 <a:ea typeface="Calibri" pitchFamily="34" charset="-122"/>
                 <a:cs typeface="Calibri" pitchFamily="34" charset="-120"/>
               </a:rPr>
-              <a:t>Κάθε ανάλυση εκτίθεται ως JSON — ίδιοι αριθμοί με το Metabase και τη διατριβή.</a:t>
+              <a:t>Κάθε ανάλυση εκτίθεται ως JSON, με τους ίδιους αριθμούς που βλέπουμε στο Metabase και στη διατριβή.</a:t>
             </a:r>
             <a:endParaRPr lang="en-US" sz="1250" dirty="0"/>
           </a:p>
@@ -22725,7 +22725,7 @@
                 <a:ea typeface="Calibri" pitchFamily="34" charset="-122"/>
                 <a:cs typeface="Calibri" pitchFamily="34" charset="-120"/>
               </a:rPr>
-              <a:t>Η δήλωση “σενάριο, όχι μέτρηση” ταξιδεύει μέσα στο ίδιο το αντικείμενο JSON — δεν μπορεί να αφαιρεθεί εκ παραδρομής.</a:t>
+              <a:t>Η δήλωση “σενάριο, όχι μέτρηση” βρίσκεται μέσα στο ίδιο το αντικείμενο JSON, ώστε να μην μπορεί ποτέ να αφαιρεθεί κατά λάθος.</a:t>
             </a:r>
             <a:endParaRPr lang="en-US" sz="1100" dirty="0"/>
           </a:p>
@@ -22913,7 +22913,7 @@
                 <a:ea typeface="Cambria" pitchFamily="34" charset="-122"/>
                 <a:cs typeface="Cambria" pitchFamily="34" charset="-120"/>
               </a:rPr>
-              <a:t>Πίνακες ελέγχου — Sales dashboard</a:t>
+              <a:t>Πίνακες ελέγχου: το dashboard πωλήσεων</a:t>
             </a:r>
             <a:endParaRPr lang="en-US" sz="3000" dirty="0"/>
           </a:p>
@@ -23021,7 +23021,7 @@
                 <a:ea typeface="Calibri" pitchFamily="34" charset="-122"/>
                 <a:cs typeface="Calibri" pitchFamily="34" charset="-120"/>
               </a:rPr>
-              <a:t>12 κάρτες SQL, 3 dashboards — ίδιοι αριθμοί με το API</a:t>
+              <a:t>12 κάρτες SQL σε 3 dashboards, ίδιοι αριθμοί με το API</a:t>
             </a:r>
             <a:endParaRPr lang="en-US" sz="900" dirty="0"/>
           </a:p>
@@ -23332,7 +23332,7 @@
                 <a:ea typeface="Calibri" pitchFamily="34" charset="-122"/>
                 <a:cs typeface="Calibri" pitchFamily="34" charset="-120"/>
               </a:rPr>
-              <a:t>ENSIGHTS — Διπλωματική Εργασία</a:t>
+              <a:t>ENSIGHTS · Διπλωματική εργασία</a:t>
             </a:r>
             <a:endParaRPr lang="en-US" sz="900" dirty="0"/>
           </a:p>
@@ -23565,7 +23565,7 @@
                 <a:ea typeface="Calibri" pitchFamily="34" charset="-122"/>
                 <a:cs typeface="Calibri" pitchFamily="34" charset="-120"/>
               </a:rPr>
-              <a:t>Metabase — Association Rules (κάρτα SQL)</a:t>
+              <a:t>Metabase: η κάρτα Association Rules</a:t>
             </a:r>
             <a:endParaRPr lang="en-US" sz="1050" dirty="0"/>
           </a:p>
@@ -23649,7 +23649,7 @@
                 <a:ea typeface="Calibri" pitchFamily="34" charset="-122"/>
                 <a:cs typeface="Calibri" pitchFamily="34" charset="-120"/>
               </a:rPr>
-              <a:t>Swagger UI στο /try — “Try it out” σε κάθε endpoint</a:t>
+              <a:t>Το Swagger UI στο /try, με “Try it out” σε κάθε endpoint</a:t>
             </a:r>
             <a:endParaRPr lang="en-US" sz="1050" dirty="0"/>
           </a:p>
@@ -23999,7 +23999,7 @@
                 <a:ea typeface="Calibri" pitchFamily="34" charset="-122"/>
                 <a:cs typeface="Calibri" pitchFamily="34" charset="-120"/>
               </a:rPr>
-              <a:t>ENSIGHTS — Διπλωματική Εργασία</a:t>
+              <a:t>ENSIGHTS · Διπλωματική εργασία</a:t>
             </a:r>
             <a:endParaRPr lang="en-US" sz="900" dirty="0"/>
           </a:p>
@@ -24218,7 +24218,7 @@
                 <a:ea typeface="Calibri" pitchFamily="34" charset="-122"/>
                 <a:cs typeface="Calibri" pitchFamily="34" charset="-120"/>
               </a:rPr>
-              <a:t>Περιγραφικό σκέλος: οι κατηγοριοποιήσεις ανά εύρος τιμής και ανά χαρακτηριστικό διαμερίζουν πλήρως τα έσοδα — χωρίς διπλομέτρηση ή απώλεια (ελεγμένο αυτόματα).</a:t>
+              <a:t>Στο περιγραφικό σκέλος, οι κατηγοριοποιήσεις ανά εύρος τιμής και ανά χαρακτηριστικό διαμερίζουν πλήρως τα έσοδα, χωρίς διπλομέτρηση ή απώλεια, κάτι που ελέγχεται και αυτόματα.</a:t>
             </a:r>
             <a:endParaRPr lang="en-US" sz="1400" dirty="0"/>
           </a:p>
@@ -24242,7 +24242,7 @@
                 <a:ea typeface="Calibri" pitchFamily="34" charset="-122"/>
                 <a:cs typeface="Calibri" pitchFamily="34" charset="-120"/>
               </a:rPr>
-              <a:t>Apriori και FP-Growth επαληθεύτηκαν πειραματικά ταυτόσημοι — η επιλογή αφορά μόνο τον χρόνο εκτέλεσης.</a:t>
+              <a:t>Επαληθεύτηκε πειραματικά ότι ο Apriori και ο FP-Growth δίνουν ταυτόσημα αποτελέσματα, οπότε η επιλογή ανάμεσά τους είναι θέμα μόνο χρόνου εκτέλεσης.</a:t>
             </a:r>
             <a:endParaRPr lang="en-US" sz="1400" dirty="0"/>
           </a:p>
@@ -24266,7 +24266,7 @@
                 <a:ea typeface="Calibri" pitchFamily="34" charset="-122"/>
                 <a:cs typeface="Calibri" pitchFamily="34" charset="-120"/>
               </a:rPr>
-              <a:t>Η εμφωλευμένη συσταδοποίηση επιλέγει το πλήθος συστάδων σε κάθε επίπεδο μέσω δείκτη περιγράμματος, αντί ορισμού εκ των προτέρων.</a:t>
+              <a:t>Η εμφωλευμένη συσταδοποίηση επιλέγει το πλήθος συστάδων σε κάθε επίπεδο μέσω δείκτη περιγράμματος, αντί να το ορίζει εκ των προτέρων.</a:t>
             </a:r>
             <a:endParaRPr lang="en-US" sz="1400" dirty="0"/>
           </a:p>
@@ -24290,7 +24290,7 @@
                 <a:ea typeface="Calibri" pitchFamily="34" charset="-122"/>
                 <a:cs typeface="Calibri" pitchFamily="34" charset="-120"/>
               </a:rPr>
-              <a:t>Κάθε πρόβλεψη συνοδεύεται από αφελή βασική γραμμή και δείκτη δεξιότητας — αποτρέπει την παρουσίαση τετριμμένης πρόβλεψης ως επιτυχίας.</a:t>
+              <a:t>Κάθε πρόβλεψη συνοδεύεται από μια αφελή βασική γραμμή και έναν δείκτη δεξιότητας, ώστε μια τετριμμένη πρόβλεψη να μη μπορεί να παρουσιαστεί ως επιτυχία.</a:t>
             </a:r>
             <a:endParaRPr lang="en-US" sz="1400" dirty="0"/>
           </a:p>
@@ -24314,7 +24314,7 @@
                 <a:ea typeface="Calibri" pitchFamily="34" charset="-122"/>
                 <a:cs typeface="Calibri" pitchFamily="34" charset="-120"/>
               </a:rPr>
-              <a:t>Η λογιστική ανάπτυξης προσφέρει το ισχυρότερο μετρήσιμο τεκμήριο για την υγεία μιας επιχείρησης — καμία παραδοχή.</a:t>
+              <a:t>Η λογιστική ανάπτυξης είναι το πιο ισχυρό μετρήσιμο τεκμήριο για την υγεία μιας επιχείρησης, χωρίς καμία παραδοχή στη μέση.</a:t>
             </a:r>
             <a:endParaRPr lang="en-US" sz="1400" dirty="0"/>
           </a:p>
@@ -24657,7 +24657,7 @@
                 <a:ea typeface="Calibri" pitchFamily="34" charset="-122"/>
                 <a:cs typeface="Calibri" pitchFamily="34" charset="-120"/>
               </a:rPr>
-              <a:t>Η ανάλυση συγκέντρωσης αποκαλύπτει εξάρτηση από λίγους μεγάλους πελάτες — κίνδυνος αόρατος σε απλό ρυθμό ανάπτυξης.</a:t>
+              <a:t>Η ανάλυση συγκέντρωσης δείχνει εξάρτηση από λίγους μεγάλους πελάτες, έναν κίνδυνο που δεν φαίνεται αν κοιτάξει κανείς μόνο τον ρυθμό ανάπτυξης.</a:t>
             </a:r>
             <a:endParaRPr lang="en-US" sz="1300" dirty="0"/>
           </a:p>
@@ -24812,7 +24812,7 @@
                 <a:ea typeface="Calibri" pitchFamily="34" charset="-122"/>
                 <a:cs typeface="Calibri" pitchFamily="34" charset="-120"/>
               </a:rPr>
-              <a:t>Το πλέγμα ευαισθησίας κερδοφορίας δείχνει ποιες παραδοχές μεταβάλλουν το συμπέρασμα — χρήσιμο ακόμη κι όταν δεν μετράται απευθείας.</a:t>
+              <a:t>Το πλέγμα ευαισθησίας κερδοφορίας δείχνει ποιες παραδοχές αλλάζουν το συμπέρασμα, χρήσιμο ακόμη κι όταν η κερδοφορία δεν μετριέται απευθείας.</a:t>
             </a:r>
             <a:endParaRPr lang="en-US" sz="1300" dirty="0"/>
           </a:p>
@@ -25000,7 +25000,7 @@
                 <a:ea typeface="Cambria" pitchFamily="34" charset="-122"/>
                 <a:cs typeface="Cambria" pitchFamily="34" charset="-120"/>
               </a:rPr>
-              <a:t>Περιορισμοί — δηλωμένοι ρητά</a:t>
+              <a:t>Περιορισμοί, δηλωμένοι ανοιχτά</a:t>
             </a:r>
             <a:endParaRPr lang="en-US" sz="3000" dirty="0"/>
           </a:p>
@@ -25375,7 +25375,7 @@
                   <a:srgbClr val="6B7280"/>
                 </a:solidFill>
               </a:rPr>
-              <a:t>Τα ευρήματα προέρχονται από μία επιχείρηση, μίας κατηγορίας — η γενίκευσή τους παραμένει ανοιχτό ερώτημα.</a:t>
+              <a:t>Τα ευρήματα προέρχονται από μία μόνο επιχείρηση, μίας κατηγορίας, οπότε το πόσο γενικεύονται παραμένει ανοιχτό ερώτημα.</a:t>
             </a:r>
             <a:endParaRPr lang="en-US" sz="1350" dirty="0"/>
           </a:p>
@@ -25713,7 +25713,7 @@
                   <a:srgbClr val="20263B"/>
                 </a:solidFill>
               </a:rPr>
-              <a:t>BG/NBD &amp; Gamma-Gamma πάνω στα ίδια τρία μεγέθη RFM — παρατηρούμενη αξία γίνεται πρόβλεψη.</a:t>
+              <a:t>Τα μοντέλα BG/NBD και Gamma-Gamma πάνω στα ίδια τρία μεγέθη RFM θα μετέτρεπαν την παρατηρούμενη αξία σε πρόβλεψη.</a:t>
             </a:r>
             <a:endParaRPr lang="en-US" sz="1300" dirty="0"/>
           </a:p>
@@ -25863,7 +25863,7 @@
                   <a:srgbClr val="20263B"/>
                 </a:solidFill>
               </a:rPr>
-              <a:t>Σύγκριση διαδοχικών εκτελέσεων mining — ποιες συσχετίσεις εμφανίζονται ή εξασθενούν.</a:t>
+              <a:t>Συγκρίνοντας διαδοχικές εκτελέσεις mining θα φαινόταν ποιες συσχετίσεις εμφανίζονται ή εξασθενούν με τον καιρό.</a:t>
             </a:r>
             <a:endParaRPr lang="en-US" sz="1300" dirty="0"/>
           </a:p>
@@ -26169,7 +26169,7 @@
                 <a:ea typeface="Cambria" pitchFamily="34" charset="-122"/>
                 <a:cs typeface="Cambria" pitchFamily="34" charset="-120"/>
               </a:rPr>
-              <a:t>Να απαντηθεί ό,τι ζήτησε η επιχείρηση —</a:t>
+              <a:t>Να απαντηθεί ό,τι ζήτησε η επιχείρηση,</a:t>
             </a:r>
             <a:endParaRPr lang="en-US" sz="2700" dirty="0"/>
           </a:p>
@@ -26306,7 +26306,7 @@
                 <a:ea typeface="Calibri" pitchFamily="34" charset="-122"/>
                 <a:cs typeface="Calibri" pitchFamily="34" charset="-120"/>
               </a:rPr>
-              <a:t>ENSIGHTS — Χρήστος Μουρτογιάννης</a:t>
+              <a:t>ENSIGHTS · Χρήστος Μουρτογιάννης</a:t>
             </a:r>
             <a:endParaRPr lang="en-US" sz="900" dirty="0"/>
           </a:p>
@@ -28682,7 +28682,7 @@
                 <a:ea typeface="Calibri" pitchFamily="34" charset="-122"/>
                 <a:cs typeface="Calibri" pitchFamily="34" charset="-120"/>
               </a:rPr>
-              <a:t>Han, Kamber &amp; Pei — Data Mining: Concepts and Techniques, κεφ. 2, 3, 6, 10</a:t>
+              <a:t>Han, Kamber &amp; Pei, Data Mining: Concepts and Techniques, κεφ. 2, 3, 6, 10</a:t>
             </a:r>
             <a:endParaRPr lang="en-US" sz="1400" dirty="0"/>
           </a:p>
@@ -28721,7 +28721,7 @@
                 <a:ea typeface="Calibri" pitchFamily="34" charset="-122"/>
                 <a:cs typeface="Calibri" pitchFamily="34" charset="-120"/>
               </a:rPr>
-              <a:t>ENSIGHTS — Διπλωματική Εργασία</a:t>
+              <a:t>ENSIGHTS · Διπλωματική εργασία</a:t>
             </a:r>
             <a:endParaRPr lang="en-US" sz="900" dirty="0"/>
           </a:p>
@@ -28916,7 +28916,7 @@
                 <a:ea typeface="Calibri" pitchFamily="34" charset="-122"/>
                 <a:cs typeface="Calibri" pitchFamily="34" charset="-120"/>
               </a:rPr>
-              <a:t>Υποστήριξη: support(X) = |{T ∈ D : X ⊆ T}| / |D| — ποσοστό συναλλαγών που περιέχουν το X.</a:t>
+              <a:t>Η υποστήριξη δείχνει σε τι ποσοστό των συναλλαγών εμφανίζεται ένα σύνολο X: support(X) = |{T ∈ D : X ⊆ T}| / |D|.</a:t>
             </a:r>
             <a:endParaRPr lang="en-US" sz="1400" dirty="0"/>
           </a:p>
@@ -28940,7 +28940,7 @@
                 <a:ea typeface="Calibri" pitchFamily="34" charset="-122"/>
                 <a:cs typeface="Calibri" pitchFamily="34" charset="-120"/>
               </a:rPr>
-              <a:t>Εμπιστοσύνη: confidence(X⇒Y) = support(X∪Y) / support(X) — υπό συνθήκη πιθανότητα.</a:t>
+              <a:t>Η εμπιστοσύνη είναι η πιθανότητα να δούμε το Y όταν έχει ήδη εμφανιστεί το X: confidence(X⇒Y) = support(X∪Y) / support(X).</a:t>
             </a:r>
             <a:endParaRPr lang="en-US" sz="1400" dirty="0"/>
           </a:p>
@@ -28964,7 +28964,7 @@
                 <a:ea typeface="Calibri" pitchFamily="34" charset="-122"/>
                 <a:cs typeface="Calibri" pitchFamily="34" charset="-120"/>
               </a:rPr>
-              <a:t>Άρση (lift): confidence(X⇒Y) / support(Y) — διορθώνει την εμπιστοσύνη ως προς τη δημοφιλία του Y.</a:t>
+              <a:t>Αυτή που μας ενδιαφέρει περισσότερο είναι η άρση (lift), γιατί διορθώνει την εμπιστοσύνη ως προς το πόσο δημοφιλές είναι το Y από μόνο του: lift = confidence(X⇒Y) / support(Y).</a:t>
             </a:r>
             <a:endParaRPr lang="en-US" sz="1400" dirty="0"/>
           </a:p>
@@ -28988,7 +28988,7 @@
                 <a:ea typeface="Calibri" pitchFamily="34" charset="-122"/>
                 <a:cs typeface="Calibri" pitchFamily="34" charset="-120"/>
               </a:rPr>
-              <a:t>lift &gt; 1: συνεμφάνιση ισχυρότερη από τυχαία · = 1: ανεξαρτησία · &lt; 1: αρνητική συσχέτιση.</a:t>
+              <a:t>Πάνω από 1 σημαίνει ισχυρότερη συνεμφάνιση απ' ό,τι θα περίμενε κανείς τυχαία, ίση με 1 σημαίνει ανεξαρτησία, κάτω από 1 αρνητική συσχέτιση.</a:t>
             </a:r>
             <a:endParaRPr lang="en-US" sz="1400" dirty="0"/>
           </a:p>
@@ -29199,7 +29199,7 @@
                 <a:ea typeface="Calibri" pitchFamily="34" charset="-122"/>
                 <a:cs typeface="Calibri" pitchFamily="34" charset="-120"/>
               </a:rPr>
-              <a:t>Για το ίδιο κατώφλι υποστήριξης, τα δύο αποτελέσματα είναι ταυτόσημα — η διαφορά τους είναι υπολογιστική.</a:t>
+              <a:t>Για το ίδιο κατώφλι υποστήριξης τα δύο αποτελέσματα βγαίνουν ταυτόσημα, η διαφορά είναι μόνο στον χρόνο εκτέλεσης.</a:t>
             </a:r>
             <a:endParaRPr lang="en-US" sz="1250" dirty="0"/>
           </a:p>
@@ -29433,7 +29433,7 @@
                 <a:ea typeface="Calibri" pitchFamily="34" charset="-122"/>
                 <a:cs typeface="Calibri" pitchFamily="34" charset="-120"/>
               </a:rPr>
-              <a:t>k-means (MacQueen, 1967): ελαχιστοποιεί J = Σᵢ Σ_{x∈Cᵢ} ‖x − μᵢ‖² — άθροισμα τετραγωνικών αποστάσεων από το κέντρο.</a:t>
+              <a:t>Ο k-means (MacQueen, 1967) ψάχνει τα κέντρα συστάδων που ελαχιστοποιούν το J = Σᵢ Σ_{x∈Cᵢ} ‖x − μᵢ‖², δηλαδή τις τετραγωνικές αποστάσεις κάθε σημείου από το κέντρο του.</a:t>
             </a:r>
             <a:endParaRPr lang="en-US" sz="1400" dirty="0"/>
           </a:p>
@@ -29457,7 +29457,7 @@
                 <a:ea typeface="Calibri" pitchFamily="34" charset="-122"/>
                 <a:cs typeface="Calibri" pitchFamily="34" charset="-120"/>
               </a:rPr>
-              <a:t>Προϋποθέτει συγκρίσιμες αποστάσεις μεταξύ διαστάσεων ⇒ τυποποίηση χαρακτηριστικών πριν τη συσταδοποίηση είναι προϋπόθεση ορθότητας, όχι προαιρετική βελτίωση.</a:t>
+              <a:t>Χρειάζεται συγκρίσιμες αποστάσεις μεταξύ διαστάσεων, οπότε η τυποποίηση των χαρακτηριστικών πριν τη συσταδοποίηση δεν είναι βελτίωση, είναι προϋπόθεση για να βγει σωστό αποτέλεσμα.</a:t>
             </a:r>
             <a:endParaRPr lang="en-US" sz="1400" dirty="0"/>
           </a:p>
@@ -29481,7 +29481,7 @@
                 <a:ea typeface="Calibri" pitchFamily="34" charset="-122"/>
                 <a:cs typeface="Calibri" pitchFamily="34" charset="-120"/>
               </a:rPr>
-              <a:t>Δείκτης περιγράμματος (Rousseeuw, 1987): s(i) = (b(i) − a(i)) / max{a(i), b(i)} ∈ [−1, 1] — αξιολογεί την κατάτμηση χωρίς γνώση της πραγματικής ομαδοποίησης.</a:t>
+              <a:t>Ο δείκτης περιγράμματος του Rousseeuw (1987), s(i) = (b(i) − a(i)) / max{a(i), b(i)} με τιμές στο [−1, 1], αξιολογεί μια κατάτμηση χωρίς να χρειάζεται να ξέρουμε την πραγματική ομαδοποίηση.</a:t>
             </a:r>
             <a:endParaRPr lang="en-US" sz="1400" dirty="0"/>
           </a:p>
@@ -29505,7 +29505,7 @@
                 <a:ea typeface="Calibri" pitchFamily="34" charset="-122"/>
                 <a:cs typeface="Calibri" pitchFamily="34" charset="-120"/>
               </a:rPr>
-              <a:t>Χρησιμοποιείται για να επιλεγεί το πλήθος συστάδων k από τα δεδομένα, αντί να οριστεί εκ των προτέρων.</a:t>
+              <a:t>Χρησιμοποιείται εδώ για να επιλεγεί το πλήθος συστάδων k από τα ίδια τα δεδομένα, αντί να οριστεί εκ των προτέρων.</a:t>
             </a:r>
             <a:endParaRPr lang="en-US" sz="1400" dirty="0"/>
           </a:p>

</xml_diff>

<commit_message>
Add per-slide speaker notes to the presentation
</commit_message>
<xml_diff>
--- a/ensights-thesis-defense.pptx
+++ b/ensights-thesis-defense.pptx
@@ -537,7 +537,7 @@
           <a:p>
             <a:r>
               <a:rPr lang="en-US" dirty="0"/>
-              <a:t/>
+              <a:t>Η πρώτη διαφάνεια: ποιος είσαι, ποιο είναι το θέμα, ποιος σε επιβλέπει, πότε γίνεται η παρουσίαση. Τίποτα τεχνικό, απλές συστάσεις.</a:t>
             </a:r>
             <a:endParaRPr lang="en-US" dirty="0"/>
           </a:p>
@@ -625,7 +625,7 @@
           <a:p>
             <a:r>
               <a:rPr lang="en-US" dirty="0"/>
-              <a:t/>
+              <a:t>RFM είναι 3 απλοί αριθμοί για κάθε πελάτη: Recency, πόσο πρόσφατα αγόρασε, Frequency, πόσο συχνά αγοράζει, και Monetary, πόσα έχει ξοδέψει συνολικά. Κάποια οικονομικά μεγέθη, π.χ. πόσα έσοδα μπήκαν συνολικά, υπολογίζονται απευθείας από τα δεδομένα. Άλλα, π.χ. πόσο κέρδος θα φέρει ένας πελάτης στο μέλλον, χρειάζονται υποθέσεις που δεν υπάρχουν στα δεδομένα.</a:t>
             </a:r>
             <a:endParaRPr lang="en-US" dirty="0"/>
           </a:p>
@@ -713,7 +713,7 @@
           <a:p>
             <a:r>
               <a:rPr lang="en-US" dirty="0"/>
-              <a:t/>
+              <a:t>Αλλαγή ενότητας: τώρα εξηγείς πώς είναι φτιαγμένο το σύστημα και τι δεδομένα χρησιμοποιεί.</a:t>
             </a:r>
             <a:endParaRPr lang="en-US" dirty="0"/>
           </a:p>
@@ -801,7 +801,8 @@
           <a:p>
             <a:r>
               <a:rPr lang="en-US" dirty="0"/>
-              <a:t/>
+              <a:t>Αυτό είναι το πείραμα πάνω στο οποίο δοκιμάστηκε όλο το σύστημα: πραγματικές πωλήσεις ενός βρετανικού καταστήματος χονδρικής πώλησης δώρων, 2009 έως 2011. Πάνω από ένα εκατομμύριο γραμμές δεδομένων.
+ΠΙΘΑΝΗ ΕΡΩΤΗΣΗ: «Γιατί αυτό το dataset;» Είναι δημόσιο, οπότε ο καθένας μπορεί να το ελέγξει. Το χρησιμοποίησε ήδη άλλη επιστημονική εργασία, οπότε μπορείς να συγκρίνεις. Και έχει επιστροφές, οπότε μπορείς να απαντήσεις το ερώτημα των επιστροφών.</a:t>
             </a:r>
             <a:endParaRPr lang="en-US" dirty="0"/>
           </a:p>
@@ -889,7 +890,8 @@
           <a:p>
             <a:r>
               <a:rPr lang="en-US" dirty="0"/>
-              <a:t/>
+              <a:t>Το πίσω μέρος του συστήματος. Φαντάσου το σαν κτίριο με τέσσερις ορόφους: πάνω-πάνω το API, που δέχεται ερωτήματα, μετά τα services, η λογική της επιχείρησης, μετά τα repositories, που πάνε και φέρνουν δεδομένα, και κάτω-κάτω η βάση δεδομένων. Κάθε όροφος μιλάει μόνο με τον διπλανό του, ποτέ δεν παρακάμπτει επίπεδα. Έτσι, αν χρειαστεί να αλλάξεις κάτι σε έναν όροφο, δεν χρειάζεται να πειράξεις τους υπόλοιπους.
+ΠΙΘΑΝΗ ΕΡΩΤΗΣΗ: «Γιατί FastAPI, PostgreSQL και Celery;» Το FastAPI είναι φτιαγμένο για ασύγχρονη δουλειά, ταιριάζει με αργές αναλύσεις. Η PostgreSQL κάνει σύνθετα ερωτήματα απευθείας στη βάση. Το Celery τρέχει δουλειές στο παρασκήνιο χωρίς να μπλοκάρει τον χρήστη που περιμένει απάντηση.</a:t>
             </a:r>
             <a:endParaRPr lang="en-US" dirty="0"/>
           </a:p>
@@ -977,7 +979,8 @@
           <a:p>
             <a:r>
               <a:rPr lang="en-US" dirty="0"/>
-              <a:t/>
+              <a:t>Δείχνει πώς το σύστημα δουλεύει με οποιοδήποτε μαγαζί, όχι μόνο με το συγκεκριμένο dataset. Κάθε μαγαζί έχει δικά του «Πελάτες», «Προϊόντα» και τα λοιπά, αλλά όλα μεταφράζονται στην ίδια κοινή γλώσσα, έξι βασικές έννοιες. Υπάρχουν τρεις τρόποι να στείλεις δεδομένα στο σύστημα, και μόνο ο ένας χρειάζεται να γραφτεί καινούριος κώδικας.
+ΠΙΘΑΝΗ ΕΡΩΤΗΣΗ: «Πώς αποδεικνύεται ότι είναι πραγματικά γενικό, και όχι απλώς σχεδιασμένο να φαίνεται έτσι;» Δοκιμάστηκε πάνω σε δεύτερη πηγή δεδομένων, εντελώς διαφορετική σε σχήμα και ονόματα από το Online Retail II.</a:t>
             </a:r>
             <a:endParaRPr lang="en-US" dirty="0"/>
           </a:p>
@@ -1065,7 +1068,7 @@
           <a:p>
             <a:r>
               <a:rPr lang="en-US" dirty="0"/>
-              <a:t/>
+              <a:t>Δύο απλά γραφήματα: ποια προϊόντα έφεραν τα περισσότερα έσοδα, ποιες χώρες αγόρασαν τα περισσότερα. Έκπληξη: το προϊόν με τις περισσότερες μονάδες δεν είναι πάντα αυτό με τα περισσότερα έσοδα. Ένα ακριβό προϊόν μπορεί να πουλήσει λιγότερα κομμάτια αλλά να φέρει περισσότερα χρήματα συνολικά.</a:t>
             </a:r>
             <a:endParaRPr lang="en-US" dirty="0"/>
           </a:p>
@@ -1153,7 +1156,7 @@
           <a:p>
             <a:r>
               <a:rPr lang="en-US" dirty="0"/>
-              <a:t/>
+              <a:t>Πότε μέσα στο χρόνο γίνονται οι πωλήσεις; Ο Νοέμβριος είναι ο πιο δυνατός μήνας, λόγω προετοιμασίας για τα Χριστούγεννα, και κάποιες μέρες της εβδομάδας πουλάνε καλύτερα από άλλες.</a:t>
             </a:r>
             <a:endParaRPr lang="en-US" dirty="0"/>
           </a:p>
@@ -1241,7 +1244,7 @@
           <a:p>
             <a:r>
               <a:rPr lang="en-US" dirty="0"/>
-              <a:t/>
+              <a:t>Χωρίζει τα προϊόντα σε φθηνά και ακριβά, και σε κατηγορίες όπως κουζίνα ή vintage, βασισμένα στις λέξεις της περιγραφής τους. Τίμιο σημείο: το 38,9% των εσόδων δεν μπόρεσε να κατηγοριοποιηθεί, γιατί δεν υπήρχε επίσημη κατηγορία στα δεδομένα, μόνο ελεύθερο κείμενο. Αυτό λέγεται ανοιχτά αντί να κρύβεται.</a:t>
             </a:r>
             <a:endParaRPr lang="en-US" dirty="0"/>
           </a:p>
@@ -1329,7 +1332,7 @@
           <a:p>
             <a:r>
               <a:rPr lang="en-US" dirty="0"/>
-              <a:t/>
+              <a:t>Καλάθι σημαίνει όλα τα προϊόντα μιας παραγγελίας μαζί. Ο πελάτης στη μέση (το διάμεσο, όχι ο μέσος όρος) έβαζε 17 διαφορετικά προϊόντα σε ένα καλάθι, χαρακτηριστικό χονδρεμπορίου και όχι απλής λιανικής. Δείχνει επίσης ότι οι δύο αλγόριθμοι έδωσαν ακριβώς το ίδιο αποτέλεσμα, με τον FP-Growth περίπου 2,6 φορές πιο γρήγορο.</a:t>
             </a:r>
             <a:endParaRPr lang="en-US" dirty="0"/>
           </a:p>
@@ -1417,7 +1420,7 @@
           <a:p>
             <a:r>
               <a:rPr lang="en-US" dirty="0"/>
-              <a:t/>
+              <a:t>Δείχνει τι συμβαίνει αν αλλάξεις το κατώφλι, δηλαδή πόσο σπάνιο επιτρέπεις να είναι ένα σύνολο προϊόντων για να το μετρήσουμε. Πιο αυστηρό κατώφλι σημαίνει λιγότεροι αλλά πιο σίγουροι κανόνες. Ο πιο δυνατός κανόνας: τρία χρώματα του ίδιου σετ τσαγιού αγοράζονται μαζί 25 φορές πιο συχνά απ' ό,τι τυχαία. Βλέπε τη Διαφάνεια 8 για το πώς υπολογίζεται το lift.</a:t>
             </a:r>
             <a:endParaRPr lang="en-US" dirty="0"/>
           </a:p>
@@ -1505,7 +1508,7 @@
           <a:p>
             <a:r>
               <a:rPr lang="en-US" dirty="0"/>
-              <a:t/>
+              <a:t>Ο χάρτης της παρουσίασης: τι θα πεις πρώτα, τι μετά, πώς κλείνει. Βοηθάει το κοινό να ξέρει πού βρίσκεσαι ανά πάσα στιγμή.</a:t>
             </a:r>
             <a:endParaRPr lang="en-US" dirty="0"/>
           </a:p>
@@ -1593,7 +1596,7 @@
           <a:p>
             <a:r>
               <a:rPr lang="en-US" dirty="0"/>
-              <a:t/>
+              <a:t>Χωρίζει τις χώρες σε ομάδες βάσει εσόδων, παραγγελιών και δραστηριότητας μέσα στον χρόνο. Το αποτέλεσμα: μόνο δύο ομάδες βγαίνουν φυσικά. Το Ηνωμένο Βασίλειο μόνο του, γιατί αγοράζει σχεδόν κάθε μήνα, και όλες οι υπόλοιπες 42 χώρες μαζί, γιατί αγοράζουν σποραδικά, λίγες φορές τον χρόνο.</a:t>
             </a:r>
             <a:endParaRPr lang="en-US" dirty="0"/>
           </a:p>
@@ -1681,7 +1684,7 @@
           <a:p>
             <a:r>
               <a:rPr lang="en-US" dirty="0"/>
-              <a:t/>
+              <a:t>Μέσα σε κάθε ομάδα χωρών, ξαναχωρίζουμε τους πελάτες σε δύο τύπους: τους συνηθισμένους, πολλοί σε αριθμό αλλά αγοράζουν λίγες φορές και μικρά ποσά, και τους λεγόμενους whales, ελάχιστοι σε αριθμό αλλά αγοράζουν συχνά και τεράστια ποσά. Αυτή η ίδια δομή εμφανίζεται και στις δύο ομάδες χωρών, ανεξάρτητα.</a:t>
             </a:r>
             <a:endParaRPr lang="en-US" dirty="0"/>
           </a:p>
@@ -1769,7 +1772,9 @@
           <a:p>
             <a:r>
               <a:rPr lang="en-US" dirty="0"/>
-              <a:t/>
+              <a:t>Μαντεύει τις πωλήσεις των επόμενων μηνών από το ιστορικό: γενική τάση, και αν φτάνει το ιστορικό, ετήσιο μοτίβο. Ενδιαφέρουσα ιστορία: το πρώτο αποτέλεσμα φαινόταν χειρότερο από το χαζό μάντεμα. Ο τελευταίος μήνας είχε μόνο 9 μέρες αντί για 30, οπότε έμοιαζε με κατάρρευση ενώ ήταν απλώς κομμένος. Μόλις εξαιρέθηκε, το μοντέλο βγήκε καλύτερο.
+ΜΑΘΗΜΑΤΙΚΑ: Skill score = 1 − (δικό μας σφάλμα / σφάλμα του χαζού μαντέματος «ίδιο με τον προηγούμενο μήνα»). Θετικό: νικάμε το χαζό μάντεμα. Αρνητικό: χάνουμε από αυτό.
+ΠΙΘΑΝΗ ΕΡΩΤΗΣΗ: «Γιατί Holt-Winters και όχι ARIMA ή deep learning;» Διαφανές, λίγες παράμετροι, δουλεύει με λίγο ιστορικό. Έχουμε μόλις 24-25 μήνες. Δηλώνεται ρητά ότι δεν είναι η ακριβέστερη, το skill score δείχνει το όριο.</a:t>
             </a:r>
             <a:endParaRPr lang="en-US" dirty="0"/>
           </a:p>
@@ -1857,7 +1862,8 @@
           <a:p>
             <a:r>
               <a:rPr lang="en-US" dirty="0"/>
-              <a:t/>
+              <a:t>Σπάει τη μεταβολή των εσόδων κάθε μήνα σε έξι κουβάδες: πόσα έφεραν νέοι πελάτες, πόσα έφεραν παλιοί που ξαναγύρισαν, πόσα ήταν ίδια με πριν, πόσα ήταν μπόνους από υπάρχοντες πελάτες που ξόδεψαν παραπάνω, πόσα χάθηκαν από πελάτες που ξόδεψαν λιγότερο, και πόσα χάθηκαν εντελώς από πελάτες που έφυγαν.
+ΜΑΘΗΜΑΤΙΚΑ: Quick ratio = (καλά πράγματα) / (κακά πράγματα), δηλαδή (νέα + αναβιωμένα + επέκταση) / (συρρίκνωση + απώλεια). Πάνω από 1 σημαίνει ότι η επιχείρηση μεγαλώνει. Κάτω από 1 σημαίνει ότι μικραίνει.</a:t>
             </a:r>
             <a:endParaRPr lang="en-US" dirty="0"/>
           </a:p>
@@ -1945,7 +1951,8 @@
           <a:p>
             <a:r>
               <a:rPr lang="en-US" dirty="0"/>
-              <a:t/>
+              <a:t>Το 72,4% των πελατών ξαναγόρασαν, πολύ υψηλό ποσοστό που δείχνει χονδρεμπόριο και όχι απλή λιανική. Ο συντελεστής Gini δείχνει πόσο άνισα μοιράζονται τα έσοδα ανάμεσα στους πελάτες. Αλλά ο μεγαλύτερος μεμονωμένος πελάτης είναι μόλις 3,3% των εσόδων, άρα δεν υπάρχει κίνδυνος αν φύγει ένας και μόνο πελάτης.
+ΜΑΘΗΜΑΤΙΚΑ: Ο δείκτης Gini: φαντάσου 100 ανθρώπους κι ένα χρηματοκιβώτιο. Αν όλοι έχουν ακριβώς τα ίδια λεφτά, αυτό είναι απόλυτα δίκαιο, Gini = 0. Αν ένας άνθρωπος έχει όλα τα λεφτά και οι υπόλοιποι τίποτα, αυτό είναι απόλυτα άδικο, Gini = 1. Το δικό μας νούμερο, 0,740, είναι πιο κοντά στο άδικο άκρο, αλλά όχι στο μέγιστο.</a:t>
             </a:r>
             <a:endParaRPr lang="en-US" dirty="0"/>
           </a:p>
@@ -2033,7 +2040,9 @@
           <a:p>
             <a:r>
               <a:rPr lang="en-US" dirty="0"/>
-              <a:t/>
+              <a:t>Το πιο σημαντικό κομμάτι για την ειλικρίνεια της δουλειάς. Δεν ξέρουμε το πραγματικό κόστος του μαγαζιού, οπότε δεν λέμε «κερδίζει τόσα». Λέμε: αν το περιθώριο είναι τόσο και το κόστος απόκτησης τόσο, τότε βγαίνει αυτό. Και δοκιμάζουμε πολλούς συνδυασμούς.
+ΜΑΘΗΜΑΤΙΚΑ: LTV:CAC = πόσα φέρνει συνολικά ένας πελάτης (LTV) διά πόσο κόστισε να τον αποκτήσεις (CAC). Πληρώνεις 100 και σου φέρνει 300 κέρδος: 3:1, καλή επένδυση. Σου φέρνει 90: έχασες λεφτά.
+ΠΙΘΑΝΗ ΕΡΩΤΗΣΗ: «Γιατί δεν υποθέτετε ένα λογικό περιθώριο για μια τελική απάντηση;» Θα ήταν υπόθεση ντυμένη σαν εύρημα. Δηλώνουμε τις παραδοχές και δείχνουμε πώς αλλάζει το συμπέρασμα.</a:t>
             </a:r>
             <a:endParaRPr lang="en-US" dirty="0"/>
           </a:p>
@@ -2121,7 +2130,7 @@
           <a:p>
             <a:r>
               <a:rPr lang="en-US" dirty="0"/>
-              <a:t/>
+              <a:t>Αλλαγή ενότητας: τώρα δείχνεις πραγματικά screenshots και πραγματικές αποκρίσεις του συστήματος, όχι μόνο θεωρία.</a:t>
             </a:r>
             <a:endParaRPr lang="en-US" dirty="0"/>
           </a:p>
@@ -2209,7 +2218,7 @@
           <a:p>
             <a:r>
               <a:rPr lang="en-US" dirty="0"/>
-              <a:t/>
+              <a:t>Δείχνει την πραγματική απάντηση που δίνει το σύστημα όταν κάποιος, πρόγραμμα ή άνθρωπος, ζητήσει μια ανάλυση, σε μορφή JSON: έναν απλό τρόπο να γράφεις δεδομένα ώστε να τα διαβάζουν εύκολα υπολογιστές. Δεν είναι εφεύρεση για την παρουσίαση. Είναι ακριβώς ό,τι επιστρέφει το πρόγραμμα όταν του ζητήσεις πρόβλεψη πωλήσεων ή Growth Accounting.</a:t>
             </a:r>
             <a:endParaRPr lang="en-US" dirty="0"/>
           </a:p>
@@ -2297,7 +2306,7 @@
           <a:p>
             <a:r>
               <a:rPr lang="en-US" dirty="0"/>
-              <a:t/>
+              <a:t>Δύο ακόμα πραγματικές αποκρίσεις: το clustering (με το silhouette score μέσα στην ίδια απάντηση, ώστε να ελέγχεται) και η κερδοφορία, όπου η δήλωση «σενάριο, όχι μέτρηση» υπάρχει κυριολεκτικά μέσα στο JSON, ώστε να μην μπορεί να αφαιρεθεί κατά λάθος.</a:t>
             </a:r>
             <a:endParaRPr lang="en-US" dirty="0"/>
           </a:p>
@@ -2385,7 +2394,7 @@
           <a:p>
             <a:r>
               <a:rPr lang="en-US" dirty="0"/>
-              <a:t/>
+              <a:t>Screenshot του πραγματικού dashboard, εκεί όπου ο ιδιοκτήτης του μαγαζιού, που δεν ξέρει προγραμματισμό, μπορεί να δει τα ίδια νούμερα σε πίνακες, χωρίς να χρειάζεται να καλέσει το API.</a:t>
             </a:r>
             <a:endParaRPr lang="en-US" dirty="0"/>
           </a:p>
@@ -2473,7 +2482,7 @@
           <a:p>
             <a:r>
               <a:rPr lang="en-US" dirty="0"/>
-              <a:t/>
+              <a:t>Απλή διαφάνεια-τίτλος. Λέει «τώρα μπαίνουμε στην πρώτη ενότητα». Καμία πληροφορία, μόνο αλλαγή θέματος.</a:t>
             </a:r>
             <a:endParaRPr lang="en-US" dirty="0"/>
           </a:p>
@@ -2561,7 +2570,7 @@
           <a:p>
             <a:r>
               <a:rPr lang="en-US" dirty="0"/>
-              <a:t/>
+              <a:t>Δύο ακόμα screenshots: πώς φαίνονται οι κανόνες συσχέτισης μέσα στο Metabase, και πώς φαίνεται η σελίδα όπου μπορεί κανείς να δοκιμάσει ζωντανά το API, το λεγόμενο Swagger UI.</a:t>
             </a:r>
             <a:endParaRPr lang="en-US" dirty="0"/>
           </a:p>
@@ -2649,7 +2658,7 @@
           <a:p>
             <a:r>
               <a:rPr lang="en-US" dirty="0"/>
-              <a:t/>
+              <a:t>Αλλαγή ενότητας: τώρα κλείνεις με το τι βρέθηκε, τι αξίζει, τι δεν μπορεί να κάνει η δουλειά, και τι θα μπορούσε να γίνει μετά.</a:t>
             </a:r>
             <a:endParaRPr lang="en-US" dirty="0"/>
           </a:p>
@@ -2737,7 +2746,7 @@
           <a:p>
             <a:r>
               <a:rPr lang="en-US" dirty="0"/>
-              <a:t/>
+              <a:t>Η περίληψη όλης της δουλειάς σε έξι προτάσεις. Αν κάποιος θυμάται μόνο μία διαφάνεια από όλη την παρουσίαση, καλό είναι να είναι αυτή.</a:t>
             </a:r>
             <a:endParaRPr lang="en-US" dirty="0"/>
           </a:p>
@@ -2825,7 +2834,7 @@
           <a:p>
             <a:r>
               <a:rPr lang="en-US" dirty="0"/>
-              <a:t/>
+              <a:t>«Και λοιπόν, τι κάνει ο ιδιοκτήτης του μαγαζιού με όλα αυτά;» Δύο στήλες: τι βοηθάει στις αποφάσεις marketing, τι βοηθάει στις αποφάσεις πωλήσεων και αποθέματος.</a:t>
             </a:r>
             <a:endParaRPr lang="en-US" dirty="0"/>
           </a:p>
@@ -2913,7 +2922,7 @@
           <a:p>
             <a:r>
               <a:rPr lang="en-US" dirty="0"/>
-              <a:t/>
+              <a:t>Τα πέντε πράγματα που η δουλειά δεν μπορεί να κάνει, δηλωμένα ανοιχτά αντί να κρύβονται. Το πιο σημαντικό: δεν ξέρουμε το κόστος του μαγαζιού, οπότε δεν μπορούμε να πούμε με σιγουριά αν είναι πραγματικά κερδοφόρο.</a:t>
             </a:r>
             <a:endParaRPr lang="en-US" dirty="0"/>
           </a:p>
@@ -3001,7 +3010,7 @@
           <a:p>
             <a:r>
               <a:rPr lang="en-US" dirty="0"/>
-              <a:t/>
+              <a:t>Πέντε ιδέες για το τι θα μπορούσε να γίνει μετά, αν κάποιος συνέχιζε αυτή τη δουλειά: δεύτερο πραγματικό κατάστημα για σύγκριση, προβλεπτική αξία πελάτη, γεωγραφική ιεραρχία, εξέλιξη κανόνων συσχέτισης με τον καιρό, και ενσωμάτωση πραγματικού κόστους.</a:t>
             </a:r>
             <a:endParaRPr lang="en-US" dirty="0"/>
           </a:p>
@@ -3089,7 +3098,7 @@
           <a:p>
             <a:r>
               <a:rPr lang="en-US" dirty="0"/>
-              <a:t/>
+              <a:t>Η τελευταία διαφάνεια, το μήνυμα όλης της δουλειάς σε μία πρόταση: να απαντηθεί ό,τι ζήτησε η επιχείρηση, και να μην προσποιηθούμε ότι απαντάμε σε πράγματα που τα δεδομένα δεν επιτρέπουν.</a:t>
             </a:r>
             <a:endParaRPr lang="en-US" dirty="0"/>
           </a:p>
@@ -3177,7 +3186,8 @@
           <a:p>
             <a:r>
               <a:rPr lang="en-US" dirty="0"/>
-              <a:t/>
+              <a:t>Φαντάσου ένα μαγαζί που έχει καταγράψει κάθε πώληση εδώ και χρόνια, αλλά ο ιδιοκτήτης παίρνει αποφάσεις με το μάτι, χωρίς ποτέ να κοιτάξει αυτά τα δεδομένα. Αυτό είναι το πρόβλημα: τα δεδομένα υπάρχουν, αλλά κανείς δεν τα χρησιμοποιεί. Η δουλειά φτιάχνει το εργαλείο που τα διαβάζει και βγάζει χρήσιμα συμπεράσματα.
+ΠΙΘΑΝΗ ΕΡΩΤΗΣΗ: «Γιατί δεν το κάνει ήδη η επιχείρηση μόνη της;» Επειδή χρειάζεται εξειδικευμένη γνώση data mining και machine learning. Δεν είναι κάτι που κάνεις με ένα απλό Excel.</a:t>
             </a:r>
             <a:endParaRPr lang="en-US" dirty="0"/>
           </a:p>
@@ -3265,7 +3275,7 @@
           <a:p>
             <a:r>
               <a:rPr lang="en-US" dirty="0"/>
-              <a:t/>
+              <a:t>Οι 7 απλές ερωτήσεις που θα έκανε κάθε μαγαζάτορας: «ποιο προϊόν πουλάει καλύτερα;», «ποιος πελάτης αγοράζει πιο πολύ;» και ούτω καθεξής. Η δουλειά ξεκίνησε απαντώντας ακριβώς σε αυτά, και μετά πρόσθεσε πιο σύνθετα κομμάτια: οικονομικά μεγέθη και τρεις τεχνικές μηχανικής μάθησης.</a:t>
             </a:r>
             <a:endParaRPr lang="en-US" dirty="0"/>
           </a:p>
@@ -3353,7 +3363,8 @@
           <a:p>
             <a:r>
               <a:rPr lang="en-US" dirty="0"/>
-              <a:t/>
+              <a:t>Δύο κανόνες που ακολουθεί όλη η δουλειά.
+ΜΑΘΗΜΑΤΙΚΑ: Γενικότητα: το σύστημα δεν είναι φτιαγμένο μόνο για αυτό το μαγαζί, δουλεύει με οποιοδήποτε μαγαζί, σαν πρίζα που ταιριάζει παντού. Ειλικρίνεια: αν κάτι δεν μπορεί να μετρηθεί με σιγουριά, π.χ. το κέρδος γιατί δεν ξέρουμε το κόστος, το σύστημα δεν προσποιείται ότι το ξέρει. Λέει ξεκάθαρα «αυτό είναι υπόθεση, όχι μέτρηση».</a:t>
             </a:r>
             <a:endParaRPr lang="en-US" dirty="0"/>
           </a:p>
@@ -3441,7 +3452,7 @@
           <a:p>
             <a:r>
               <a:rPr lang="en-US" dirty="0"/>
-              <a:t/>
+              <a:t>Αλλαγή ενότητας: τώρα εξηγείς τη θεωρία πίσω από τις τεχνικές, πριν δείξεις τα αποτελέσματα.</a:t>
             </a:r>
             <a:endParaRPr lang="en-US" dirty="0"/>
           </a:p>
@@ -3529,7 +3540,9 @@
           <a:p>
             <a:r>
               <a:rPr lang="en-US" dirty="0"/>
-              <a:t/>
+              <a:t>Φαντάσου χιλιάδες αποδείξεις από ένα μαγαζί. Θέλεις να βρεις ποια προϊόντα αγοράζονται μαζί συχνά, π.χ. «όποιος παίρνει ψωμί, συχνά παίρνει και βούτυρο».
+ΜΑΘΗΜΑΤΙΚΑ: 10 αποδείξεις, οι 3 έχουν ψωμί+βούτυρο. Support = 3/10 = 0,3. Το ψωμί σε 5 συνολικά, άρα Confidence(ψωμί→βούτυρο) = 3/5 = 0,6. Αν το βούτυρο είναι ούτως ή άλλως δημοφιλές (support 0,8): Lift = 0,6/0,8 = 0,75, κάτω από 1, καμία πραγματική σχέση. Αν είναι σπάνιο (support 0,2): Lift = 0,6/0,2 = 3, τριπλάσια πιθανότητα από την τύχη. Το lift δείχνει αληθινή σχέση, όχι δημοφιλία του ενός.
+ΠΙΘΑΝΗ ΕΡΩΤΗΣΗ: «Γιατί δύο αλγόριθμοι για το ίδιο πράγμα;» Το ζήτησε η επίβλεψη, και επέτρεψε να αποδειχθεί πειραματικά ότι δίνουν ταυτόσημο αποτέλεσμα, διαφέρουν μόνο στην ταχύτητα.</a:t>
             </a:r>
             <a:endParaRPr lang="en-US" dirty="0"/>
           </a:p>
@@ -3617,7 +3630,9 @@
           <a:p>
             <a:r>
               <a:rPr lang="en-US" dirty="0"/>
-              <a:t/>
+              <a:t>Έχεις έναν σωρό στοιχεία, π.χ. χώρες ή πελάτες, και θες να τα χωρίσεις σε ομάδες (clusters) όπου τα μέλη μοιάζουν μεταξύ τους. Ο k-means διαλέγει k κέντρα, βάζει κάθε στοιχείο στο πλησιέστερο, μετακινεί τα κέντρα στο μέσο της ομάδας, και επαναλαμβάνει μέχρι να σταθεροποιηθεί.
+ΜΑΘΗΜΑΤΙΚΑ: Το J = Σ (απόσταση κάθε σημείου από το κέντρο του)² μετράει πόσο μαζεμένη είναι κάθε ομάδα, το θέλουμε όσο πιο μικρό γίνεται. Silhouette: συγκρίνει πόσο κοντά είναι κάθε σημείο στη δική του ομάδα σε σχέση με την πιο κοντινή άλλη. Κοντά στο +1 καλό, στο 0 μπερδεμένο, στο −1 λάθος ομάδα. Δοκιμάζουμε πολλά k και κρατάμε το καλύτερο μέσο score.
+ΠΙΘΑΝΗ ΕΡΩΤΗΣΗ: «Γιατί δύο επίπεδα clustering;» Το ζήτησε η επίβλεψη: πρώτα ανά περιοχή και χρόνο, μετά μέσα σε κάθε ομάδα ξανά με RFM. Πληροφορία σε δύο επίπεδα αντί για ένα.</a:t>
             </a:r>
             <a:endParaRPr lang="en-US" dirty="0"/>
           </a:p>
@@ -3992,7 +4007,7 @@
       </p:grpSpPr>
       <p:sp>
         <p:nvSpPr>
-          <p:cNvPr id="2" name="Shape 0"/>
+          <p:cNvPr id="3" name="Shape 0"/>
           <p:cNvSpPr/>
           <p:nvPr/>
         </p:nvSpPr>
@@ -4012,7 +4027,7 @@
       </p:sp>
       <p:sp>
         <p:nvSpPr>
-          <p:cNvPr id="3" name="Shape 1"/>
+          <p:cNvPr id="4" name="Shape 1"/>
           <p:cNvSpPr/>
           <p:nvPr/>
         </p:nvSpPr>
@@ -4032,7 +4047,7 @@
       </p:sp>
       <p:sp>
         <p:nvSpPr>
-          <p:cNvPr id="4" name="Text 2"/>
+          <p:cNvPr id="5" name="Text 2"/>
           <p:cNvSpPr txBox="1"/>
           <p:nvPr/>
         </p:nvSpPr>
@@ -4071,7 +4086,7 @@
       </p:sp>
       <p:sp>
         <p:nvSpPr>
-          <p:cNvPr id="5" name="Text 3"/>
+          <p:cNvPr id="6" name="Text 3"/>
           <p:cNvSpPr txBox="1"/>
           <p:nvPr/>
         </p:nvSpPr>
@@ -4113,7 +4128,7 @@
       </p:sp>
       <p:sp>
         <p:nvSpPr>
-          <p:cNvPr id="6" name="Text 4"/>
+          <p:cNvPr id="7" name="Text 4"/>
           <p:cNvSpPr txBox="1"/>
           <p:nvPr/>
         </p:nvSpPr>
@@ -4152,7 +4167,7 @@
       </p:sp>
       <p:sp>
         <p:nvSpPr>
-          <p:cNvPr id="7" name="Shape 5"/>
+          <p:cNvPr id="8" name="Shape 5"/>
           <p:cNvSpPr/>
           <p:nvPr/>
         </p:nvSpPr>
@@ -4175,7 +4190,7 @@
       </p:sp>
       <p:sp>
         <p:nvSpPr>
-          <p:cNvPr id="8" name="Text 6"/>
+          <p:cNvPr id="9" name="Text 6"/>
           <p:cNvSpPr txBox="1"/>
           <p:nvPr/>
         </p:nvSpPr>
@@ -4245,7 +4260,7 @@
       </p:sp>
       <p:sp>
         <p:nvSpPr>
-          <p:cNvPr id="9" name="Text 7"/>
+          <p:cNvPr id="10" name="Text 7"/>
           <p:cNvSpPr txBox="1"/>
           <p:nvPr/>
         </p:nvSpPr>
@@ -4284,7 +4299,7 @@
       </p:sp>
       <p:sp>
         <p:nvSpPr>
-          <p:cNvPr id="10" name="Text 8"/>
+          <p:cNvPr id="11" name="Text 8"/>
           <p:cNvSpPr txBox="1"/>
           <p:nvPr/>
         </p:nvSpPr>
@@ -4331,7 +4346,7 @@
       </p:sp>
       <p:sp>
         <p:nvSpPr>
-          <p:cNvPr id="11" name="Text 9"/>
+          <p:cNvPr id="12" name="Text 9"/>
           <p:cNvSpPr txBox="1"/>
           <p:nvPr/>
         </p:nvSpPr>
@@ -4378,7 +4393,7 @@
       </p:sp>
       <p:sp>
         <p:nvSpPr>
-          <p:cNvPr id="12" name="Text 10"/>
+          <p:cNvPr id="13" name="Text 10"/>
           <p:cNvSpPr txBox="1"/>
           <p:nvPr/>
         </p:nvSpPr>
@@ -4425,7 +4440,7 @@
       </p:sp>
       <p:sp>
         <p:nvSpPr>
-          <p:cNvPr id="13" name="Text 11"/>
+          <p:cNvPr id="14" name="Text 11"/>
           <p:cNvSpPr txBox="1"/>
           <p:nvPr/>
         </p:nvSpPr>
@@ -4496,7 +4511,7 @@
       </p:grpSpPr>
       <p:sp>
         <p:nvSpPr>
-          <p:cNvPr id="2" name="Text 0"/>
+          <p:cNvPr id="3" name="Text 0"/>
           <p:cNvSpPr txBox="1"/>
           <p:nvPr/>
         </p:nvSpPr>
@@ -4535,7 +4550,7 @@
       </p:sp>
       <p:sp>
         <p:nvSpPr>
-          <p:cNvPr id="3" name="Text 1"/>
+          <p:cNvPr id="4" name="Text 1"/>
           <p:cNvSpPr txBox="1"/>
           <p:nvPr/>
         </p:nvSpPr>
@@ -4574,7 +4589,7 @@
       </p:sp>
       <p:sp>
         <p:nvSpPr>
-          <p:cNvPr id="4" name="Text 2"/>
+          <p:cNvPr id="5" name="Text 2"/>
           <p:cNvSpPr txBox="1"/>
           <p:nvPr/>
         </p:nvSpPr>
@@ -4668,7 +4683,7 @@
       </p:sp>
       <p:sp>
         <p:nvSpPr>
-          <p:cNvPr id="5" name="Shape 3"/>
+          <p:cNvPr id="6" name="Shape 3"/>
           <p:cNvSpPr/>
           <p:nvPr/>
         </p:nvSpPr>
@@ -4690,7 +4705,7 @@
       </p:sp>
       <p:sp>
         <p:nvSpPr>
-          <p:cNvPr id="6" name="Text 4"/>
+          <p:cNvPr id="7" name="Text 4"/>
           <p:cNvSpPr txBox="1"/>
           <p:nvPr/>
         </p:nvSpPr>
@@ -4729,7 +4744,7 @@
       </p:sp>
       <p:sp>
         <p:nvSpPr>
-          <p:cNvPr id="7" name="Text 5"/>
+          <p:cNvPr id="8" name="Text 5"/>
           <p:cNvSpPr txBox="1"/>
           <p:nvPr/>
         </p:nvSpPr>
@@ -4799,7 +4814,7 @@
       </p:sp>
       <p:sp>
         <p:nvSpPr>
-          <p:cNvPr id="8" name="Shape 6"/>
+          <p:cNvPr id="9" name="Shape 6"/>
           <p:cNvSpPr/>
           <p:nvPr/>
         </p:nvSpPr>
@@ -4821,7 +4836,7 @@
       </p:sp>
       <p:sp>
         <p:nvSpPr>
-          <p:cNvPr id="9" name="Text 7"/>
+          <p:cNvPr id="10" name="Text 7"/>
           <p:cNvSpPr txBox="1"/>
           <p:nvPr/>
         </p:nvSpPr>
@@ -4860,7 +4875,7 @@
       </p:sp>
       <p:sp>
         <p:nvSpPr>
-          <p:cNvPr id="10" name="Text 8"/>
+          <p:cNvPr id="11" name="Text 8"/>
           <p:cNvSpPr txBox="1"/>
           <p:nvPr/>
         </p:nvSpPr>
@@ -4930,7 +4945,7 @@
       </p:sp>
       <p:sp>
         <p:nvSpPr>
-          <p:cNvPr id="11" name="Text 9"/>
+          <p:cNvPr id="12" name="Text 9"/>
           <p:cNvSpPr txBox="1"/>
           <p:nvPr/>
         </p:nvSpPr>
@@ -4969,7 +4984,7 @@
       </p:sp>
       <p:sp>
         <p:nvSpPr>
-          <p:cNvPr id="12" name="Text 10"/>
+          <p:cNvPr id="13" name="Text 10"/>
           <p:cNvSpPr txBox="1"/>
           <p:nvPr/>
         </p:nvSpPr>
@@ -5040,7 +5055,7 @@
       </p:grpSpPr>
       <p:sp>
         <p:nvSpPr>
-          <p:cNvPr id="2" name="Shape 0"/>
+          <p:cNvPr id="3" name="Shape 0"/>
           <p:cNvSpPr/>
           <p:nvPr/>
         </p:nvSpPr>
@@ -5060,7 +5075,7 @@
       </p:sp>
       <p:sp>
         <p:nvSpPr>
-          <p:cNvPr id="3" name="Shape 1"/>
+          <p:cNvPr id="4" name="Shape 1"/>
           <p:cNvSpPr/>
           <p:nvPr/>
         </p:nvSpPr>
@@ -5085,7 +5100,7 @@
       </p:sp>
       <p:sp>
         <p:nvSpPr>
-          <p:cNvPr id="4" name="Text 2"/>
+          <p:cNvPr id="5" name="Text 2"/>
           <p:cNvSpPr txBox="1"/>
           <p:nvPr/>
         </p:nvSpPr>
@@ -5124,7 +5139,7 @@
       </p:sp>
       <p:sp>
         <p:nvSpPr>
-          <p:cNvPr id="5" name="Text 3"/>
+          <p:cNvPr id="6" name="Text 3"/>
           <p:cNvSpPr txBox="1"/>
           <p:nvPr/>
         </p:nvSpPr>
@@ -5163,7 +5178,7 @@
       </p:sp>
       <p:sp>
         <p:nvSpPr>
-          <p:cNvPr id="6" name="Text 4"/>
+          <p:cNvPr id="7" name="Text 4"/>
           <p:cNvSpPr txBox="1"/>
           <p:nvPr/>
         </p:nvSpPr>
@@ -5202,7 +5217,7 @@
       </p:sp>
       <p:sp>
         <p:nvSpPr>
-          <p:cNvPr id="7" name="Text 5"/>
+          <p:cNvPr id="8" name="Text 5"/>
           <p:cNvSpPr txBox="1"/>
           <p:nvPr/>
         </p:nvSpPr>
@@ -5241,7 +5256,7 @@
       </p:sp>
       <p:sp>
         <p:nvSpPr>
-          <p:cNvPr id="8" name="Text 6"/>
+          <p:cNvPr id="9" name="Text 6"/>
           <p:cNvSpPr txBox="1"/>
           <p:nvPr/>
         </p:nvSpPr>
@@ -5280,7 +5295,7 @@
       </p:sp>
       <p:sp>
         <p:nvSpPr>
-          <p:cNvPr id="9" name="Text 7"/>
+          <p:cNvPr id="10" name="Text 7"/>
           <p:cNvSpPr txBox="1"/>
           <p:nvPr/>
         </p:nvSpPr>
@@ -5351,7 +5366,7 @@
       </p:grpSpPr>
       <p:sp>
         <p:nvSpPr>
-          <p:cNvPr id="2" name="Text 0"/>
+          <p:cNvPr id="3" name="Text 0"/>
           <p:cNvSpPr txBox="1"/>
           <p:nvPr/>
         </p:nvSpPr>
@@ -5390,7 +5405,7 @@
       </p:sp>
       <p:sp>
         <p:nvSpPr>
-          <p:cNvPr id="3" name="Text 1"/>
+          <p:cNvPr id="4" name="Text 1"/>
           <p:cNvSpPr txBox="1"/>
           <p:nvPr/>
         </p:nvSpPr>
@@ -5429,7 +5444,7 @@
       </p:sp>
       <p:sp>
         <p:nvSpPr>
-          <p:cNvPr id="4" name="Text 2"/>
+          <p:cNvPr id="5" name="Text 2"/>
           <p:cNvSpPr txBox="1"/>
           <p:nvPr/>
         </p:nvSpPr>
@@ -5499,7 +5514,7 @@
       </p:sp>
       <p:sp>
         <p:nvSpPr>
-          <p:cNvPr id="5" name="Shape 3"/>
+          <p:cNvPr id="6" name="Shape 3"/>
           <p:cNvSpPr/>
           <p:nvPr/>
         </p:nvSpPr>
@@ -5528,7 +5543,7 @@
       </p:sp>
       <p:sp>
         <p:nvSpPr>
-          <p:cNvPr id="6" name="Text 4"/>
+          <p:cNvPr id="7" name="Text 4"/>
           <p:cNvSpPr txBox="1"/>
           <p:nvPr/>
         </p:nvSpPr>
@@ -5567,7 +5582,7 @@
       </p:sp>
       <p:sp>
         <p:nvSpPr>
-          <p:cNvPr id="7" name="Text 5"/>
+          <p:cNvPr id="8" name="Text 5"/>
           <p:cNvSpPr txBox="1"/>
           <p:nvPr/>
         </p:nvSpPr>
@@ -5606,7 +5621,7 @@
       </p:sp>
       <p:sp>
         <p:nvSpPr>
-          <p:cNvPr id="8" name="Shape 6"/>
+          <p:cNvPr id="9" name="Shape 6"/>
           <p:cNvSpPr/>
           <p:nvPr/>
         </p:nvSpPr>
@@ -5635,7 +5650,7 @@
       </p:sp>
       <p:sp>
         <p:nvSpPr>
-          <p:cNvPr id="9" name="Text 7"/>
+          <p:cNvPr id="10" name="Text 7"/>
           <p:cNvSpPr txBox="1"/>
           <p:nvPr/>
         </p:nvSpPr>
@@ -5674,7 +5689,7 @@
       </p:sp>
       <p:sp>
         <p:nvSpPr>
-          <p:cNvPr id="10" name="Text 8"/>
+          <p:cNvPr id="11" name="Text 8"/>
           <p:cNvSpPr txBox="1"/>
           <p:nvPr/>
         </p:nvSpPr>
@@ -5713,7 +5728,7 @@
       </p:sp>
       <p:sp>
         <p:nvSpPr>
-          <p:cNvPr id="11" name="Shape 9"/>
+          <p:cNvPr id="12" name="Shape 9"/>
           <p:cNvSpPr/>
           <p:nvPr/>
         </p:nvSpPr>
@@ -5742,7 +5757,7 @@
       </p:sp>
       <p:sp>
         <p:nvSpPr>
-          <p:cNvPr id="12" name="Text 10"/>
+          <p:cNvPr id="13" name="Text 10"/>
           <p:cNvSpPr txBox="1"/>
           <p:nvPr/>
         </p:nvSpPr>
@@ -5781,7 +5796,7 @@
       </p:sp>
       <p:sp>
         <p:nvSpPr>
-          <p:cNvPr id="13" name="Text 11"/>
+          <p:cNvPr id="14" name="Text 11"/>
           <p:cNvSpPr txBox="1"/>
           <p:nvPr/>
         </p:nvSpPr>
@@ -5820,7 +5835,7 @@
       </p:sp>
       <p:sp>
         <p:nvSpPr>
-          <p:cNvPr id="14" name="Shape 12"/>
+          <p:cNvPr id="15" name="Shape 12"/>
           <p:cNvSpPr/>
           <p:nvPr/>
         </p:nvSpPr>
@@ -5849,7 +5864,7 @@
       </p:sp>
       <p:sp>
         <p:nvSpPr>
-          <p:cNvPr id="15" name="Text 13"/>
+          <p:cNvPr id="16" name="Text 13"/>
           <p:cNvSpPr txBox="1"/>
           <p:nvPr/>
         </p:nvSpPr>
@@ -5888,7 +5903,7 @@
       </p:sp>
       <p:sp>
         <p:nvSpPr>
-          <p:cNvPr id="16" name="Text 14"/>
+          <p:cNvPr id="17" name="Text 14"/>
           <p:cNvSpPr txBox="1"/>
           <p:nvPr/>
         </p:nvSpPr>
@@ -5927,7 +5942,7 @@
       </p:sp>
       <p:sp>
         <p:nvSpPr>
-          <p:cNvPr id="17" name="Shape 15"/>
+          <p:cNvPr id="18" name="Shape 15"/>
           <p:cNvSpPr/>
           <p:nvPr/>
         </p:nvSpPr>
@@ -5956,7 +5971,7 @@
       </p:sp>
       <p:sp>
         <p:nvSpPr>
-          <p:cNvPr id="18" name="Text 16"/>
+          <p:cNvPr id="19" name="Text 16"/>
           <p:cNvSpPr txBox="1"/>
           <p:nvPr/>
         </p:nvSpPr>
@@ -5995,7 +6010,7 @@
       </p:sp>
       <p:sp>
         <p:nvSpPr>
-          <p:cNvPr id="19" name="Text 17"/>
+          <p:cNvPr id="20" name="Text 17"/>
           <p:cNvSpPr txBox="1"/>
           <p:nvPr/>
         </p:nvSpPr>
@@ -6034,7 +6049,7 @@
       </p:sp>
       <p:sp>
         <p:nvSpPr>
-          <p:cNvPr id="20" name="Shape 18"/>
+          <p:cNvPr id="21" name="Shape 18"/>
           <p:cNvSpPr/>
           <p:nvPr/>
         </p:nvSpPr>
@@ -6063,7 +6078,7 @@
       </p:sp>
       <p:sp>
         <p:nvSpPr>
-          <p:cNvPr id="21" name="Text 19"/>
+          <p:cNvPr id="22" name="Text 19"/>
           <p:cNvSpPr txBox="1"/>
           <p:nvPr/>
         </p:nvSpPr>
@@ -6102,7 +6117,7 @@
       </p:sp>
       <p:sp>
         <p:nvSpPr>
-          <p:cNvPr id="22" name="Text 20"/>
+          <p:cNvPr id="23" name="Text 20"/>
           <p:cNvSpPr txBox="1"/>
           <p:nvPr/>
         </p:nvSpPr>
@@ -6141,7 +6156,7 @@
       </p:sp>
       <p:sp>
         <p:nvSpPr>
-          <p:cNvPr id="23" name="Text 21"/>
+          <p:cNvPr id="24" name="Text 21"/>
           <p:cNvSpPr txBox="1"/>
           <p:nvPr/>
         </p:nvSpPr>
@@ -6211,7 +6226,7 @@
       </p:sp>
       <p:sp>
         <p:nvSpPr>
-          <p:cNvPr id="24" name="Text 22"/>
+          <p:cNvPr id="25" name="Text 22"/>
           <p:cNvSpPr txBox="1"/>
           <p:nvPr/>
         </p:nvSpPr>
@@ -6250,7 +6265,7 @@
       </p:sp>
       <p:sp>
         <p:nvSpPr>
-          <p:cNvPr id="25" name="Text 23"/>
+          <p:cNvPr id="26" name="Text 23"/>
           <p:cNvSpPr txBox="1"/>
           <p:nvPr/>
         </p:nvSpPr>
@@ -6321,7 +6336,7 @@
       </p:grpSpPr>
       <p:sp>
         <p:nvSpPr>
-          <p:cNvPr id="2" name="Text 0"/>
+          <p:cNvPr id="3" name="Text 0"/>
           <p:cNvSpPr txBox="1"/>
           <p:nvPr/>
         </p:nvSpPr>
@@ -6360,7 +6375,7 @@
       </p:sp>
       <p:sp>
         <p:nvSpPr>
-          <p:cNvPr id="3" name="Text 1"/>
+          <p:cNvPr id="4" name="Text 1"/>
           <p:cNvSpPr txBox="1"/>
           <p:nvPr/>
         </p:nvSpPr>
@@ -6399,7 +6414,7 @@
       </p:sp>
       <p:sp>
         <p:nvSpPr>
-          <p:cNvPr id="4" name="Text 2"/>
+          <p:cNvPr id="5" name="Text 2"/>
           <p:cNvSpPr txBox="1"/>
           <p:nvPr/>
         </p:nvSpPr>
@@ -6493,7 +6508,7 @@
       </p:sp>
       <p:sp>
         <p:nvSpPr>
-          <p:cNvPr id="5" name="Shape 3"/>
+          <p:cNvPr id="6" name="Shape 3"/>
           <p:cNvSpPr/>
           <p:nvPr/>
         </p:nvSpPr>
@@ -6515,7 +6530,7 @@
       </p:sp>
       <p:sp>
         <p:nvSpPr>
-          <p:cNvPr id="6" name="Text 4"/>
+          <p:cNvPr id="7" name="Text 4"/>
           <p:cNvSpPr txBox="1"/>
           <p:nvPr/>
         </p:nvSpPr>
@@ -6554,7 +6569,7 @@
       </p:sp>
       <p:sp>
         <p:nvSpPr>
-          <p:cNvPr id="7" name="Shape 5"/>
+          <p:cNvPr id="8" name="Shape 5"/>
           <p:cNvSpPr/>
           <p:nvPr/>
         </p:nvSpPr>
@@ -6577,7 +6592,7 @@
       </p:sp>
       <p:sp>
         <p:nvSpPr>
-          <p:cNvPr id="8" name="Shape 6"/>
+          <p:cNvPr id="9" name="Shape 6"/>
           <p:cNvSpPr/>
           <p:nvPr/>
         </p:nvSpPr>
@@ -6599,7 +6614,7 @@
       </p:sp>
       <p:sp>
         <p:nvSpPr>
-          <p:cNvPr id="9" name="Text 7"/>
+          <p:cNvPr id="10" name="Text 7"/>
           <p:cNvSpPr txBox="1"/>
           <p:nvPr/>
         </p:nvSpPr>
@@ -6638,7 +6653,7 @@
       </p:sp>
       <p:sp>
         <p:nvSpPr>
-          <p:cNvPr id="10" name="Text 8"/>
+          <p:cNvPr id="11" name="Text 8"/>
           <p:cNvSpPr txBox="1"/>
           <p:nvPr/>
         </p:nvSpPr>
@@ -6677,7 +6692,7 @@
       </p:sp>
       <p:sp>
         <p:nvSpPr>
-          <p:cNvPr id="11" name="Shape 9"/>
+          <p:cNvPr id="12" name="Shape 9"/>
           <p:cNvSpPr/>
           <p:nvPr/>
         </p:nvSpPr>
@@ -6700,7 +6715,7 @@
       </p:sp>
       <p:sp>
         <p:nvSpPr>
-          <p:cNvPr id="12" name="Shape 10"/>
+          <p:cNvPr id="13" name="Shape 10"/>
           <p:cNvSpPr/>
           <p:nvPr/>
         </p:nvSpPr>
@@ -6722,7 +6737,7 @@
       </p:sp>
       <p:sp>
         <p:nvSpPr>
-          <p:cNvPr id="13" name="Text 11"/>
+          <p:cNvPr id="14" name="Text 11"/>
           <p:cNvSpPr txBox="1"/>
           <p:nvPr/>
         </p:nvSpPr>
@@ -6761,7 +6776,7 @@
       </p:sp>
       <p:sp>
         <p:nvSpPr>
-          <p:cNvPr id="14" name="Text 12"/>
+          <p:cNvPr id="15" name="Text 12"/>
           <p:cNvSpPr txBox="1"/>
           <p:nvPr/>
         </p:nvSpPr>
@@ -6800,7 +6815,7 @@
       </p:sp>
       <p:sp>
         <p:nvSpPr>
-          <p:cNvPr id="15" name="Shape 13"/>
+          <p:cNvPr id="16" name="Shape 13"/>
           <p:cNvSpPr/>
           <p:nvPr/>
         </p:nvSpPr>
@@ -6823,7 +6838,7 @@
       </p:sp>
       <p:sp>
         <p:nvSpPr>
-          <p:cNvPr id="16" name="Shape 14"/>
+          <p:cNvPr id="17" name="Shape 14"/>
           <p:cNvSpPr/>
           <p:nvPr/>
         </p:nvSpPr>
@@ -6845,7 +6860,7 @@
       </p:sp>
       <p:sp>
         <p:nvSpPr>
-          <p:cNvPr id="17" name="Text 15"/>
+          <p:cNvPr id="18" name="Text 15"/>
           <p:cNvSpPr txBox="1"/>
           <p:nvPr/>
         </p:nvSpPr>
@@ -6884,7 +6899,7 @@
       </p:sp>
       <p:sp>
         <p:nvSpPr>
-          <p:cNvPr id="18" name="Text 16"/>
+          <p:cNvPr id="19" name="Text 16"/>
           <p:cNvSpPr txBox="1"/>
           <p:nvPr/>
         </p:nvSpPr>
@@ -6923,7 +6938,7 @@
       </p:sp>
       <p:sp>
         <p:nvSpPr>
-          <p:cNvPr id="19" name="Text 17"/>
+          <p:cNvPr id="20" name="Text 17"/>
           <p:cNvSpPr txBox="1"/>
           <p:nvPr/>
         </p:nvSpPr>
@@ -6962,7 +6977,7 @@
       </p:sp>
       <p:sp>
         <p:nvSpPr>
-          <p:cNvPr id="20" name="Text 18"/>
+          <p:cNvPr id="21" name="Text 18"/>
           <p:cNvSpPr txBox="1"/>
           <p:nvPr/>
         </p:nvSpPr>
@@ -7001,7 +7016,7 @@
       </p:sp>
       <p:sp>
         <p:nvSpPr>
-          <p:cNvPr id="21" name="Text 19"/>
+          <p:cNvPr id="22" name="Text 19"/>
           <p:cNvSpPr txBox="1"/>
           <p:nvPr/>
         </p:nvSpPr>
@@ -7072,7 +7087,7 @@
       </p:grpSpPr>
       <p:sp>
         <p:nvSpPr>
-          <p:cNvPr id="2" name="Text 0"/>
+          <p:cNvPr id="3" name="Text 0"/>
           <p:cNvSpPr txBox="1"/>
           <p:nvPr/>
         </p:nvSpPr>
@@ -7111,7 +7126,7 @@
       </p:sp>
       <p:sp>
         <p:nvSpPr>
-          <p:cNvPr id="3" name="Text 1"/>
+          <p:cNvPr id="4" name="Text 1"/>
           <p:cNvSpPr txBox="1"/>
           <p:nvPr/>
         </p:nvSpPr>
@@ -7150,7 +7165,7 @@
       </p:sp>
       <p:sp>
         <p:nvSpPr>
-          <p:cNvPr id="4" name="Text 2"/>
+          <p:cNvPr id="5" name="Text 2"/>
           <p:cNvSpPr txBox="1"/>
           <p:nvPr/>
         </p:nvSpPr>
@@ -7189,7 +7204,7 @@
       </p:sp>
       <p:sp>
         <p:nvSpPr>
-          <p:cNvPr id="5" name="Shape 3"/>
+          <p:cNvPr id="6" name="Shape 3"/>
           <p:cNvSpPr/>
           <p:nvPr/>
         </p:nvSpPr>
@@ -7211,7 +7226,7 @@
       </p:sp>
       <p:sp>
         <p:nvSpPr>
-          <p:cNvPr id="6" name="Text 4"/>
+          <p:cNvPr id="7" name="Text 4"/>
           <p:cNvSpPr txBox="1"/>
           <p:nvPr/>
         </p:nvSpPr>
@@ -7250,7 +7265,7 @@
       </p:sp>
       <p:sp>
         <p:nvSpPr>
-          <p:cNvPr id="7" name="Shape 5"/>
+          <p:cNvPr id="8" name="Shape 5"/>
           <p:cNvSpPr/>
           <p:nvPr/>
         </p:nvSpPr>
@@ -7272,7 +7287,7 @@
       </p:sp>
       <p:sp>
         <p:nvSpPr>
-          <p:cNvPr id="8" name="Text 6"/>
+          <p:cNvPr id="9" name="Text 6"/>
           <p:cNvSpPr txBox="1"/>
           <p:nvPr/>
         </p:nvSpPr>
@@ -7311,7 +7326,7 @@
       </p:sp>
       <p:sp>
         <p:nvSpPr>
-          <p:cNvPr id="9" name="Shape 7"/>
+          <p:cNvPr id="10" name="Shape 7"/>
           <p:cNvSpPr/>
           <p:nvPr/>
         </p:nvSpPr>
@@ -7333,7 +7348,7 @@
       </p:sp>
       <p:sp>
         <p:nvSpPr>
-          <p:cNvPr id="10" name="Text 8"/>
+          <p:cNvPr id="11" name="Text 8"/>
           <p:cNvSpPr txBox="1"/>
           <p:nvPr/>
         </p:nvSpPr>
@@ -7372,7 +7387,7 @@
       </p:sp>
       <p:sp>
         <p:nvSpPr>
-          <p:cNvPr id="11" name="Shape 9"/>
+          <p:cNvPr id="12" name="Shape 9"/>
           <p:cNvSpPr/>
           <p:nvPr/>
         </p:nvSpPr>
@@ -7394,7 +7409,7 @@
       </p:sp>
       <p:sp>
         <p:nvSpPr>
-          <p:cNvPr id="12" name="Text 10"/>
+          <p:cNvPr id="13" name="Text 10"/>
           <p:cNvSpPr txBox="1"/>
           <p:nvPr/>
         </p:nvSpPr>
@@ -7433,7 +7448,7 @@
       </p:sp>
       <p:sp>
         <p:nvSpPr>
-          <p:cNvPr id="13" name="Shape 11"/>
+          <p:cNvPr id="14" name="Shape 11"/>
           <p:cNvSpPr/>
           <p:nvPr/>
         </p:nvSpPr>
@@ -7455,7 +7470,7 @@
       </p:sp>
       <p:sp>
         <p:nvSpPr>
-          <p:cNvPr id="14" name="Text 12"/>
+          <p:cNvPr id="15" name="Text 12"/>
           <p:cNvSpPr txBox="1"/>
           <p:nvPr/>
         </p:nvSpPr>
@@ -7494,7 +7509,7 @@
       </p:sp>
       <p:sp>
         <p:nvSpPr>
-          <p:cNvPr id="15" name="Shape 13"/>
+          <p:cNvPr id="16" name="Shape 13"/>
           <p:cNvSpPr/>
           <p:nvPr/>
         </p:nvSpPr>
@@ -7516,7 +7531,7 @@
       </p:sp>
       <p:sp>
         <p:nvSpPr>
-          <p:cNvPr id="16" name="Text 14"/>
+          <p:cNvPr id="17" name="Text 14"/>
           <p:cNvSpPr txBox="1"/>
           <p:nvPr/>
         </p:nvSpPr>
@@ -7555,7 +7570,7 @@
       </p:sp>
       <p:sp>
         <p:nvSpPr>
-          <p:cNvPr id="17" name="Text 15"/>
+          <p:cNvPr id="18" name="Text 15"/>
           <p:cNvSpPr txBox="1"/>
           <p:nvPr/>
         </p:nvSpPr>
@@ -7594,7 +7609,7 @@
       </p:sp>
       <p:sp>
         <p:nvSpPr>
-          <p:cNvPr id="18" name="Shape 16"/>
+          <p:cNvPr id="19" name="Shape 16"/>
           <p:cNvSpPr/>
           <p:nvPr/>
         </p:nvSpPr>
@@ -7616,7 +7631,7 @@
       </p:sp>
       <p:sp>
         <p:nvSpPr>
-          <p:cNvPr id="19" name="Text 17"/>
+          <p:cNvPr id="20" name="Text 17"/>
           <p:cNvSpPr txBox="1"/>
           <p:nvPr/>
         </p:nvSpPr>
@@ -7655,7 +7670,7 @@
       </p:sp>
       <p:sp>
         <p:nvSpPr>
-          <p:cNvPr id="20" name="Text 18"/>
+          <p:cNvPr id="21" name="Text 18"/>
           <p:cNvSpPr txBox="1"/>
           <p:nvPr/>
         </p:nvSpPr>
@@ -7694,7 +7709,7 @@
       </p:sp>
       <p:sp>
         <p:nvSpPr>
-          <p:cNvPr id="21" name="Shape 19"/>
+          <p:cNvPr id="22" name="Shape 19"/>
           <p:cNvSpPr/>
           <p:nvPr/>
         </p:nvSpPr>
@@ -7716,7 +7731,7 @@
       </p:sp>
       <p:sp>
         <p:nvSpPr>
-          <p:cNvPr id="22" name="Text 20"/>
+          <p:cNvPr id="23" name="Text 20"/>
           <p:cNvSpPr txBox="1"/>
           <p:nvPr/>
         </p:nvSpPr>
@@ -7755,7 +7770,7 @@
       </p:sp>
       <p:sp>
         <p:nvSpPr>
-          <p:cNvPr id="23" name="Text 21"/>
+          <p:cNvPr id="24" name="Text 21"/>
           <p:cNvSpPr txBox="1"/>
           <p:nvPr/>
         </p:nvSpPr>
@@ -7794,7 +7809,7 @@
       </p:sp>
       <p:sp>
         <p:nvSpPr>
-          <p:cNvPr id="24" name="Shape 22"/>
+          <p:cNvPr id="25" name="Shape 22"/>
           <p:cNvSpPr/>
           <p:nvPr/>
         </p:nvSpPr>
@@ -7816,7 +7831,7 @@
       </p:sp>
       <p:sp>
         <p:nvSpPr>
-          <p:cNvPr id="25" name="Text 23"/>
+          <p:cNvPr id="26" name="Text 23"/>
           <p:cNvSpPr txBox="1"/>
           <p:nvPr/>
         </p:nvSpPr>
@@ -7855,7 +7870,7 @@
       </p:sp>
       <p:sp>
         <p:nvSpPr>
-          <p:cNvPr id="26" name="Text 24"/>
+          <p:cNvPr id="27" name="Text 24"/>
           <p:cNvSpPr txBox="1"/>
           <p:nvPr/>
         </p:nvSpPr>
@@ -7894,7 +7909,7 @@
       </p:sp>
       <p:sp>
         <p:nvSpPr>
-          <p:cNvPr id="27" name="Text 25"/>
+          <p:cNvPr id="28" name="Text 25"/>
           <p:cNvSpPr txBox="1"/>
           <p:nvPr/>
         </p:nvSpPr>
@@ -7933,7 +7948,7 @@
       </p:sp>
       <p:sp>
         <p:nvSpPr>
-          <p:cNvPr id="28" name="Text 26"/>
+          <p:cNvPr id="29" name="Text 26"/>
           <p:cNvSpPr txBox="1"/>
           <p:nvPr/>
         </p:nvSpPr>
@@ -8027,7 +8042,7 @@
       </p:sp>
       <p:sp>
         <p:nvSpPr>
-          <p:cNvPr id="29" name="Text 27"/>
+          <p:cNvPr id="30" name="Text 27"/>
           <p:cNvSpPr txBox="1"/>
           <p:nvPr/>
         </p:nvSpPr>
@@ -8066,7 +8081,7 @@
       </p:sp>
       <p:sp>
         <p:nvSpPr>
-          <p:cNvPr id="30" name="Text 28"/>
+          <p:cNvPr id="31" name="Text 28"/>
           <p:cNvSpPr txBox="1"/>
           <p:nvPr/>
         </p:nvSpPr>
@@ -8137,7 +8152,7 @@
       </p:grpSpPr>
       <p:sp>
         <p:nvSpPr>
-          <p:cNvPr id="2" name="Text 0"/>
+          <p:cNvPr id="3" name="Text 0"/>
           <p:cNvSpPr txBox="1"/>
           <p:nvPr/>
         </p:nvSpPr>
@@ -8176,7 +8191,7 @@
       </p:sp>
       <p:sp>
         <p:nvSpPr>
-          <p:cNvPr id="3" name="Text 1"/>
+          <p:cNvPr id="4" name="Text 1"/>
           <p:cNvSpPr txBox="1"/>
           <p:nvPr/>
         </p:nvSpPr>
@@ -8215,7 +8230,7 @@
       </p:sp>
       <p:pic>
         <p:nvPicPr>
-          <p:cNvPr id="4" name="Image 0" descr="/tmp/claude-0/-home-user-ensights/57acd941-a2c9-5cfa-90b7-9e5814c7c436/scratchpad/figures/top_products.png">    </p:cNvPr>
+          <p:cNvPr id="5" name="Image 0" descr="/tmp/claude-0/-home-user-ensights/57acd941-a2c9-5cfa-90b7-9e5814c7c436/scratchpad/figures/top_products.png">    </p:cNvPr>
           <p:cNvPicPr>
             <a:picLocks noChangeAspect="1"/>
           </p:cNvPicPr>
@@ -8238,7 +8253,7 @@
       </p:pic>
       <p:sp>
         <p:nvSpPr>
-          <p:cNvPr id="5" name="Shape 2"/>
+          <p:cNvPr id="6" name="Shape 2"/>
           <p:cNvSpPr/>
           <p:nvPr/>
         </p:nvSpPr>
@@ -8260,7 +8275,7 @@
       </p:sp>
       <p:sp>
         <p:nvSpPr>
-          <p:cNvPr id="6" name="Text 3"/>
+          <p:cNvPr id="7" name="Text 3"/>
           <p:cNvSpPr txBox="1"/>
           <p:nvPr/>
         </p:nvSpPr>
@@ -8299,7 +8314,7 @@
       </p:sp>
       <p:pic>
         <p:nvPicPr>
-          <p:cNvPr id="7" name="Image 1" descr="/tmp/claude-0/-home-user-ensights/57acd941-a2c9-5cfa-90b7-9e5814c7c436/scratchpad/figures/top_regions.png">    </p:cNvPr>
+          <p:cNvPr id="8" name="Image 1" descr="/tmp/claude-0/-home-user-ensights/57acd941-a2c9-5cfa-90b7-9e5814c7c436/scratchpad/figures/top_regions.png">    </p:cNvPr>
           <p:cNvPicPr>
             <a:picLocks noChangeAspect="1"/>
           </p:cNvPicPr>
@@ -8322,7 +8337,7 @@
       </p:pic>
       <p:sp>
         <p:nvSpPr>
-          <p:cNvPr id="8" name="Shape 4"/>
+          <p:cNvPr id="9" name="Shape 4"/>
           <p:cNvSpPr/>
           <p:nvPr/>
         </p:nvSpPr>
@@ -8344,7 +8359,7 @@
       </p:sp>
       <p:sp>
         <p:nvSpPr>
-          <p:cNvPr id="9" name="Text 5"/>
+          <p:cNvPr id="10" name="Text 5"/>
           <p:cNvSpPr txBox="1"/>
           <p:nvPr/>
         </p:nvSpPr>
@@ -8383,7 +8398,7 @@
       </p:sp>
       <p:sp>
         <p:nvSpPr>
-          <p:cNvPr id="10" name="Text 6"/>
+          <p:cNvPr id="11" name="Text 6"/>
           <p:cNvSpPr txBox="1"/>
           <p:nvPr/>
         </p:nvSpPr>
@@ -8453,7 +8468,7 @@
       </p:sp>
       <p:sp>
         <p:nvSpPr>
-          <p:cNvPr id="11" name="Text 7"/>
+          <p:cNvPr id="12" name="Text 7"/>
           <p:cNvSpPr txBox="1"/>
           <p:nvPr/>
         </p:nvSpPr>
@@ -8492,7 +8507,7 @@
       </p:sp>
       <p:sp>
         <p:nvSpPr>
-          <p:cNvPr id="12" name="Text 8"/>
+          <p:cNvPr id="13" name="Text 8"/>
           <p:cNvSpPr txBox="1"/>
           <p:nvPr/>
         </p:nvSpPr>
@@ -8563,7 +8578,7 @@
       </p:grpSpPr>
       <p:sp>
         <p:nvSpPr>
-          <p:cNvPr id="2" name="Text 0"/>
+          <p:cNvPr id="3" name="Text 0"/>
           <p:cNvSpPr txBox="1"/>
           <p:nvPr/>
         </p:nvSpPr>
@@ -8602,7 +8617,7 @@
       </p:sp>
       <p:sp>
         <p:nvSpPr>
-          <p:cNvPr id="3" name="Text 1"/>
+          <p:cNvPr id="4" name="Text 1"/>
           <p:cNvSpPr txBox="1"/>
           <p:nvPr/>
         </p:nvSpPr>
@@ -8641,7 +8656,7 @@
       </p:sp>
       <p:pic>
         <p:nvPicPr>
-          <p:cNvPr id="4" name="Image 0" descr="/tmp/claude-0/-home-user-ensights/57acd941-a2c9-5cfa-90b7-9e5814c7c436/scratchpad/figures/sales_monthly.png">    </p:cNvPr>
+          <p:cNvPr id="5" name="Image 0" descr="/tmp/claude-0/-home-user-ensights/57acd941-a2c9-5cfa-90b7-9e5814c7c436/scratchpad/figures/sales_monthly.png">    </p:cNvPr>
           <p:cNvPicPr>
             <a:picLocks noChangeAspect="1"/>
           </p:cNvPicPr>
@@ -8664,7 +8679,7 @@
       </p:pic>
       <p:sp>
         <p:nvSpPr>
-          <p:cNvPr id="5" name="Shape 2"/>
+          <p:cNvPr id="6" name="Shape 2"/>
           <p:cNvSpPr/>
           <p:nvPr/>
         </p:nvSpPr>
@@ -8686,7 +8701,7 @@
       </p:sp>
       <p:sp>
         <p:nvSpPr>
-          <p:cNvPr id="6" name="Text 3"/>
+          <p:cNvPr id="7" name="Text 3"/>
           <p:cNvSpPr txBox="1"/>
           <p:nvPr/>
         </p:nvSpPr>
@@ -8725,7 +8740,7 @@
       </p:sp>
       <p:pic>
         <p:nvPicPr>
-          <p:cNvPr id="7" name="Image 1" descr="/tmp/claude-0/-home-user-ensights/57acd941-a2c9-5cfa-90b7-9e5814c7c436/scratchpad/figures/sales_weekday.png">    </p:cNvPr>
+          <p:cNvPr id="8" name="Image 1" descr="/tmp/claude-0/-home-user-ensights/57acd941-a2c9-5cfa-90b7-9e5814c7c436/scratchpad/figures/sales_weekday.png">    </p:cNvPr>
           <p:cNvPicPr>
             <a:picLocks noChangeAspect="1"/>
           </p:cNvPicPr>
@@ -8748,7 +8763,7 @@
       </p:pic>
       <p:sp>
         <p:nvSpPr>
-          <p:cNvPr id="8" name="Shape 4"/>
+          <p:cNvPr id="9" name="Shape 4"/>
           <p:cNvSpPr/>
           <p:nvPr/>
         </p:nvSpPr>
@@ -8770,7 +8785,7 @@
       </p:sp>
       <p:sp>
         <p:nvSpPr>
-          <p:cNvPr id="9" name="Text 5"/>
+          <p:cNvPr id="10" name="Text 5"/>
           <p:cNvSpPr txBox="1"/>
           <p:nvPr/>
         </p:nvSpPr>
@@ -8809,7 +8824,7 @@
       </p:sp>
       <p:sp>
         <p:nvSpPr>
-          <p:cNvPr id="10" name="Text 6"/>
+          <p:cNvPr id="11" name="Text 6"/>
           <p:cNvSpPr txBox="1"/>
           <p:nvPr/>
         </p:nvSpPr>
@@ -8848,7 +8863,7 @@
       </p:sp>
       <p:sp>
         <p:nvSpPr>
-          <p:cNvPr id="11" name="Text 7"/>
+          <p:cNvPr id="12" name="Text 7"/>
           <p:cNvSpPr txBox="1"/>
           <p:nvPr/>
         </p:nvSpPr>
@@ -8919,7 +8934,7 @@
       </p:grpSpPr>
       <p:sp>
         <p:nvSpPr>
-          <p:cNvPr id="2" name="Text 0"/>
+          <p:cNvPr id="3" name="Text 0"/>
           <p:cNvSpPr txBox="1"/>
           <p:nvPr/>
         </p:nvSpPr>
@@ -8958,7 +8973,7 @@
       </p:sp>
       <p:sp>
         <p:nvSpPr>
-          <p:cNvPr id="3" name="Text 1"/>
+          <p:cNvPr id="4" name="Text 1"/>
           <p:cNvSpPr txBox="1"/>
           <p:nvPr/>
         </p:nvSpPr>
@@ -8997,7 +9012,7 @@
       </p:sp>
       <p:pic>
         <p:nvPicPr>
-          <p:cNvPr id="4" name="Image 0" descr="/tmp/claude-0/-home-user-ensights/57acd941-a2c9-5cfa-90b7-9e5814c7c436/scratchpad/figures/price_bands.png">    </p:cNvPr>
+          <p:cNvPr id="5" name="Image 0" descr="/tmp/claude-0/-home-user-ensights/57acd941-a2c9-5cfa-90b7-9e5814c7c436/scratchpad/figures/price_bands.png">    </p:cNvPr>
           <p:cNvPicPr>
             <a:picLocks noChangeAspect="1"/>
           </p:cNvPicPr>
@@ -9020,7 +9035,7 @@
       </p:pic>
       <p:sp>
         <p:nvSpPr>
-          <p:cNvPr id="5" name="Shape 2"/>
+          <p:cNvPr id="6" name="Shape 2"/>
           <p:cNvSpPr/>
           <p:nvPr/>
         </p:nvSpPr>
@@ -9042,7 +9057,7 @@
       </p:sp>
       <p:sp>
         <p:nvSpPr>
-          <p:cNvPr id="6" name="Text 3"/>
+          <p:cNvPr id="7" name="Text 3"/>
           <p:cNvSpPr txBox="1"/>
           <p:nvPr/>
         </p:nvSpPr>
@@ -9081,7 +9096,7 @@
       </p:sp>
       <p:pic>
         <p:nvPicPr>
-          <p:cNvPr id="7" name="Image 1" descr="/tmp/claude-0/-home-user-ensights/57acd941-a2c9-5cfa-90b7-9e5814c7c436/scratchpad/figures/characteristics.png">    </p:cNvPr>
+          <p:cNvPr id="8" name="Image 1" descr="/tmp/claude-0/-home-user-ensights/57acd941-a2c9-5cfa-90b7-9e5814c7c436/scratchpad/figures/characteristics.png">    </p:cNvPr>
           <p:cNvPicPr>
             <a:picLocks noChangeAspect="1"/>
           </p:cNvPicPr>
@@ -9104,7 +9119,7 @@
       </p:pic>
       <p:sp>
         <p:nvSpPr>
-          <p:cNvPr id="8" name="Shape 4"/>
+          <p:cNvPr id="9" name="Shape 4"/>
           <p:cNvSpPr/>
           <p:nvPr/>
         </p:nvSpPr>
@@ -9126,7 +9141,7 @@
       </p:sp>
       <p:sp>
         <p:nvSpPr>
-          <p:cNvPr id="9" name="Text 5"/>
+          <p:cNvPr id="10" name="Text 5"/>
           <p:cNvSpPr txBox="1"/>
           <p:nvPr/>
         </p:nvSpPr>
@@ -9165,7 +9180,7 @@
       </p:sp>
       <p:sp>
         <p:nvSpPr>
-          <p:cNvPr id="10" name="Text 6"/>
+          <p:cNvPr id="11" name="Text 6"/>
           <p:cNvSpPr txBox="1"/>
           <p:nvPr/>
         </p:nvSpPr>
@@ -9235,7 +9250,7 @@
       </p:sp>
       <p:sp>
         <p:nvSpPr>
-          <p:cNvPr id="11" name="Text 7"/>
+          <p:cNvPr id="12" name="Text 7"/>
           <p:cNvSpPr txBox="1"/>
           <p:nvPr/>
         </p:nvSpPr>
@@ -9274,7 +9289,7 @@
       </p:sp>
       <p:sp>
         <p:nvSpPr>
-          <p:cNvPr id="12" name="Text 8"/>
+          <p:cNvPr id="13" name="Text 8"/>
           <p:cNvSpPr txBox="1"/>
           <p:nvPr/>
         </p:nvSpPr>
@@ -9345,7 +9360,7 @@
       </p:grpSpPr>
       <p:sp>
         <p:nvSpPr>
-          <p:cNvPr id="2" name="Text 0"/>
+          <p:cNvPr id="3" name="Text 0"/>
           <p:cNvSpPr txBox="1"/>
           <p:nvPr/>
         </p:nvSpPr>
@@ -9384,7 +9399,7 @@
       </p:sp>
       <p:sp>
         <p:nvSpPr>
-          <p:cNvPr id="3" name="Text 1"/>
+          <p:cNvPr id="4" name="Text 1"/>
           <p:cNvSpPr txBox="1"/>
           <p:nvPr/>
         </p:nvSpPr>
@@ -9423,7 +9438,7 @@
       </p:sp>
       <p:pic>
         <p:nvPicPr>
-          <p:cNvPr id="4" name="Image 0" descr="/tmp/claude-0/-home-user-ensights/57acd941-a2c9-5cfa-90b7-9e5814c7c436/scratchpad/figures/basket_sizes.png">    </p:cNvPr>
+          <p:cNvPr id="5" name="Image 0" descr="/tmp/claude-0/-home-user-ensights/57acd941-a2c9-5cfa-90b7-9e5814c7c436/scratchpad/figures/basket_sizes.png">    </p:cNvPr>
           <p:cNvPicPr>
             <a:picLocks noChangeAspect="1"/>
           </p:cNvPicPr>
@@ -9446,7 +9461,7 @@
       </p:pic>
       <p:sp>
         <p:nvSpPr>
-          <p:cNvPr id="5" name="Shape 2"/>
+          <p:cNvPr id="6" name="Shape 2"/>
           <p:cNvSpPr/>
           <p:nvPr/>
         </p:nvSpPr>
@@ -9468,7 +9483,7 @@
       </p:sp>
       <p:sp>
         <p:nvSpPr>
-          <p:cNvPr id="6" name="Text 3"/>
+          <p:cNvPr id="7" name="Text 3"/>
           <p:cNvSpPr txBox="1"/>
           <p:nvPr/>
         </p:nvSpPr>
@@ -9507,7 +9522,7 @@
       </p:sp>
       <p:sp>
         <p:nvSpPr>
-          <p:cNvPr id="7" name="Shape 4"/>
+          <p:cNvPr id="8" name="Shape 4"/>
           <p:cNvSpPr/>
           <p:nvPr/>
         </p:nvSpPr>
@@ -9536,7 +9551,7 @@
       </p:sp>
       <p:sp>
         <p:nvSpPr>
-          <p:cNvPr id="8" name="Text 5"/>
+          <p:cNvPr id="9" name="Text 5"/>
           <p:cNvSpPr txBox="1"/>
           <p:nvPr/>
         </p:nvSpPr>
@@ -9575,7 +9590,7 @@
       </p:sp>
       <p:sp>
         <p:nvSpPr>
-          <p:cNvPr id="9" name="Text 6"/>
+          <p:cNvPr id="10" name="Text 6"/>
           <p:cNvSpPr txBox="1"/>
           <p:nvPr/>
         </p:nvSpPr>
@@ -9614,7 +9629,7 @@
       </p:sp>
       <p:sp>
         <p:nvSpPr>
-          <p:cNvPr id="10" name="Shape 7"/>
+          <p:cNvPr id="11" name="Shape 7"/>
           <p:cNvSpPr/>
           <p:nvPr/>
         </p:nvSpPr>
@@ -9643,7 +9658,7 @@
       </p:sp>
       <p:sp>
         <p:nvSpPr>
-          <p:cNvPr id="11" name="Text 8"/>
+          <p:cNvPr id="12" name="Text 8"/>
           <p:cNvSpPr txBox="1"/>
           <p:nvPr/>
         </p:nvSpPr>
@@ -9682,7 +9697,7 @@
       </p:sp>
       <p:sp>
         <p:nvSpPr>
-          <p:cNvPr id="12" name="Text 9"/>
+          <p:cNvPr id="13" name="Text 9"/>
           <p:cNvSpPr txBox="1"/>
           <p:nvPr/>
         </p:nvSpPr>
@@ -9721,7 +9736,7 @@
       </p:sp>
       <p:sp>
         <p:nvSpPr>
-          <p:cNvPr id="13" name="Text 10"/>
+          <p:cNvPr id="14" name="Text 10"/>
           <p:cNvSpPr txBox="1"/>
           <p:nvPr/>
         </p:nvSpPr>
@@ -10614,7 +10629,7 @@
       </p:graphicFrame>
       <p:sp>
         <p:nvSpPr>
-          <p:cNvPr id="15" name="Text 11"/>
+          <p:cNvPr id="16" name="Text 11"/>
           <p:cNvSpPr txBox="1"/>
           <p:nvPr/>
         </p:nvSpPr>
@@ -10653,7 +10668,7 @@
       </p:sp>
       <p:sp>
         <p:nvSpPr>
-          <p:cNvPr id="16" name="Text 12"/>
+          <p:cNvPr id="17" name="Text 12"/>
           <p:cNvSpPr txBox="1"/>
           <p:nvPr/>
         </p:nvSpPr>
@@ -10692,7 +10707,7 @@
       </p:sp>
       <p:sp>
         <p:nvSpPr>
-          <p:cNvPr id="17" name="Text 13"/>
+          <p:cNvPr id="18" name="Text 13"/>
           <p:cNvSpPr txBox="1"/>
           <p:nvPr/>
         </p:nvSpPr>
@@ -10763,7 +10778,7 @@
       </p:grpSpPr>
       <p:sp>
         <p:nvSpPr>
-          <p:cNvPr id="2" name="Text 0"/>
+          <p:cNvPr id="3" name="Text 0"/>
           <p:cNvSpPr txBox="1"/>
           <p:nvPr/>
         </p:nvSpPr>
@@ -10802,7 +10817,7 @@
       </p:sp>
       <p:sp>
         <p:nvSpPr>
-          <p:cNvPr id="3" name="Text 1"/>
+          <p:cNvPr id="4" name="Text 1"/>
           <p:cNvSpPr txBox="1"/>
           <p:nvPr/>
         </p:nvSpPr>
@@ -10841,7 +10856,7 @@
       </p:sp>
       <p:pic>
         <p:nvPicPr>
-          <p:cNvPr id="4" name="Image 0" descr="/tmp/claude-0/-home-user-ensights/57acd941-a2c9-5cfa-90b7-9e5814c7c436/scratchpad/figures/support_sensitivity.png">    </p:cNvPr>
+          <p:cNvPr id="5" name="Image 0" descr="/tmp/claude-0/-home-user-ensights/57acd941-a2c9-5cfa-90b7-9e5814c7c436/scratchpad/figures/support_sensitivity.png">    </p:cNvPr>
           <p:cNvPicPr>
             <a:picLocks noChangeAspect="1"/>
           </p:cNvPicPr>
@@ -10864,7 +10879,7 @@
       </p:pic>
       <p:sp>
         <p:nvSpPr>
-          <p:cNvPr id="5" name="Shape 2"/>
+          <p:cNvPr id="6" name="Shape 2"/>
           <p:cNvSpPr/>
           <p:nvPr/>
         </p:nvSpPr>
@@ -10886,7 +10901,7 @@
       </p:sp>
       <p:sp>
         <p:nvSpPr>
-          <p:cNvPr id="6" name="Text 3"/>
+          <p:cNvPr id="7" name="Text 3"/>
           <p:cNvSpPr txBox="1"/>
           <p:nvPr/>
         </p:nvSpPr>
@@ -10925,7 +10940,7 @@
       </p:sp>
       <p:pic>
         <p:nvPicPr>
-          <p:cNvPr id="7" name="Image 1" descr="/tmp/claude-0/-home-user-ensights/57acd941-a2c9-5cfa-90b7-9e5814c7c436/scratchpad/figures/association_rules.png">    </p:cNvPr>
+          <p:cNvPr id="8" name="Image 1" descr="/tmp/claude-0/-home-user-ensights/57acd941-a2c9-5cfa-90b7-9e5814c7c436/scratchpad/figures/association_rules.png">    </p:cNvPr>
           <p:cNvPicPr>
             <a:picLocks noChangeAspect="1"/>
           </p:cNvPicPr>
@@ -10948,7 +10963,7 @@
       </p:pic>
       <p:sp>
         <p:nvSpPr>
-          <p:cNvPr id="8" name="Shape 4"/>
+          <p:cNvPr id="9" name="Shape 4"/>
           <p:cNvSpPr/>
           <p:nvPr/>
         </p:nvSpPr>
@@ -10970,7 +10985,7 @@
       </p:sp>
       <p:sp>
         <p:nvSpPr>
-          <p:cNvPr id="9" name="Text 5"/>
+          <p:cNvPr id="10" name="Text 5"/>
           <p:cNvSpPr txBox="1"/>
           <p:nvPr/>
         </p:nvSpPr>
@@ -11009,7 +11024,7 @@
       </p:sp>
       <p:sp>
         <p:nvSpPr>
-          <p:cNvPr id="10" name="Shape 6"/>
+          <p:cNvPr id="11" name="Shape 6"/>
           <p:cNvSpPr/>
           <p:nvPr/>
         </p:nvSpPr>
@@ -11031,7 +11046,7 @@
       </p:sp>
       <p:sp>
         <p:nvSpPr>
-          <p:cNvPr id="11" name="Text 7"/>
+          <p:cNvPr id="12" name="Text 7"/>
           <p:cNvSpPr txBox="1"/>
           <p:nvPr/>
         </p:nvSpPr>
@@ -11101,7 +11116,7 @@
       </p:sp>
       <p:sp>
         <p:nvSpPr>
-          <p:cNvPr id="12" name="Text 8"/>
+          <p:cNvPr id="13" name="Text 8"/>
           <p:cNvSpPr txBox="1"/>
           <p:nvPr/>
         </p:nvSpPr>
@@ -11140,7 +11155,7 @@
       </p:sp>
       <p:sp>
         <p:nvSpPr>
-          <p:cNvPr id="13" name="Text 9"/>
+          <p:cNvPr id="14" name="Text 9"/>
           <p:cNvSpPr txBox="1"/>
           <p:nvPr/>
         </p:nvSpPr>
@@ -11211,7 +11226,7 @@
       </p:grpSpPr>
       <p:sp>
         <p:nvSpPr>
-          <p:cNvPr id="2" name="Text 0"/>
+          <p:cNvPr id="3" name="Text 0"/>
           <p:cNvSpPr txBox="1"/>
           <p:nvPr/>
         </p:nvSpPr>
@@ -11250,7 +11265,7 @@
       </p:sp>
       <p:sp>
         <p:nvSpPr>
-          <p:cNvPr id="3" name="Text 1"/>
+          <p:cNvPr id="4" name="Text 1"/>
           <p:cNvSpPr txBox="1"/>
           <p:nvPr/>
         </p:nvSpPr>
@@ -11289,7 +11304,7 @@
       </p:sp>
       <p:sp>
         <p:nvSpPr>
-          <p:cNvPr id="4" name="Shape 2"/>
+          <p:cNvPr id="5" name="Shape 2"/>
           <p:cNvSpPr/>
           <p:nvPr/>
         </p:nvSpPr>
@@ -11309,7 +11324,7 @@
       </p:sp>
       <p:sp>
         <p:nvSpPr>
-          <p:cNvPr id="5" name="Text 3"/>
+          <p:cNvPr id="6" name="Text 3"/>
           <p:cNvSpPr txBox="1"/>
           <p:nvPr/>
         </p:nvSpPr>
@@ -11348,7 +11363,7 @@
       </p:sp>
       <p:sp>
         <p:nvSpPr>
-          <p:cNvPr id="6" name="Text 4"/>
+          <p:cNvPr id="7" name="Text 4"/>
           <p:cNvSpPr txBox="1"/>
           <p:nvPr/>
         </p:nvSpPr>
@@ -11401,7 +11416,7 @@
       </p:sp>
       <p:sp>
         <p:nvSpPr>
-          <p:cNvPr id="7" name="Shape 5"/>
+          <p:cNvPr id="8" name="Shape 5"/>
           <p:cNvSpPr/>
           <p:nvPr/>
         </p:nvSpPr>
@@ -11421,7 +11436,7 @@
       </p:sp>
       <p:sp>
         <p:nvSpPr>
-          <p:cNvPr id="8" name="Text 6"/>
+          <p:cNvPr id="9" name="Text 6"/>
           <p:cNvSpPr txBox="1"/>
           <p:nvPr/>
         </p:nvSpPr>
@@ -11460,7 +11475,7 @@
       </p:sp>
       <p:sp>
         <p:nvSpPr>
-          <p:cNvPr id="9" name="Text 7"/>
+          <p:cNvPr id="10" name="Text 7"/>
           <p:cNvSpPr txBox="1"/>
           <p:nvPr/>
         </p:nvSpPr>
@@ -11513,7 +11528,7 @@
       </p:sp>
       <p:sp>
         <p:nvSpPr>
-          <p:cNvPr id="10" name="Shape 8"/>
+          <p:cNvPr id="11" name="Shape 8"/>
           <p:cNvSpPr/>
           <p:nvPr/>
         </p:nvSpPr>
@@ -11533,7 +11548,7 @@
       </p:sp>
       <p:sp>
         <p:nvSpPr>
-          <p:cNvPr id="11" name="Text 9"/>
+          <p:cNvPr id="12" name="Text 9"/>
           <p:cNvSpPr txBox="1"/>
           <p:nvPr/>
         </p:nvSpPr>
@@ -11572,7 +11587,7 @@
       </p:sp>
       <p:sp>
         <p:nvSpPr>
-          <p:cNvPr id="12" name="Text 10"/>
+          <p:cNvPr id="13" name="Text 10"/>
           <p:cNvSpPr txBox="1"/>
           <p:nvPr/>
         </p:nvSpPr>
@@ -11625,7 +11640,7 @@
       </p:sp>
       <p:sp>
         <p:nvSpPr>
-          <p:cNvPr id="13" name="Shape 11"/>
+          <p:cNvPr id="14" name="Shape 11"/>
           <p:cNvSpPr/>
           <p:nvPr/>
         </p:nvSpPr>
@@ -11645,7 +11660,7 @@
       </p:sp>
       <p:sp>
         <p:nvSpPr>
-          <p:cNvPr id="14" name="Text 12"/>
+          <p:cNvPr id="15" name="Text 12"/>
           <p:cNvSpPr txBox="1"/>
           <p:nvPr/>
         </p:nvSpPr>
@@ -11684,7 +11699,7 @@
       </p:sp>
       <p:sp>
         <p:nvSpPr>
-          <p:cNvPr id="15" name="Text 13"/>
+          <p:cNvPr id="16" name="Text 13"/>
           <p:cNvSpPr txBox="1"/>
           <p:nvPr/>
         </p:nvSpPr>
@@ -11737,7 +11752,7 @@
       </p:sp>
       <p:sp>
         <p:nvSpPr>
-          <p:cNvPr id="16" name="Shape 14"/>
+          <p:cNvPr id="17" name="Shape 14"/>
           <p:cNvSpPr/>
           <p:nvPr/>
         </p:nvSpPr>
@@ -11757,7 +11772,7 @@
       </p:sp>
       <p:sp>
         <p:nvSpPr>
-          <p:cNvPr id="17" name="Text 15"/>
+          <p:cNvPr id="18" name="Text 15"/>
           <p:cNvSpPr txBox="1"/>
           <p:nvPr/>
         </p:nvSpPr>
@@ -11796,7 +11811,7 @@
       </p:sp>
       <p:sp>
         <p:nvSpPr>
-          <p:cNvPr id="18" name="Text 16"/>
+          <p:cNvPr id="19" name="Text 16"/>
           <p:cNvSpPr txBox="1"/>
           <p:nvPr/>
         </p:nvSpPr>
@@ -11849,7 +11864,7 @@
       </p:sp>
       <p:sp>
         <p:nvSpPr>
-          <p:cNvPr id="19" name="Shape 17"/>
+          <p:cNvPr id="20" name="Shape 17"/>
           <p:cNvSpPr/>
           <p:nvPr/>
         </p:nvSpPr>
@@ -11869,7 +11884,7 @@
       </p:sp>
       <p:sp>
         <p:nvSpPr>
-          <p:cNvPr id="20" name="Text 18"/>
+          <p:cNvPr id="21" name="Text 18"/>
           <p:cNvSpPr txBox="1"/>
           <p:nvPr/>
         </p:nvSpPr>
@@ -11908,7 +11923,7 @@
       </p:sp>
       <p:sp>
         <p:nvSpPr>
-          <p:cNvPr id="21" name="Text 19"/>
+          <p:cNvPr id="22" name="Text 19"/>
           <p:cNvSpPr txBox="1"/>
           <p:nvPr/>
         </p:nvSpPr>
@@ -11961,7 +11976,7 @@
       </p:sp>
       <p:sp>
         <p:nvSpPr>
-          <p:cNvPr id="22" name="Text 20"/>
+          <p:cNvPr id="23" name="Text 20"/>
           <p:cNvSpPr txBox="1"/>
           <p:nvPr/>
         </p:nvSpPr>
@@ -12000,7 +12015,7 @@
       </p:sp>
       <p:sp>
         <p:nvSpPr>
-          <p:cNvPr id="23" name="Text 21"/>
+          <p:cNvPr id="24" name="Text 21"/>
           <p:cNvSpPr txBox="1"/>
           <p:nvPr/>
         </p:nvSpPr>
@@ -12071,7 +12086,7 @@
       </p:grpSpPr>
       <p:sp>
         <p:nvSpPr>
-          <p:cNvPr id="2" name="Text 0"/>
+          <p:cNvPr id="3" name="Text 0"/>
           <p:cNvSpPr txBox="1"/>
           <p:nvPr/>
         </p:nvSpPr>
@@ -12110,7 +12125,7 @@
       </p:sp>
       <p:sp>
         <p:nvSpPr>
-          <p:cNvPr id="3" name="Text 1"/>
+          <p:cNvPr id="4" name="Text 1"/>
           <p:cNvSpPr txBox="1"/>
           <p:nvPr/>
         </p:nvSpPr>
@@ -12149,7 +12164,7 @@
       </p:sp>
       <p:pic>
         <p:nvPicPr>
-          <p:cNvPr id="4" name="Image 0" descr="/tmp/claude-0/-home-user-ensights/57acd941-a2c9-5cfa-90b7-9e5814c7c436/scratchpad/figures/silhouette_level_one.png">    </p:cNvPr>
+          <p:cNvPr id="5" name="Image 0" descr="/tmp/claude-0/-home-user-ensights/57acd941-a2c9-5cfa-90b7-9e5814c7c436/scratchpad/figures/silhouette_level_one.png">    </p:cNvPr>
           <p:cNvPicPr>
             <a:picLocks noChangeAspect="1"/>
           </p:cNvPicPr>
@@ -12172,7 +12187,7 @@
       </p:pic>
       <p:sp>
         <p:nvSpPr>
-          <p:cNvPr id="5" name="Shape 2"/>
+          <p:cNvPr id="6" name="Shape 2"/>
           <p:cNvSpPr/>
           <p:nvPr/>
         </p:nvSpPr>
@@ -12194,7 +12209,7 @@
       </p:sp>
       <p:sp>
         <p:nvSpPr>
-          <p:cNvPr id="6" name="Text 3"/>
+          <p:cNvPr id="7" name="Text 3"/>
           <p:cNvSpPr txBox="1"/>
           <p:nvPr/>
         </p:nvSpPr>
@@ -12233,7 +12248,7 @@
       </p:sp>
       <p:sp>
         <p:nvSpPr>
-          <p:cNvPr id="7" name="Text 4"/>
+          <p:cNvPr id="8" name="Text 4"/>
           <p:cNvSpPr txBox="1"/>
           <p:nvPr/>
         </p:nvSpPr>
@@ -13126,7 +13141,7 @@
       </p:graphicFrame>
       <p:sp>
         <p:nvSpPr>
-          <p:cNvPr id="9" name="Text 5"/>
+          <p:cNvPr id="10" name="Text 5"/>
           <p:cNvSpPr txBox="1"/>
           <p:nvPr/>
         </p:nvSpPr>
@@ -13172,7 +13187,7 @@
       </p:sp>
       <p:sp>
         <p:nvSpPr>
-          <p:cNvPr id="10" name="Text 6"/>
+          <p:cNvPr id="11" name="Text 6"/>
           <p:cNvSpPr txBox="1"/>
           <p:nvPr/>
         </p:nvSpPr>
@@ -13211,7 +13226,7 @@
       </p:sp>
       <p:sp>
         <p:nvSpPr>
-          <p:cNvPr id="11" name="Text 7"/>
+          <p:cNvPr id="12" name="Text 7"/>
           <p:cNvSpPr txBox="1"/>
           <p:nvPr/>
         </p:nvSpPr>
@@ -13282,7 +13297,7 @@
       </p:grpSpPr>
       <p:sp>
         <p:nvSpPr>
-          <p:cNvPr id="2" name="Text 0"/>
+          <p:cNvPr id="3" name="Text 0"/>
           <p:cNvSpPr txBox="1"/>
           <p:nvPr/>
         </p:nvSpPr>
@@ -13321,7 +13336,7 @@
       </p:sp>
       <p:sp>
         <p:nvSpPr>
-          <p:cNvPr id="3" name="Text 1"/>
+          <p:cNvPr id="4" name="Text 1"/>
           <p:cNvSpPr txBox="1"/>
           <p:nvPr/>
         </p:nvSpPr>
@@ -13360,7 +13375,7 @@
       </p:sp>
       <p:pic>
         <p:nvPicPr>
-          <p:cNvPr id="4" name="Image 0" descr="/tmp/claude-0/-home-user-ensights/57acd941-a2c9-5cfa-90b7-9e5814c7c436/scratchpad/figures/rfm_scatter.png">    </p:cNvPr>
+          <p:cNvPr id="5" name="Image 0" descr="/tmp/claude-0/-home-user-ensights/57acd941-a2c9-5cfa-90b7-9e5814c7c436/scratchpad/figures/rfm_scatter.png">    </p:cNvPr>
           <p:cNvPicPr>
             <a:picLocks noChangeAspect="1"/>
           </p:cNvPicPr>
@@ -13383,7 +13398,7 @@
       </p:pic>
       <p:sp>
         <p:nvSpPr>
-          <p:cNvPr id="5" name="Shape 2"/>
+          <p:cNvPr id="6" name="Shape 2"/>
           <p:cNvSpPr/>
           <p:nvPr/>
         </p:nvSpPr>
@@ -13405,7 +13420,7 @@
       </p:sp>
       <p:sp>
         <p:nvSpPr>
-          <p:cNvPr id="6" name="Text 3"/>
+          <p:cNvPr id="7" name="Text 3"/>
           <p:cNvSpPr txBox="1"/>
           <p:nvPr/>
         </p:nvSpPr>
@@ -14846,7 +14861,7 @@
       </p:graphicFrame>
       <p:sp>
         <p:nvSpPr>
-          <p:cNvPr id="8" name="Text 4"/>
+          <p:cNvPr id="9" name="Text 4"/>
           <p:cNvSpPr txBox="1"/>
           <p:nvPr/>
         </p:nvSpPr>
@@ -14916,7 +14931,7 @@
       </p:sp>
       <p:sp>
         <p:nvSpPr>
-          <p:cNvPr id="9" name="Text 5"/>
+          <p:cNvPr id="10" name="Text 5"/>
           <p:cNvSpPr txBox="1"/>
           <p:nvPr/>
         </p:nvSpPr>
@@ -14955,7 +14970,7 @@
       </p:sp>
       <p:sp>
         <p:nvSpPr>
-          <p:cNvPr id="10" name="Text 6"/>
+          <p:cNvPr id="11" name="Text 6"/>
           <p:cNvSpPr txBox="1"/>
           <p:nvPr/>
         </p:nvSpPr>
@@ -15026,7 +15041,7 @@
       </p:grpSpPr>
       <p:sp>
         <p:nvSpPr>
-          <p:cNvPr id="2" name="Text 0"/>
+          <p:cNvPr id="3" name="Text 0"/>
           <p:cNvSpPr txBox="1"/>
           <p:nvPr/>
         </p:nvSpPr>
@@ -15065,7 +15080,7 @@
       </p:sp>
       <p:sp>
         <p:nvSpPr>
-          <p:cNvPr id="3" name="Text 1"/>
+          <p:cNvPr id="4" name="Text 1"/>
           <p:cNvSpPr txBox="1"/>
           <p:nvPr/>
         </p:nvSpPr>
@@ -15104,7 +15119,7 @@
       </p:sp>
       <p:pic>
         <p:nvPicPr>
-          <p:cNvPr id="4" name="Image 0" descr="/tmp/claude-0/-home-user-ensights/57acd941-a2c9-5cfa-90b7-9e5814c7c436/scratchpad/figures/revenue_forecast.png">    </p:cNvPr>
+          <p:cNvPr id="5" name="Image 0" descr="/tmp/claude-0/-home-user-ensights/57acd941-a2c9-5cfa-90b7-9e5814c7c436/scratchpad/figures/revenue_forecast.png">    </p:cNvPr>
           <p:cNvPicPr>
             <a:picLocks noChangeAspect="1"/>
           </p:cNvPicPr>
@@ -15127,7 +15142,7 @@
       </p:pic>
       <p:sp>
         <p:nvSpPr>
-          <p:cNvPr id="5" name="Shape 2"/>
+          <p:cNvPr id="6" name="Shape 2"/>
           <p:cNvSpPr/>
           <p:nvPr/>
         </p:nvSpPr>
@@ -15149,7 +15164,7 @@
       </p:sp>
       <p:sp>
         <p:nvSpPr>
-          <p:cNvPr id="6" name="Text 3"/>
+          <p:cNvPr id="7" name="Text 3"/>
           <p:cNvSpPr txBox="1"/>
           <p:nvPr/>
         </p:nvSpPr>
@@ -16247,7 +16262,7 @@
       </p:graphicFrame>
       <p:sp>
         <p:nvSpPr>
-          <p:cNvPr id="8" name="Shape 4"/>
+          <p:cNvPr id="9" name="Shape 4"/>
           <p:cNvSpPr/>
           <p:nvPr/>
         </p:nvSpPr>
@@ -16269,7 +16284,7 @@
       </p:sp>
       <p:sp>
         <p:nvSpPr>
-          <p:cNvPr id="9" name="Text 5"/>
+          <p:cNvPr id="10" name="Text 5"/>
           <p:cNvSpPr txBox="1"/>
           <p:nvPr/>
         </p:nvSpPr>
@@ -16363,7 +16378,7 @@
       </p:sp>
       <p:sp>
         <p:nvSpPr>
-          <p:cNvPr id="10" name="Text 6"/>
+          <p:cNvPr id="11" name="Text 6"/>
           <p:cNvSpPr txBox="1"/>
           <p:nvPr/>
         </p:nvSpPr>
@@ -16402,7 +16417,7 @@
       </p:sp>
       <p:sp>
         <p:nvSpPr>
-          <p:cNvPr id="11" name="Text 7"/>
+          <p:cNvPr id="12" name="Text 7"/>
           <p:cNvSpPr txBox="1"/>
           <p:nvPr/>
         </p:nvSpPr>
@@ -16473,7 +16488,7 @@
       </p:grpSpPr>
       <p:sp>
         <p:nvSpPr>
-          <p:cNvPr id="2" name="Text 0"/>
+          <p:cNvPr id="3" name="Text 0"/>
           <p:cNvSpPr txBox="1"/>
           <p:nvPr/>
         </p:nvSpPr>
@@ -16512,7 +16527,7 @@
       </p:sp>
       <p:sp>
         <p:nvSpPr>
-          <p:cNvPr id="3" name="Text 1"/>
+          <p:cNvPr id="4" name="Text 1"/>
           <p:cNvSpPr txBox="1"/>
           <p:nvPr/>
         </p:nvSpPr>
@@ -16551,7 +16566,7 @@
       </p:sp>
       <p:pic>
         <p:nvPicPr>
-          <p:cNvPr id="4" name="Image 0" descr="/tmp/claude-0/-home-user-ensights/57acd941-a2c9-5cfa-90b7-9e5814c7c436/scratchpad/figures/growth_accounting.png">    </p:cNvPr>
+          <p:cNvPr id="5" name="Image 0" descr="/tmp/claude-0/-home-user-ensights/57acd941-a2c9-5cfa-90b7-9e5814c7c436/scratchpad/figures/growth_accounting.png">    </p:cNvPr>
           <p:cNvPicPr>
             <a:picLocks noChangeAspect="1"/>
           </p:cNvPicPr>
@@ -16574,7 +16589,7 @@
       </p:pic>
       <p:sp>
         <p:nvSpPr>
-          <p:cNvPr id="5" name="Shape 2"/>
+          <p:cNvPr id="6" name="Shape 2"/>
           <p:cNvSpPr/>
           <p:nvPr/>
         </p:nvSpPr>
@@ -16596,7 +16611,7 @@
       </p:sp>
       <p:sp>
         <p:nvSpPr>
-          <p:cNvPr id="6" name="Text 3"/>
+          <p:cNvPr id="7" name="Text 3"/>
           <p:cNvSpPr txBox="1"/>
           <p:nvPr/>
         </p:nvSpPr>
@@ -16635,7 +16650,7 @@
       </p:sp>
       <p:pic>
         <p:nvPicPr>
-          <p:cNvPr id="7" name="Image 1" descr="/tmp/claude-0/-home-user-ensights/57acd941-a2c9-5cfa-90b7-9e5814c7c436/scratchpad/figures/quick_ratio.png">    </p:cNvPr>
+          <p:cNvPr id="8" name="Image 1" descr="/tmp/claude-0/-home-user-ensights/57acd941-a2c9-5cfa-90b7-9e5814c7c436/scratchpad/figures/quick_ratio.png">    </p:cNvPr>
           <p:cNvPicPr>
             <a:picLocks noChangeAspect="1"/>
           </p:cNvPicPr>
@@ -16658,7 +16673,7 @@
       </p:pic>
       <p:sp>
         <p:nvSpPr>
-          <p:cNvPr id="8" name="Shape 4"/>
+          <p:cNvPr id="9" name="Shape 4"/>
           <p:cNvSpPr/>
           <p:nvPr/>
         </p:nvSpPr>
@@ -16680,7 +16695,7 @@
       </p:sp>
       <p:sp>
         <p:nvSpPr>
-          <p:cNvPr id="9" name="Text 5"/>
+          <p:cNvPr id="10" name="Text 5"/>
           <p:cNvSpPr txBox="1"/>
           <p:nvPr/>
         </p:nvSpPr>
@@ -16719,7 +16734,7 @@
       </p:sp>
       <p:sp>
         <p:nvSpPr>
-          <p:cNvPr id="10" name="Text 6"/>
+          <p:cNvPr id="11" name="Text 6"/>
           <p:cNvSpPr txBox="1"/>
           <p:nvPr/>
         </p:nvSpPr>
@@ -16758,7 +16773,7 @@
       </p:sp>
       <p:sp>
         <p:nvSpPr>
-          <p:cNvPr id="11" name="Text 7"/>
+          <p:cNvPr id="12" name="Text 7"/>
           <p:cNvSpPr txBox="1"/>
           <p:nvPr/>
         </p:nvSpPr>
@@ -16829,7 +16844,7 @@
       </p:grpSpPr>
       <p:sp>
         <p:nvSpPr>
-          <p:cNvPr id="2" name="Text 0"/>
+          <p:cNvPr id="3" name="Text 0"/>
           <p:cNvSpPr txBox="1"/>
           <p:nvPr/>
         </p:nvSpPr>
@@ -16868,7 +16883,7 @@
       </p:sp>
       <p:sp>
         <p:nvSpPr>
-          <p:cNvPr id="3" name="Text 1"/>
+          <p:cNvPr id="4" name="Text 1"/>
           <p:cNvSpPr txBox="1"/>
           <p:nvPr/>
         </p:nvSpPr>
@@ -16907,7 +16922,7 @@
       </p:sp>
       <p:sp>
         <p:nvSpPr>
-          <p:cNvPr id="4" name="Shape 2"/>
+          <p:cNvPr id="5" name="Shape 2"/>
           <p:cNvSpPr/>
           <p:nvPr/>
         </p:nvSpPr>
@@ -16936,7 +16951,7 @@
       </p:sp>
       <p:sp>
         <p:nvSpPr>
-          <p:cNvPr id="5" name="Text 3"/>
+          <p:cNvPr id="6" name="Text 3"/>
           <p:cNvSpPr txBox="1"/>
           <p:nvPr/>
         </p:nvSpPr>
@@ -16975,7 +16990,7 @@
       </p:sp>
       <p:sp>
         <p:nvSpPr>
-          <p:cNvPr id="6" name="Text 4"/>
+          <p:cNvPr id="7" name="Text 4"/>
           <p:cNvSpPr txBox="1"/>
           <p:nvPr/>
         </p:nvSpPr>
@@ -17014,7 +17029,7 @@
       </p:sp>
       <p:sp>
         <p:nvSpPr>
-          <p:cNvPr id="7" name="Shape 5"/>
+          <p:cNvPr id="8" name="Shape 5"/>
           <p:cNvSpPr/>
           <p:nvPr/>
         </p:nvSpPr>
@@ -17043,7 +17058,7 @@
       </p:sp>
       <p:sp>
         <p:nvSpPr>
-          <p:cNvPr id="8" name="Text 6"/>
+          <p:cNvPr id="9" name="Text 6"/>
           <p:cNvSpPr txBox="1"/>
           <p:nvPr/>
         </p:nvSpPr>
@@ -17082,7 +17097,7 @@
       </p:sp>
       <p:sp>
         <p:nvSpPr>
-          <p:cNvPr id="9" name="Text 7"/>
+          <p:cNvPr id="10" name="Text 7"/>
           <p:cNvSpPr txBox="1"/>
           <p:nvPr/>
         </p:nvSpPr>
@@ -17121,7 +17136,7 @@
       </p:sp>
       <p:sp>
         <p:nvSpPr>
-          <p:cNvPr id="10" name="Shape 8"/>
+          <p:cNvPr id="11" name="Shape 8"/>
           <p:cNvSpPr/>
           <p:nvPr/>
         </p:nvSpPr>
@@ -17150,7 +17165,7 @@
       </p:sp>
       <p:sp>
         <p:nvSpPr>
-          <p:cNvPr id="11" name="Text 9"/>
+          <p:cNvPr id="12" name="Text 9"/>
           <p:cNvSpPr txBox="1"/>
           <p:nvPr/>
         </p:nvSpPr>
@@ -17189,7 +17204,7 @@
       </p:sp>
       <p:sp>
         <p:nvSpPr>
-          <p:cNvPr id="12" name="Text 10"/>
+          <p:cNvPr id="13" name="Text 10"/>
           <p:cNvSpPr txBox="1"/>
           <p:nvPr/>
         </p:nvSpPr>
@@ -17228,7 +17243,7 @@
       </p:sp>
       <p:sp>
         <p:nvSpPr>
-          <p:cNvPr id="13" name="Text 11"/>
+          <p:cNvPr id="14" name="Text 11"/>
           <p:cNvSpPr txBox="1"/>
           <p:nvPr/>
         </p:nvSpPr>
@@ -18125,7 +18140,7 @@
       </p:graphicFrame>
       <p:sp>
         <p:nvSpPr>
-          <p:cNvPr id="15" name="Shape 12"/>
+          <p:cNvPr id="16" name="Shape 12"/>
           <p:cNvSpPr/>
           <p:nvPr/>
         </p:nvSpPr>
@@ -18147,7 +18162,7 @@
       </p:sp>
       <p:sp>
         <p:nvSpPr>
-          <p:cNvPr id="16" name="Text 13"/>
+          <p:cNvPr id="17" name="Text 13"/>
           <p:cNvSpPr txBox="1"/>
           <p:nvPr/>
         </p:nvSpPr>
@@ -18241,7 +18256,7 @@
       </p:sp>
       <p:sp>
         <p:nvSpPr>
-          <p:cNvPr id="17" name="Text 14"/>
+          <p:cNvPr id="18" name="Text 14"/>
           <p:cNvSpPr txBox="1"/>
           <p:nvPr/>
         </p:nvSpPr>
@@ -18280,7 +18295,7 @@
       </p:sp>
       <p:sp>
         <p:nvSpPr>
-          <p:cNvPr id="18" name="Text 15"/>
+          <p:cNvPr id="19" name="Text 15"/>
           <p:cNvSpPr txBox="1"/>
           <p:nvPr/>
         </p:nvSpPr>
@@ -18351,7 +18366,7 @@
       </p:grpSpPr>
       <p:sp>
         <p:nvSpPr>
-          <p:cNvPr id="2" name="Text 0"/>
+          <p:cNvPr id="3" name="Text 0"/>
           <p:cNvSpPr txBox="1"/>
           <p:nvPr/>
         </p:nvSpPr>
@@ -18390,7 +18405,7 @@
       </p:sp>
       <p:sp>
         <p:nvSpPr>
-          <p:cNvPr id="3" name="Text 1"/>
+          <p:cNvPr id="4" name="Text 1"/>
           <p:cNvSpPr txBox="1"/>
           <p:nvPr/>
         </p:nvSpPr>
@@ -18429,7 +18444,7 @@
       </p:sp>
       <p:pic>
         <p:nvPicPr>
-          <p:cNvPr id="4" name="Image 0" descr="/tmp/claude-0/-home-user-ensights/57acd941-a2c9-5cfa-90b7-9e5814c7c436/scratchpad/figures/profitability_sensitivity.png">    </p:cNvPr>
+          <p:cNvPr id="5" name="Image 0" descr="/tmp/claude-0/-home-user-ensights/57acd941-a2c9-5cfa-90b7-9e5814c7c436/scratchpad/figures/profitability_sensitivity.png">    </p:cNvPr>
           <p:cNvPicPr>
             <a:picLocks noChangeAspect="1"/>
           </p:cNvPicPr>
@@ -18452,7 +18467,7 @@
       </p:pic>
       <p:sp>
         <p:nvSpPr>
-          <p:cNvPr id="5" name="Shape 2"/>
+          <p:cNvPr id="6" name="Shape 2"/>
           <p:cNvSpPr/>
           <p:nvPr/>
         </p:nvSpPr>
@@ -18474,7 +18489,7 @@
       </p:sp>
       <p:sp>
         <p:nvSpPr>
-          <p:cNvPr id="6" name="Text 3"/>
+          <p:cNvPr id="7" name="Text 3"/>
           <p:cNvSpPr txBox="1"/>
           <p:nvPr/>
         </p:nvSpPr>
@@ -20189,7 +20204,7 @@
       </p:graphicFrame>
       <p:sp>
         <p:nvSpPr>
-          <p:cNvPr id="8" name="Shape 4"/>
+          <p:cNvPr id="9" name="Shape 4"/>
           <p:cNvSpPr/>
           <p:nvPr/>
         </p:nvSpPr>
@@ -20211,7 +20226,7 @@
       </p:sp>
       <p:sp>
         <p:nvSpPr>
-          <p:cNvPr id="9" name="Text 5"/>
+          <p:cNvPr id="10" name="Text 5"/>
           <p:cNvSpPr txBox="1"/>
           <p:nvPr/>
         </p:nvSpPr>
@@ -20250,7 +20265,7 @@
       </p:sp>
       <p:sp>
         <p:nvSpPr>
-          <p:cNvPr id="10" name="Text 6"/>
+          <p:cNvPr id="11" name="Text 6"/>
           <p:cNvSpPr txBox="1"/>
           <p:nvPr/>
         </p:nvSpPr>
@@ -20289,7 +20304,7 @@
       </p:sp>
       <p:sp>
         <p:nvSpPr>
-          <p:cNvPr id="11" name="Text 7"/>
+          <p:cNvPr id="12" name="Text 7"/>
           <p:cNvSpPr txBox="1"/>
           <p:nvPr/>
         </p:nvSpPr>
@@ -20328,7 +20343,7 @@
       </p:sp>
       <p:sp>
         <p:nvSpPr>
-          <p:cNvPr id="12" name="Text 8"/>
+          <p:cNvPr id="13" name="Text 8"/>
           <p:cNvSpPr txBox="1"/>
           <p:nvPr/>
         </p:nvSpPr>
@@ -20399,7 +20414,7 @@
       </p:grpSpPr>
       <p:sp>
         <p:nvSpPr>
-          <p:cNvPr id="2" name="Shape 0"/>
+          <p:cNvPr id="3" name="Shape 0"/>
           <p:cNvSpPr/>
           <p:nvPr/>
         </p:nvSpPr>
@@ -20419,7 +20434,7 @@
       </p:sp>
       <p:sp>
         <p:nvSpPr>
-          <p:cNvPr id="3" name="Shape 1"/>
+          <p:cNvPr id="4" name="Shape 1"/>
           <p:cNvSpPr/>
           <p:nvPr/>
         </p:nvSpPr>
@@ -20444,7 +20459,7 @@
       </p:sp>
       <p:sp>
         <p:nvSpPr>
-          <p:cNvPr id="4" name="Text 2"/>
+          <p:cNvPr id="5" name="Text 2"/>
           <p:cNvSpPr txBox="1"/>
           <p:nvPr/>
         </p:nvSpPr>
@@ -20483,7 +20498,7 @@
       </p:sp>
       <p:sp>
         <p:nvSpPr>
-          <p:cNvPr id="5" name="Text 3"/>
+          <p:cNvPr id="6" name="Text 3"/>
           <p:cNvSpPr txBox="1"/>
           <p:nvPr/>
         </p:nvSpPr>
@@ -20522,7 +20537,7 @@
       </p:sp>
       <p:sp>
         <p:nvSpPr>
-          <p:cNvPr id="6" name="Text 4"/>
+          <p:cNvPr id="7" name="Text 4"/>
           <p:cNvSpPr txBox="1"/>
           <p:nvPr/>
         </p:nvSpPr>
@@ -20561,7 +20576,7 @@
       </p:sp>
       <p:sp>
         <p:nvSpPr>
-          <p:cNvPr id="7" name="Text 5"/>
+          <p:cNvPr id="8" name="Text 5"/>
           <p:cNvSpPr txBox="1"/>
           <p:nvPr/>
         </p:nvSpPr>
@@ -20600,7 +20615,7 @@
       </p:sp>
       <p:sp>
         <p:nvSpPr>
-          <p:cNvPr id="8" name="Text 6"/>
+          <p:cNvPr id="9" name="Text 6"/>
           <p:cNvSpPr txBox="1"/>
           <p:nvPr/>
         </p:nvSpPr>
@@ -20639,7 +20654,7 @@
       </p:sp>
       <p:sp>
         <p:nvSpPr>
-          <p:cNvPr id="9" name="Text 7"/>
+          <p:cNvPr id="10" name="Text 7"/>
           <p:cNvSpPr txBox="1"/>
           <p:nvPr/>
         </p:nvSpPr>
@@ -20710,7 +20725,7 @@
       </p:grpSpPr>
       <p:sp>
         <p:nvSpPr>
-          <p:cNvPr id="2" name="Text 0"/>
+          <p:cNvPr id="3" name="Text 0"/>
           <p:cNvSpPr txBox="1"/>
           <p:nvPr/>
         </p:nvSpPr>
@@ -20749,7 +20764,7 @@
       </p:sp>
       <p:sp>
         <p:nvSpPr>
-          <p:cNvPr id="3" name="Text 1"/>
+          <p:cNvPr id="4" name="Text 1"/>
           <p:cNvSpPr txBox="1"/>
           <p:nvPr/>
         </p:nvSpPr>
@@ -20788,7 +20803,7 @@
       </p:sp>
       <p:sp>
         <p:nvSpPr>
-          <p:cNvPr id="4" name="Text 2"/>
+          <p:cNvPr id="5" name="Text 2"/>
           <p:cNvSpPr txBox="1"/>
           <p:nvPr/>
         </p:nvSpPr>
@@ -20827,7 +20842,7 @@
       </p:sp>
       <p:sp>
         <p:nvSpPr>
-          <p:cNvPr id="5" name="Shape 3"/>
+          <p:cNvPr id="6" name="Shape 3"/>
           <p:cNvSpPr/>
           <p:nvPr/>
         </p:nvSpPr>
@@ -20849,7 +20864,7 @@
       </p:sp>
       <p:sp>
         <p:nvSpPr>
-          <p:cNvPr id="6" name="Text 4"/>
+          <p:cNvPr id="7" name="Text 4"/>
           <p:cNvSpPr txBox="1"/>
           <p:nvPr/>
         </p:nvSpPr>
@@ -20888,7 +20903,7 @@
       </p:sp>
       <p:sp>
         <p:nvSpPr>
-          <p:cNvPr id="7" name="Text 5"/>
+          <p:cNvPr id="8" name="Text 5"/>
           <p:cNvSpPr txBox="1"/>
           <p:nvPr/>
         </p:nvSpPr>
@@ -21255,7 +21270,7 @@
       </p:sp>
       <p:sp>
         <p:nvSpPr>
-          <p:cNvPr id="8" name="Shape 6"/>
+          <p:cNvPr id="9" name="Shape 6"/>
           <p:cNvSpPr/>
           <p:nvPr/>
         </p:nvSpPr>
@@ -21277,7 +21292,7 @@
       </p:sp>
       <p:sp>
         <p:nvSpPr>
-          <p:cNvPr id="9" name="Text 7"/>
+          <p:cNvPr id="10" name="Text 7"/>
           <p:cNvSpPr txBox="1"/>
           <p:nvPr/>
         </p:nvSpPr>
@@ -21316,7 +21331,7 @@
       </p:sp>
       <p:sp>
         <p:nvSpPr>
-          <p:cNvPr id="10" name="Text 8"/>
+          <p:cNvPr id="11" name="Text 8"/>
           <p:cNvSpPr txBox="1"/>
           <p:nvPr/>
         </p:nvSpPr>
@@ -21591,7 +21606,7 @@
       </p:sp>
       <p:sp>
         <p:nvSpPr>
-          <p:cNvPr id="11" name="Text 9"/>
+          <p:cNvPr id="12" name="Text 9"/>
           <p:cNvSpPr txBox="1"/>
           <p:nvPr/>
         </p:nvSpPr>
@@ -21630,7 +21645,7 @@
       </p:sp>
       <p:sp>
         <p:nvSpPr>
-          <p:cNvPr id="12" name="Text 10"/>
+          <p:cNvPr id="13" name="Text 10"/>
           <p:cNvSpPr txBox="1"/>
           <p:nvPr/>
         </p:nvSpPr>
@@ -21701,7 +21716,7 @@
       </p:grpSpPr>
       <p:sp>
         <p:nvSpPr>
-          <p:cNvPr id="2" name="Text 0"/>
+          <p:cNvPr id="3" name="Text 0"/>
           <p:cNvSpPr txBox="1"/>
           <p:nvPr/>
         </p:nvSpPr>
@@ -21740,7 +21755,7 @@
       </p:sp>
       <p:sp>
         <p:nvSpPr>
-          <p:cNvPr id="3" name="Text 1"/>
+          <p:cNvPr id="4" name="Text 1"/>
           <p:cNvSpPr txBox="1"/>
           <p:nvPr/>
         </p:nvSpPr>
@@ -21779,7 +21794,7 @@
       </p:sp>
       <p:sp>
         <p:nvSpPr>
-          <p:cNvPr id="4" name="Shape 2"/>
+          <p:cNvPr id="5" name="Shape 2"/>
           <p:cNvSpPr/>
           <p:nvPr/>
         </p:nvSpPr>
@@ -21801,7 +21816,7 @@
       </p:sp>
       <p:sp>
         <p:nvSpPr>
-          <p:cNvPr id="5" name="Text 3"/>
+          <p:cNvPr id="6" name="Text 3"/>
           <p:cNvSpPr txBox="1"/>
           <p:nvPr/>
         </p:nvSpPr>
@@ -21840,7 +21855,7 @@
       </p:sp>
       <p:sp>
         <p:nvSpPr>
-          <p:cNvPr id="6" name="Text 4"/>
+          <p:cNvPr id="7" name="Text 4"/>
           <p:cNvSpPr txBox="1"/>
           <p:nvPr/>
         </p:nvSpPr>
@@ -22069,7 +22084,7 @@
       </p:sp>
       <p:sp>
         <p:nvSpPr>
-          <p:cNvPr id="7" name="Shape 5"/>
+          <p:cNvPr id="8" name="Shape 5"/>
           <p:cNvSpPr/>
           <p:nvPr/>
         </p:nvSpPr>
@@ -22091,7 +22106,7 @@
       </p:sp>
       <p:sp>
         <p:nvSpPr>
-          <p:cNvPr id="8" name="Text 6"/>
+          <p:cNvPr id="9" name="Text 6"/>
           <p:cNvSpPr txBox="1"/>
           <p:nvPr/>
         </p:nvSpPr>
@@ -22130,7 +22145,7 @@
       </p:sp>
       <p:sp>
         <p:nvSpPr>
-          <p:cNvPr id="9" name="Text 7"/>
+          <p:cNvPr id="10" name="Text 7"/>
           <p:cNvSpPr txBox="1"/>
           <p:nvPr/>
         </p:nvSpPr>
@@ -22244,7 +22259,7 @@
       </p:sp>
       <p:sp>
         <p:nvSpPr>
-          <p:cNvPr id="10" name="Shape 8"/>
+          <p:cNvPr id="11" name="Shape 8"/>
           <p:cNvSpPr/>
           <p:nvPr/>
         </p:nvSpPr>
@@ -22266,7 +22281,7 @@
       </p:sp>
       <p:sp>
         <p:nvSpPr>
-          <p:cNvPr id="11" name="Text 9"/>
+          <p:cNvPr id="12" name="Text 9"/>
           <p:cNvSpPr txBox="1"/>
           <p:nvPr/>
         </p:nvSpPr>
@@ -22305,7 +22320,7 @@
       </p:sp>
       <p:sp>
         <p:nvSpPr>
-          <p:cNvPr id="12" name="Text 10"/>
+          <p:cNvPr id="13" name="Text 10"/>
           <p:cNvSpPr txBox="1"/>
           <p:nvPr/>
         </p:nvSpPr>
@@ -22672,7 +22687,7 @@
       </p:sp>
       <p:sp>
         <p:nvSpPr>
-          <p:cNvPr id="13" name="Shape 11"/>
+          <p:cNvPr id="14" name="Shape 11"/>
           <p:cNvSpPr/>
           <p:nvPr/>
         </p:nvSpPr>
@@ -22694,7 +22709,7 @@
       </p:sp>
       <p:sp>
         <p:nvSpPr>
-          <p:cNvPr id="14" name="Text 12"/>
+          <p:cNvPr id="15" name="Text 12"/>
           <p:cNvSpPr txBox="1"/>
           <p:nvPr/>
         </p:nvSpPr>
@@ -22733,7 +22748,7 @@
       </p:sp>
       <p:sp>
         <p:nvSpPr>
-          <p:cNvPr id="15" name="Text 13"/>
+          <p:cNvPr id="16" name="Text 13"/>
           <p:cNvSpPr txBox="1"/>
           <p:nvPr/>
         </p:nvSpPr>
@@ -22772,7 +22787,7 @@
       </p:sp>
       <p:sp>
         <p:nvSpPr>
-          <p:cNvPr id="16" name="Text 14"/>
+          <p:cNvPr id="17" name="Text 14"/>
           <p:cNvSpPr txBox="1"/>
           <p:nvPr/>
         </p:nvSpPr>
@@ -22843,7 +22858,7 @@
       </p:grpSpPr>
       <p:sp>
         <p:nvSpPr>
-          <p:cNvPr id="2" name="Text 0"/>
+          <p:cNvPr id="3" name="Text 0"/>
           <p:cNvSpPr txBox="1"/>
           <p:nvPr/>
         </p:nvSpPr>
@@ -22882,7 +22897,7 @@
       </p:sp>
       <p:sp>
         <p:nvSpPr>
-          <p:cNvPr id="3" name="Text 1"/>
+          <p:cNvPr id="4" name="Text 1"/>
           <p:cNvSpPr txBox="1"/>
           <p:nvPr/>
         </p:nvSpPr>
@@ -22921,7 +22936,7 @@
       </p:sp>
       <p:sp>
         <p:nvSpPr>
-          <p:cNvPr id="4" name="Shape 2"/>
+          <p:cNvPr id="5" name="Shape 2"/>
           <p:cNvSpPr/>
           <p:nvPr/>
         </p:nvSpPr>
@@ -22945,7 +22960,7 @@
       </p:sp>
       <p:pic>
         <p:nvPicPr>
-          <p:cNvPr id="5" name="Image 0" descr="/home/user/ensights/documents/screenshots/metabase-dashboard.jpg">    </p:cNvPr>
+          <p:cNvPr id="6" name="Image 0" descr="/home/user/ensights/documents/screenshots/metabase-dashboard.jpg">    </p:cNvPr>
           <p:cNvPicPr>
             <a:picLocks noChangeAspect="1"/>
           </p:cNvPicPr>
@@ -22968,7 +22983,7 @@
       </p:pic>
       <p:sp>
         <p:nvSpPr>
-          <p:cNvPr id="6" name="Shape 3"/>
+          <p:cNvPr id="7" name="Shape 3"/>
           <p:cNvSpPr/>
           <p:nvPr/>
         </p:nvSpPr>
@@ -22990,7 +23005,7 @@
       </p:sp>
       <p:sp>
         <p:nvSpPr>
-          <p:cNvPr id="7" name="Text 4"/>
+          <p:cNvPr id="8" name="Text 4"/>
           <p:cNvSpPr txBox="1"/>
           <p:nvPr/>
         </p:nvSpPr>
@@ -23029,7 +23044,7 @@
       </p:sp>
       <p:sp>
         <p:nvSpPr>
-          <p:cNvPr id="8" name="Text 5"/>
+          <p:cNvPr id="9" name="Text 5"/>
           <p:cNvSpPr txBox="1"/>
           <p:nvPr/>
         </p:nvSpPr>
@@ -23100,7 +23115,7 @@
       </p:grpSpPr>
       <p:sp>
         <p:nvSpPr>
-          <p:cNvPr id="2" name="Shape 0"/>
+          <p:cNvPr id="3" name="Shape 0"/>
           <p:cNvSpPr/>
           <p:nvPr/>
         </p:nvSpPr>
@@ -23120,7 +23135,7 @@
       </p:sp>
       <p:sp>
         <p:nvSpPr>
-          <p:cNvPr id="3" name="Shape 1"/>
+          <p:cNvPr id="4" name="Shape 1"/>
           <p:cNvSpPr/>
           <p:nvPr/>
         </p:nvSpPr>
@@ -23145,7 +23160,7 @@
       </p:sp>
       <p:sp>
         <p:nvSpPr>
-          <p:cNvPr id="4" name="Text 2"/>
+          <p:cNvPr id="5" name="Text 2"/>
           <p:cNvSpPr txBox="1"/>
           <p:nvPr/>
         </p:nvSpPr>
@@ -23184,7 +23199,7 @@
       </p:sp>
       <p:sp>
         <p:nvSpPr>
-          <p:cNvPr id="5" name="Text 3"/>
+          <p:cNvPr id="6" name="Text 3"/>
           <p:cNvSpPr txBox="1"/>
           <p:nvPr/>
         </p:nvSpPr>
@@ -23223,7 +23238,7 @@
       </p:sp>
       <p:sp>
         <p:nvSpPr>
-          <p:cNvPr id="6" name="Text 4"/>
+          <p:cNvPr id="7" name="Text 4"/>
           <p:cNvSpPr txBox="1"/>
           <p:nvPr/>
         </p:nvSpPr>
@@ -23262,7 +23277,7 @@
       </p:sp>
       <p:sp>
         <p:nvSpPr>
-          <p:cNvPr id="7" name="Text 5"/>
+          <p:cNvPr id="8" name="Text 5"/>
           <p:cNvSpPr txBox="1"/>
           <p:nvPr/>
         </p:nvSpPr>
@@ -23301,7 +23316,7 @@
       </p:sp>
       <p:sp>
         <p:nvSpPr>
-          <p:cNvPr id="8" name="Text 6"/>
+          <p:cNvPr id="9" name="Text 6"/>
           <p:cNvSpPr txBox="1"/>
           <p:nvPr/>
         </p:nvSpPr>
@@ -23340,7 +23355,7 @@
       </p:sp>
       <p:sp>
         <p:nvSpPr>
-          <p:cNvPr id="9" name="Text 7"/>
+          <p:cNvPr id="10" name="Text 7"/>
           <p:cNvSpPr txBox="1"/>
           <p:nvPr/>
         </p:nvSpPr>
@@ -23411,7 +23426,7 @@
       </p:grpSpPr>
       <p:sp>
         <p:nvSpPr>
-          <p:cNvPr id="2" name="Text 0"/>
+          <p:cNvPr id="3" name="Text 0"/>
           <p:cNvSpPr txBox="1"/>
           <p:nvPr/>
         </p:nvSpPr>
@@ -23450,7 +23465,7 @@
       </p:sp>
       <p:sp>
         <p:nvSpPr>
-          <p:cNvPr id="3" name="Text 1"/>
+          <p:cNvPr id="4" name="Text 1"/>
           <p:cNvSpPr txBox="1"/>
           <p:nvPr/>
         </p:nvSpPr>
@@ -23489,7 +23504,7 @@
       </p:sp>
       <p:pic>
         <p:nvPicPr>
-          <p:cNvPr id="4" name="Image 0" descr="/home/user/ensights/documents/screenshots/metabase-association-rules.jpg">    </p:cNvPr>
+          <p:cNvPr id="5" name="Image 0" descr="/home/user/ensights/documents/screenshots/metabase-association-rules.jpg">    </p:cNvPr>
           <p:cNvPicPr>
             <a:picLocks noChangeAspect="1"/>
           </p:cNvPicPr>
@@ -23512,7 +23527,7 @@
       </p:pic>
       <p:sp>
         <p:nvSpPr>
-          <p:cNvPr id="5" name="Shape 2"/>
+          <p:cNvPr id="6" name="Shape 2"/>
           <p:cNvSpPr/>
           <p:nvPr/>
         </p:nvSpPr>
@@ -23534,7 +23549,7 @@
       </p:sp>
       <p:sp>
         <p:nvSpPr>
-          <p:cNvPr id="6" name="Text 3"/>
+          <p:cNvPr id="7" name="Text 3"/>
           <p:cNvSpPr txBox="1"/>
           <p:nvPr/>
         </p:nvSpPr>
@@ -23573,7 +23588,7 @@
       </p:sp>
       <p:pic>
         <p:nvPicPr>
-          <p:cNvPr id="7" name="Image 1" descr="/home/user/ensights/documents/screenshots/swagger-try.jpg">    </p:cNvPr>
+          <p:cNvPr id="8" name="Image 1" descr="/home/user/ensights/documents/screenshots/swagger-try.jpg">    </p:cNvPr>
           <p:cNvPicPr>
             <a:picLocks noChangeAspect="1"/>
           </p:cNvPicPr>
@@ -23596,7 +23611,7 @@
       </p:pic>
       <p:sp>
         <p:nvSpPr>
-          <p:cNvPr id="8" name="Shape 4"/>
+          <p:cNvPr id="9" name="Shape 4"/>
           <p:cNvSpPr/>
           <p:nvPr/>
         </p:nvSpPr>
@@ -23618,7 +23633,7 @@
       </p:sp>
       <p:sp>
         <p:nvSpPr>
-          <p:cNvPr id="9" name="Text 5"/>
+          <p:cNvPr id="10" name="Text 5"/>
           <p:cNvSpPr txBox="1"/>
           <p:nvPr/>
         </p:nvSpPr>
@@ -23657,7 +23672,7 @@
       </p:sp>
       <p:sp>
         <p:nvSpPr>
-          <p:cNvPr id="10" name="Text 6"/>
+          <p:cNvPr id="11" name="Text 6"/>
           <p:cNvSpPr txBox="1"/>
           <p:nvPr/>
         </p:nvSpPr>
@@ -23696,7 +23711,7 @@
       </p:sp>
       <p:sp>
         <p:nvSpPr>
-          <p:cNvPr id="11" name="Text 7"/>
+          <p:cNvPr id="12" name="Text 7"/>
           <p:cNvSpPr txBox="1"/>
           <p:nvPr/>
         </p:nvSpPr>
@@ -23767,7 +23782,7 @@
       </p:grpSpPr>
       <p:sp>
         <p:nvSpPr>
-          <p:cNvPr id="2" name="Shape 0"/>
+          <p:cNvPr id="3" name="Shape 0"/>
           <p:cNvSpPr/>
           <p:nvPr/>
         </p:nvSpPr>
@@ -23787,7 +23802,7 @@
       </p:sp>
       <p:sp>
         <p:nvSpPr>
-          <p:cNvPr id="3" name="Shape 1"/>
+          <p:cNvPr id="4" name="Shape 1"/>
           <p:cNvSpPr/>
           <p:nvPr/>
         </p:nvSpPr>
@@ -23812,7 +23827,7 @@
       </p:sp>
       <p:sp>
         <p:nvSpPr>
-          <p:cNvPr id="4" name="Text 2"/>
+          <p:cNvPr id="5" name="Text 2"/>
           <p:cNvSpPr txBox="1"/>
           <p:nvPr/>
         </p:nvSpPr>
@@ -23851,7 +23866,7 @@
       </p:sp>
       <p:sp>
         <p:nvSpPr>
-          <p:cNvPr id="5" name="Text 3"/>
+          <p:cNvPr id="6" name="Text 3"/>
           <p:cNvSpPr txBox="1"/>
           <p:nvPr/>
         </p:nvSpPr>
@@ -23890,7 +23905,7 @@
       </p:sp>
       <p:sp>
         <p:nvSpPr>
-          <p:cNvPr id="6" name="Text 4"/>
+          <p:cNvPr id="7" name="Text 4"/>
           <p:cNvSpPr txBox="1"/>
           <p:nvPr/>
         </p:nvSpPr>
@@ -23929,7 +23944,7 @@
       </p:sp>
       <p:sp>
         <p:nvSpPr>
-          <p:cNvPr id="7" name="Text 5"/>
+          <p:cNvPr id="8" name="Text 5"/>
           <p:cNvSpPr txBox="1"/>
           <p:nvPr/>
         </p:nvSpPr>
@@ -23968,7 +23983,7 @@
       </p:sp>
       <p:sp>
         <p:nvSpPr>
-          <p:cNvPr id="8" name="Text 6"/>
+          <p:cNvPr id="9" name="Text 6"/>
           <p:cNvSpPr txBox="1"/>
           <p:nvPr/>
         </p:nvSpPr>
@@ -24007,7 +24022,7 @@
       </p:sp>
       <p:sp>
         <p:nvSpPr>
-          <p:cNvPr id="9" name="Text 7"/>
+          <p:cNvPr id="10" name="Text 7"/>
           <p:cNvSpPr txBox="1"/>
           <p:nvPr/>
         </p:nvSpPr>
@@ -24078,7 +24093,7 @@
       </p:grpSpPr>
       <p:sp>
         <p:nvSpPr>
-          <p:cNvPr id="2" name="Text 0"/>
+          <p:cNvPr id="3" name="Text 0"/>
           <p:cNvSpPr txBox="1"/>
           <p:nvPr/>
         </p:nvSpPr>
@@ -24117,7 +24132,7 @@
       </p:sp>
       <p:sp>
         <p:nvSpPr>
-          <p:cNvPr id="3" name="Text 1"/>
+          <p:cNvPr id="4" name="Text 1"/>
           <p:cNvSpPr txBox="1"/>
           <p:nvPr/>
         </p:nvSpPr>
@@ -24156,7 +24171,7 @@
       </p:sp>
       <p:sp>
         <p:nvSpPr>
-          <p:cNvPr id="4" name="Text 2"/>
+          <p:cNvPr id="5" name="Text 2"/>
           <p:cNvSpPr txBox="1"/>
           <p:nvPr/>
         </p:nvSpPr>
@@ -24322,7 +24337,7 @@
       </p:sp>
       <p:sp>
         <p:nvSpPr>
-          <p:cNvPr id="5" name="Text 3"/>
+          <p:cNvPr id="6" name="Text 3"/>
           <p:cNvSpPr txBox="1"/>
           <p:nvPr/>
         </p:nvSpPr>
@@ -24361,7 +24376,7 @@
       </p:sp>
       <p:sp>
         <p:nvSpPr>
-          <p:cNvPr id="6" name="Text 4"/>
+          <p:cNvPr id="7" name="Text 4"/>
           <p:cNvSpPr txBox="1"/>
           <p:nvPr/>
         </p:nvSpPr>
@@ -24432,7 +24447,7 @@
       </p:grpSpPr>
       <p:sp>
         <p:nvSpPr>
-          <p:cNvPr id="2" name="Text 0"/>
+          <p:cNvPr id="3" name="Text 0"/>
           <p:cNvSpPr txBox="1"/>
           <p:nvPr/>
         </p:nvSpPr>
@@ -24471,7 +24486,7 @@
       </p:sp>
       <p:sp>
         <p:nvSpPr>
-          <p:cNvPr id="3" name="Text 1"/>
+          <p:cNvPr id="4" name="Text 1"/>
           <p:cNvSpPr txBox="1"/>
           <p:nvPr/>
         </p:nvSpPr>
@@ -24510,7 +24525,7 @@
       </p:sp>
       <p:sp>
         <p:nvSpPr>
-          <p:cNvPr id="4" name="Shape 2"/>
+          <p:cNvPr id="5" name="Shape 2"/>
           <p:cNvSpPr/>
           <p:nvPr/>
         </p:nvSpPr>
@@ -24532,7 +24547,7 @@
       </p:sp>
       <p:sp>
         <p:nvSpPr>
-          <p:cNvPr id="5" name="Text 3"/>
+          <p:cNvPr id="6" name="Text 3"/>
           <p:cNvSpPr txBox="1"/>
           <p:nvPr/>
         </p:nvSpPr>
@@ -24571,7 +24586,7 @@
       </p:sp>
       <p:sp>
         <p:nvSpPr>
-          <p:cNvPr id="6" name="Text 4"/>
+          <p:cNvPr id="7" name="Text 4"/>
           <p:cNvSpPr txBox="1"/>
           <p:nvPr/>
         </p:nvSpPr>
@@ -24665,7 +24680,7 @@
       </p:sp>
       <p:sp>
         <p:nvSpPr>
-          <p:cNvPr id="7" name="Shape 5"/>
+          <p:cNvPr id="8" name="Shape 5"/>
           <p:cNvSpPr/>
           <p:nvPr/>
         </p:nvSpPr>
@@ -24687,7 +24702,7 @@
       </p:sp>
       <p:sp>
         <p:nvSpPr>
-          <p:cNvPr id="8" name="Text 6"/>
+          <p:cNvPr id="9" name="Text 6"/>
           <p:cNvSpPr txBox="1"/>
           <p:nvPr/>
         </p:nvSpPr>
@@ -24726,7 +24741,7 @@
       </p:sp>
       <p:sp>
         <p:nvSpPr>
-          <p:cNvPr id="9" name="Text 7"/>
+          <p:cNvPr id="10" name="Text 7"/>
           <p:cNvSpPr txBox="1"/>
           <p:nvPr/>
         </p:nvSpPr>
@@ -24820,7 +24835,7 @@
       </p:sp>
       <p:sp>
         <p:nvSpPr>
-          <p:cNvPr id="10" name="Text 8"/>
+          <p:cNvPr id="11" name="Text 8"/>
           <p:cNvSpPr txBox="1"/>
           <p:nvPr/>
         </p:nvSpPr>
@@ -24859,7 +24874,7 @@
       </p:sp>
       <p:sp>
         <p:nvSpPr>
-          <p:cNvPr id="11" name="Text 9"/>
+          <p:cNvPr id="12" name="Text 9"/>
           <p:cNvSpPr txBox="1"/>
           <p:nvPr/>
         </p:nvSpPr>
@@ -24930,7 +24945,7 @@
       </p:grpSpPr>
       <p:sp>
         <p:nvSpPr>
-          <p:cNvPr id="2" name="Text 0"/>
+          <p:cNvPr id="3" name="Text 0"/>
           <p:cNvSpPr txBox="1"/>
           <p:nvPr/>
         </p:nvSpPr>
@@ -24969,7 +24984,7 @@
       </p:sp>
       <p:sp>
         <p:nvSpPr>
-          <p:cNvPr id="3" name="Text 1"/>
+          <p:cNvPr id="4" name="Text 1"/>
           <p:cNvSpPr txBox="1"/>
           <p:nvPr/>
         </p:nvSpPr>
@@ -25008,7 +25023,7 @@
       </p:sp>
       <p:sp>
         <p:nvSpPr>
-          <p:cNvPr id="4" name="Shape 2"/>
+          <p:cNvPr id="5" name="Shape 2"/>
           <p:cNvSpPr/>
           <p:nvPr/>
         </p:nvSpPr>
@@ -25030,7 +25045,7 @@
       </p:sp>
       <p:sp>
         <p:nvSpPr>
-          <p:cNvPr id="5" name="Text 3"/>
+          <p:cNvPr id="6" name="Text 3"/>
           <p:cNvSpPr txBox="1"/>
           <p:nvPr/>
         </p:nvSpPr>
@@ -25083,7 +25098,7 @@
       </p:sp>
       <p:sp>
         <p:nvSpPr>
-          <p:cNvPr id="6" name="Shape 4"/>
+          <p:cNvPr id="7" name="Shape 4"/>
           <p:cNvSpPr/>
           <p:nvPr/>
         </p:nvSpPr>
@@ -25105,7 +25120,7 @@
       </p:sp>
       <p:sp>
         <p:nvSpPr>
-          <p:cNvPr id="7" name="Text 5"/>
+          <p:cNvPr id="8" name="Text 5"/>
           <p:cNvSpPr txBox="1"/>
           <p:nvPr/>
         </p:nvSpPr>
@@ -25158,7 +25173,7 @@
       </p:sp>
       <p:sp>
         <p:nvSpPr>
-          <p:cNvPr id="8" name="Shape 6"/>
+          <p:cNvPr id="9" name="Shape 6"/>
           <p:cNvSpPr/>
           <p:nvPr/>
         </p:nvSpPr>
@@ -25180,7 +25195,7 @@
       </p:sp>
       <p:sp>
         <p:nvSpPr>
-          <p:cNvPr id="9" name="Text 7"/>
+          <p:cNvPr id="10" name="Text 7"/>
           <p:cNvSpPr txBox="1"/>
           <p:nvPr/>
         </p:nvSpPr>
@@ -25233,7 +25248,7 @@
       </p:sp>
       <p:sp>
         <p:nvSpPr>
-          <p:cNvPr id="10" name="Shape 8"/>
+          <p:cNvPr id="11" name="Shape 8"/>
           <p:cNvSpPr/>
           <p:nvPr/>
         </p:nvSpPr>
@@ -25255,7 +25270,7 @@
       </p:sp>
       <p:sp>
         <p:nvSpPr>
-          <p:cNvPr id="11" name="Text 9"/>
+          <p:cNvPr id="12" name="Text 9"/>
           <p:cNvSpPr txBox="1"/>
           <p:nvPr/>
         </p:nvSpPr>
@@ -25308,7 +25323,7 @@
       </p:sp>
       <p:sp>
         <p:nvSpPr>
-          <p:cNvPr id="12" name="Shape 10"/>
+          <p:cNvPr id="13" name="Shape 10"/>
           <p:cNvSpPr/>
           <p:nvPr/>
         </p:nvSpPr>
@@ -25330,7 +25345,7 @@
       </p:sp>
       <p:sp>
         <p:nvSpPr>
-          <p:cNvPr id="13" name="Text 11"/>
+          <p:cNvPr id="14" name="Text 11"/>
           <p:cNvSpPr txBox="1"/>
           <p:nvPr/>
         </p:nvSpPr>
@@ -25383,7 +25398,7 @@
       </p:sp>
       <p:sp>
         <p:nvSpPr>
-          <p:cNvPr id="14" name="Text 12"/>
+          <p:cNvPr id="15" name="Text 12"/>
           <p:cNvSpPr txBox="1"/>
           <p:nvPr/>
         </p:nvSpPr>
@@ -25422,7 +25437,7 @@
       </p:sp>
       <p:sp>
         <p:nvSpPr>
-          <p:cNvPr id="15" name="Text 13"/>
+          <p:cNvPr id="16" name="Text 13"/>
           <p:cNvSpPr txBox="1"/>
           <p:nvPr/>
         </p:nvSpPr>
@@ -25493,7 +25508,7 @@
       </p:grpSpPr>
       <p:sp>
         <p:nvSpPr>
-          <p:cNvPr id="2" name="Text 0"/>
+          <p:cNvPr id="3" name="Text 0"/>
           <p:cNvSpPr txBox="1"/>
           <p:nvPr/>
         </p:nvSpPr>
@@ -25532,7 +25547,7 @@
       </p:sp>
       <p:sp>
         <p:nvSpPr>
-          <p:cNvPr id="3" name="Text 1"/>
+          <p:cNvPr id="4" name="Text 1"/>
           <p:cNvSpPr txBox="1"/>
           <p:nvPr/>
         </p:nvSpPr>
@@ -25571,7 +25586,7 @@
       </p:sp>
       <p:sp>
         <p:nvSpPr>
-          <p:cNvPr id="4" name="Shape 2"/>
+          <p:cNvPr id="5" name="Shape 2"/>
           <p:cNvSpPr/>
           <p:nvPr/>
         </p:nvSpPr>
@@ -25593,7 +25608,7 @@
       </p:sp>
       <p:sp>
         <p:nvSpPr>
-          <p:cNvPr id="5" name="Text 3"/>
+          <p:cNvPr id="6" name="Text 3"/>
           <p:cNvSpPr txBox="1"/>
           <p:nvPr/>
         </p:nvSpPr>
@@ -25646,7 +25661,7 @@
       </p:sp>
       <p:sp>
         <p:nvSpPr>
-          <p:cNvPr id="6" name="Shape 4"/>
+          <p:cNvPr id="7" name="Shape 4"/>
           <p:cNvSpPr/>
           <p:nvPr/>
         </p:nvSpPr>
@@ -25668,7 +25683,7 @@
       </p:sp>
       <p:sp>
         <p:nvSpPr>
-          <p:cNvPr id="7" name="Text 5"/>
+          <p:cNvPr id="8" name="Text 5"/>
           <p:cNvSpPr txBox="1"/>
           <p:nvPr/>
         </p:nvSpPr>
@@ -25721,7 +25736,7 @@
       </p:sp>
       <p:sp>
         <p:nvSpPr>
-          <p:cNvPr id="8" name="Shape 6"/>
+          <p:cNvPr id="9" name="Shape 6"/>
           <p:cNvSpPr/>
           <p:nvPr/>
         </p:nvSpPr>
@@ -25743,7 +25758,7 @@
       </p:sp>
       <p:sp>
         <p:nvSpPr>
-          <p:cNvPr id="9" name="Text 7"/>
+          <p:cNvPr id="10" name="Text 7"/>
           <p:cNvSpPr txBox="1"/>
           <p:nvPr/>
         </p:nvSpPr>
@@ -25796,7 +25811,7 @@
       </p:sp>
       <p:sp>
         <p:nvSpPr>
-          <p:cNvPr id="10" name="Shape 8"/>
+          <p:cNvPr id="11" name="Shape 8"/>
           <p:cNvSpPr/>
           <p:nvPr/>
         </p:nvSpPr>
@@ -25818,7 +25833,7 @@
       </p:sp>
       <p:sp>
         <p:nvSpPr>
-          <p:cNvPr id="11" name="Text 9"/>
+          <p:cNvPr id="12" name="Text 9"/>
           <p:cNvSpPr txBox="1"/>
           <p:nvPr/>
         </p:nvSpPr>
@@ -25871,7 +25886,7 @@
       </p:sp>
       <p:sp>
         <p:nvSpPr>
-          <p:cNvPr id="12" name="Shape 10"/>
+          <p:cNvPr id="13" name="Shape 10"/>
           <p:cNvSpPr/>
           <p:nvPr/>
         </p:nvSpPr>
@@ -25893,7 +25908,7 @@
       </p:sp>
       <p:sp>
         <p:nvSpPr>
-          <p:cNvPr id="13" name="Text 11"/>
+          <p:cNvPr id="14" name="Text 11"/>
           <p:cNvSpPr txBox="1"/>
           <p:nvPr/>
         </p:nvSpPr>
@@ -25946,7 +25961,7 @@
       </p:sp>
       <p:sp>
         <p:nvSpPr>
-          <p:cNvPr id="14" name="Text 12"/>
+          <p:cNvPr id="15" name="Text 12"/>
           <p:cNvSpPr txBox="1"/>
           <p:nvPr/>
         </p:nvSpPr>
@@ -25985,7 +26000,7 @@
       </p:sp>
       <p:sp>
         <p:nvSpPr>
-          <p:cNvPr id="15" name="Text 13"/>
+          <p:cNvPr id="16" name="Text 13"/>
           <p:cNvSpPr txBox="1"/>
           <p:nvPr/>
         </p:nvSpPr>
@@ -26056,7 +26071,7 @@
       </p:grpSpPr>
       <p:sp>
         <p:nvSpPr>
-          <p:cNvPr id="2" name="Shape 0"/>
+          <p:cNvPr id="3" name="Shape 0"/>
           <p:cNvSpPr/>
           <p:nvPr/>
         </p:nvSpPr>
@@ -26076,7 +26091,7 @@
       </p:sp>
       <p:sp>
         <p:nvSpPr>
-          <p:cNvPr id="3" name="Shape 1"/>
+          <p:cNvPr id="4" name="Shape 1"/>
           <p:cNvSpPr/>
           <p:nvPr/>
         </p:nvSpPr>
@@ -26096,7 +26111,7 @@
       </p:sp>
       <p:sp>
         <p:nvSpPr>
-          <p:cNvPr id="4" name="Text 2"/>
+          <p:cNvPr id="5" name="Text 2"/>
           <p:cNvSpPr txBox="1"/>
           <p:nvPr/>
         </p:nvSpPr>
@@ -26135,7 +26150,7 @@
       </p:sp>
       <p:sp>
         <p:nvSpPr>
-          <p:cNvPr id="5" name="Text 3"/>
+          <p:cNvPr id="6" name="Text 3"/>
           <p:cNvSpPr txBox="1"/>
           <p:nvPr/>
         </p:nvSpPr>
@@ -26197,7 +26212,7 @@
       </p:sp>
       <p:sp>
         <p:nvSpPr>
-          <p:cNvPr id="6" name="Text 4"/>
+          <p:cNvPr id="7" name="Text 4"/>
           <p:cNvSpPr txBox="1"/>
           <p:nvPr/>
         </p:nvSpPr>
@@ -26236,7 +26251,7 @@
       </p:sp>
       <p:sp>
         <p:nvSpPr>
-          <p:cNvPr id="7" name="Text 5"/>
+          <p:cNvPr id="8" name="Text 5"/>
           <p:cNvSpPr txBox="1"/>
           <p:nvPr/>
         </p:nvSpPr>
@@ -26275,7 +26290,7 @@
       </p:sp>
       <p:sp>
         <p:nvSpPr>
-          <p:cNvPr id="8" name="Text 6"/>
+          <p:cNvPr id="9" name="Text 6"/>
           <p:cNvSpPr txBox="1"/>
           <p:nvPr/>
         </p:nvSpPr>
@@ -26314,7 +26329,7 @@
       </p:sp>
       <p:sp>
         <p:nvSpPr>
-          <p:cNvPr id="9" name="Text 7"/>
+          <p:cNvPr id="10" name="Text 7"/>
           <p:cNvSpPr txBox="1"/>
           <p:nvPr/>
         </p:nvSpPr>
@@ -26385,7 +26400,7 @@
       </p:grpSpPr>
       <p:sp>
         <p:nvSpPr>
-          <p:cNvPr id="2" name="Text 0"/>
+          <p:cNvPr id="3" name="Text 0"/>
           <p:cNvSpPr txBox="1"/>
           <p:nvPr/>
         </p:nvSpPr>
@@ -26424,7 +26439,7 @@
       </p:sp>
       <p:sp>
         <p:nvSpPr>
-          <p:cNvPr id="3" name="Text 1"/>
+          <p:cNvPr id="4" name="Text 1"/>
           <p:cNvSpPr txBox="1"/>
           <p:nvPr/>
         </p:nvSpPr>
@@ -26463,7 +26478,7 @@
       </p:sp>
       <p:sp>
         <p:nvSpPr>
-          <p:cNvPr id="4" name="Text 2"/>
+          <p:cNvPr id="5" name="Text 2"/>
           <p:cNvSpPr txBox="1"/>
           <p:nvPr/>
         </p:nvSpPr>
@@ -26557,7 +26572,7 @@
       </p:sp>
       <p:sp>
         <p:nvSpPr>
-          <p:cNvPr id="5" name="Shape 3"/>
+          <p:cNvPr id="6" name="Shape 3"/>
           <p:cNvSpPr/>
           <p:nvPr/>
         </p:nvSpPr>
@@ -26579,7 +26594,7 @@
       </p:sp>
       <p:sp>
         <p:nvSpPr>
-          <p:cNvPr id="6" name="Text 4"/>
+          <p:cNvPr id="7" name="Text 4"/>
           <p:cNvSpPr txBox="1"/>
           <p:nvPr/>
         </p:nvSpPr>
@@ -26618,7 +26633,7 @@
       </p:sp>
       <p:sp>
         <p:nvSpPr>
-          <p:cNvPr id="7" name="Text 5"/>
+          <p:cNvPr id="8" name="Text 5"/>
           <p:cNvSpPr txBox="1"/>
           <p:nvPr/>
         </p:nvSpPr>
@@ -26657,7 +26672,7 @@
       </p:sp>
       <p:sp>
         <p:nvSpPr>
-          <p:cNvPr id="8" name="Shape 6"/>
+          <p:cNvPr id="9" name="Shape 6"/>
           <p:cNvSpPr/>
           <p:nvPr/>
         </p:nvSpPr>
@@ -26684,7 +26699,7 @@
       </p:sp>
       <p:sp>
         <p:nvSpPr>
-          <p:cNvPr id="9" name="Text 7"/>
+          <p:cNvPr id="10" name="Text 7"/>
           <p:cNvSpPr txBox="1"/>
           <p:nvPr/>
         </p:nvSpPr>
@@ -26723,7 +26738,7 @@
       </p:sp>
       <p:sp>
         <p:nvSpPr>
-          <p:cNvPr id="10" name="Text 8"/>
+          <p:cNvPr id="11" name="Text 8"/>
           <p:cNvSpPr txBox="1"/>
           <p:nvPr/>
         </p:nvSpPr>
@@ -26762,7 +26777,7 @@
       </p:sp>
       <p:sp>
         <p:nvSpPr>
-          <p:cNvPr id="11" name="Shape 9"/>
+          <p:cNvPr id="12" name="Shape 9"/>
           <p:cNvSpPr/>
           <p:nvPr/>
         </p:nvSpPr>
@@ -26784,7 +26799,7 @@
       </p:sp>
       <p:sp>
         <p:nvSpPr>
-          <p:cNvPr id="12" name="Text 10"/>
+          <p:cNvPr id="13" name="Text 10"/>
           <p:cNvSpPr txBox="1"/>
           <p:nvPr/>
         </p:nvSpPr>
@@ -26823,7 +26838,7 @@
       </p:sp>
       <p:sp>
         <p:nvSpPr>
-          <p:cNvPr id="13" name="Text 11"/>
+          <p:cNvPr id="14" name="Text 11"/>
           <p:cNvSpPr txBox="1"/>
           <p:nvPr/>
         </p:nvSpPr>
@@ -26862,7 +26877,7 @@
       </p:sp>
       <p:sp>
         <p:nvSpPr>
-          <p:cNvPr id="14" name="Text 12"/>
+          <p:cNvPr id="15" name="Text 12"/>
           <p:cNvSpPr txBox="1"/>
           <p:nvPr/>
         </p:nvSpPr>
@@ -26901,7 +26916,7 @@
       </p:sp>
       <p:sp>
         <p:nvSpPr>
-          <p:cNvPr id="15" name="Text 13"/>
+          <p:cNvPr id="16" name="Text 13"/>
           <p:cNvSpPr txBox="1"/>
           <p:nvPr/>
         </p:nvSpPr>
@@ -26972,7 +26987,7 @@
       </p:grpSpPr>
       <p:sp>
         <p:nvSpPr>
-          <p:cNvPr id="2" name="Text 0"/>
+          <p:cNvPr id="3" name="Text 0"/>
           <p:cNvSpPr txBox="1"/>
           <p:nvPr/>
         </p:nvSpPr>
@@ -27011,7 +27026,7 @@
       </p:sp>
       <p:sp>
         <p:nvSpPr>
-          <p:cNvPr id="3" name="Text 1"/>
+          <p:cNvPr id="4" name="Text 1"/>
           <p:cNvSpPr txBox="1"/>
           <p:nvPr/>
         </p:nvSpPr>
@@ -27050,7 +27065,7 @@
       </p:sp>
       <p:sp>
         <p:nvSpPr>
-          <p:cNvPr id="4" name="Shape 2"/>
+          <p:cNvPr id="5" name="Shape 2"/>
           <p:cNvSpPr/>
           <p:nvPr/>
         </p:nvSpPr>
@@ -27072,7 +27087,7 @@
       </p:sp>
       <p:sp>
         <p:nvSpPr>
-          <p:cNvPr id="5" name="Text 3"/>
+          <p:cNvPr id="6" name="Text 3"/>
           <p:cNvSpPr txBox="1"/>
           <p:nvPr/>
         </p:nvSpPr>
@@ -27111,7 +27126,7 @@
       </p:sp>
       <p:sp>
         <p:nvSpPr>
-          <p:cNvPr id="6" name="Text 4"/>
+          <p:cNvPr id="7" name="Text 4"/>
           <p:cNvSpPr txBox="1"/>
           <p:nvPr/>
         </p:nvSpPr>
@@ -27150,7 +27165,7 @@
       </p:sp>
       <p:sp>
         <p:nvSpPr>
-          <p:cNvPr id="7" name="Shape 5"/>
+          <p:cNvPr id="8" name="Shape 5"/>
           <p:cNvSpPr/>
           <p:nvPr/>
         </p:nvSpPr>
@@ -27172,7 +27187,7 @@
       </p:sp>
       <p:sp>
         <p:nvSpPr>
-          <p:cNvPr id="8" name="Text 6"/>
+          <p:cNvPr id="9" name="Text 6"/>
           <p:cNvSpPr txBox="1"/>
           <p:nvPr/>
         </p:nvSpPr>
@@ -27211,7 +27226,7 @@
       </p:sp>
       <p:sp>
         <p:nvSpPr>
-          <p:cNvPr id="9" name="Text 7"/>
+          <p:cNvPr id="10" name="Text 7"/>
           <p:cNvSpPr txBox="1"/>
           <p:nvPr/>
         </p:nvSpPr>
@@ -27250,7 +27265,7 @@
       </p:sp>
       <p:sp>
         <p:nvSpPr>
-          <p:cNvPr id="10" name="Shape 8"/>
+          <p:cNvPr id="11" name="Shape 8"/>
           <p:cNvSpPr/>
           <p:nvPr/>
         </p:nvSpPr>
@@ -27272,7 +27287,7 @@
       </p:sp>
       <p:sp>
         <p:nvSpPr>
-          <p:cNvPr id="11" name="Text 9"/>
+          <p:cNvPr id="12" name="Text 9"/>
           <p:cNvSpPr txBox="1"/>
           <p:nvPr/>
         </p:nvSpPr>
@@ -27311,7 +27326,7 @@
       </p:sp>
       <p:sp>
         <p:nvSpPr>
-          <p:cNvPr id="12" name="Text 10"/>
+          <p:cNvPr id="13" name="Text 10"/>
           <p:cNvSpPr txBox="1"/>
           <p:nvPr/>
         </p:nvSpPr>
@@ -27350,7 +27365,7 @@
       </p:sp>
       <p:sp>
         <p:nvSpPr>
-          <p:cNvPr id="13" name="Shape 11"/>
+          <p:cNvPr id="14" name="Shape 11"/>
           <p:cNvSpPr/>
           <p:nvPr/>
         </p:nvSpPr>
@@ -27372,7 +27387,7 @@
       </p:sp>
       <p:sp>
         <p:nvSpPr>
-          <p:cNvPr id="14" name="Text 12"/>
+          <p:cNvPr id="15" name="Text 12"/>
           <p:cNvSpPr txBox="1"/>
           <p:nvPr/>
         </p:nvSpPr>
@@ -27411,7 +27426,7 @@
       </p:sp>
       <p:sp>
         <p:nvSpPr>
-          <p:cNvPr id="15" name="Text 13"/>
+          <p:cNvPr id="16" name="Text 13"/>
           <p:cNvSpPr txBox="1"/>
           <p:nvPr/>
         </p:nvSpPr>
@@ -27450,7 +27465,7 @@
       </p:sp>
       <p:sp>
         <p:nvSpPr>
-          <p:cNvPr id="16" name="Shape 14"/>
+          <p:cNvPr id="17" name="Shape 14"/>
           <p:cNvSpPr/>
           <p:nvPr/>
         </p:nvSpPr>
@@ -27472,7 +27487,7 @@
       </p:sp>
       <p:sp>
         <p:nvSpPr>
-          <p:cNvPr id="17" name="Text 15"/>
+          <p:cNvPr id="18" name="Text 15"/>
           <p:cNvSpPr txBox="1"/>
           <p:nvPr/>
         </p:nvSpPr>
@@ -27511,7 +27526,7 @@
       </p:sp>
       <p:sp>
         <p:nvSpPr>
-          <p:cNvPr id="18" name="Text 16"/>
+          <p:cNvPr id="19" name="Text 16"/>
           <p:cNvSpPr txBox="1"/>
           <p:nvPr/>
         </p:nvSpPr>
@@ -27550,7 +27565,7 @@
       </p:sp>
       <p:sp>
         <p:nvSpPr>
-          <p:cNvPr id="19" name="Shape 17"/>
+          <p:cNvPr id="20" name="Shape 17"/>
           <p:cNvSpPr/>
           <p:nvPr/>
         </p:nvSpPr>
@@ -27572,7 +27587,7 @@
       </p:sp>
       <p:sp>
         <p:nvSpPr>
-          <p:cNvPr id="20" name="Text 18"/>
+          <p:cNvPr id="21" name="Text 18"/>
           <p:cNvSpPr txBox="1"/>
           <p:nvPr/>
         </p:nvSpPr>
@@ -27611,7 +27626,7 @@
       </p:sp>
       <p:sp>
         <p:nvSpPr>
-          <p:cNvPr id="21" name="Text 19"/>
+          <p:cNvPr id="22" name="Text 19"/>
           <p:cNvSpPr txBox="1"/>
           <p:nvPr/>
         </p:nvSpPr>
@@ -27650,7 +27665,7 @@
       </p:sp>
       <p:sp>
         <p:nvSpPr>
-          <p:cNvPr id="22" name="Shape 20"/>
+          <p:cNvPr id="23" name="Shape 20"/>
           <p:cNvSpPr/>
           <p:nvPr/>
         </p:nvSpPr>
@@ -27672,7 +27687,7 @@
       </p:sp>
       <p:sp>
         <p:nvSpPr>
-          <p:cNvPr id="23" name="Text 21"/>
+          <p:cNvPr id="24" name="Text 21"/>
           <p:cNvSpPr txBox="1"/>
           <p:nvPr/>
         </p:nvSpPr>
@@ -27711,7 +27726,7 @@
       </p:sp>
       <p:sp>
         <p:nvSpPr>
-          <p:cNvPr id="24" name="Text 22"/>
+          <p:cNvPr id="25" name="Text 22"/>
           <p:cNvSpPr txBox="1"/>
           <p:nvPr/>
         </p:nvSpPr>
@@ -27750,7 +27765,7 @@
       </p:sp>
       <p:sp>
         <p:nvSpPr>
-          <p:cNvPr id="25" name="Shape 23"/>
+          <p:cNvPr id="26" name="Shape 23"/>
           <p:cNvSpPr/>
           <p:nvPr/>
         </p:nvSpPr>
@@ -27772,7 +27787,7 @@
       </p:sp>
       <p:sp>
         <p:nvSpPr>
-          <p:cNvPr id="26" name="Text 24"/>
+          <p:cNvPr id="27" name="Text 24"/>
           <p:cNvSpPr txBox="1"/>
           <p:nvPr/>
         </p:nvSpPr>
@@ -27811,7 +27826,7 @@
       </p:sp>
       <p:sp>
         <p:nvSpPr>
-          <p:cNvPr id="27" name="Text 25"/>
+          <p:cNvPr id="28" name="Text 25"/>
           <p:cNvSpPr txBox="1"/>
           <p:nvPr/>
         </p:nvSpPr>
@@ -27881,7 +27896,7 @@
       </p:sp>
       <p:sp>
         <p:nvSpPr>
-          <p:cNvPr id="28" name="Text 26"/>
+          <p:cNvPr id="29" name="Text 26"/>
           <p:cNvSpPr txBox="1"/>
           <p:nvPr/>
         </p:nvSpPr>
@@ -27920,7 +27935,7 @@
       </p:sp>
       <p:sp>
         <p:nvSpPr>
-          <p:cNvPr id="29" name="Text 27"/>
+          <p:cNvPr id="30" name="Text 27"/>
           <p:cNvSpPr txBox="1"/>
           <p:nvPr/>
         </p:nvSpPr>
@@ -27991,7 +28006,7 @@
       </p:grpSpPr>
       <p:sp>
         <p:nvSpPr>
-          <p:cNvPr id="2" name="Text 0"/>
+          <p:cNvPr id="3" name="Text 0"/>
           <p:cNvSpPr txBox="1"/>
           <p:nvPr/>
         </p:nvSpPr>
@@ -28030,7 +28045,7 @@
       </p:sp>
       <p:sp>
         <p:nvSpPr>
-          <p:cNvPr id="3" name="Text 1"/>
+          <p:cNvPr id="4" name="Text 1"/>
           <p:cNvSpPr txBox="1"/>
           <p:nvPr/>
         </p:nvSpPr>
@@ -28069,7 +28084,7 @@
       </p:sp>
       <p:sp>
         <p:nvSpPr>
-          <p:cNvPr id="4" name="Shape 2"/>
+          <p:cNvPr id="5" name="Shape 2"/>
           <p:cNvSpPr/>
           <p:nvPr/>
         </p:nvSpPr>
@@ -28091,7 +28106,7 @@
       </p:sp>
       <p:sp>
         <p:nvSpPr>
-          <p:cNvPr id="5" name="Text 3"/>
+          <p:cNvPr id="6" name="Text 3"/>
           <p:cNvSpPr txBox="1"/>
           <p:nvPr/>
         </p:nvSpPr>
@@ -28130,7 +28145,7 @@
       </p:sp>
       <p:sp>
         <p:nvSpPr>
-          <p:cNvPr id="6" name="Text 4"/>
+          <p:cNvPr id="7" name="Text 4"/>
           <p:cNvSpPr txBox="1"/>
           <p:nvPr/>
         </p:nvSpPr>
@@ -28224,7 +28239,7 @@
       </p:sp>
       <p:sp>
         <p:nvSpPr>
-          <p:cNvPr id="7" name="Shape 5"/>
+          <p:cNvPr id="8" name="Shape 5"/>
           <p:cNvSpPr/>
           <p:nvPr/>
         </p:nvSpPr>
@@ -28246,7 +28261,7 @@
       </p:sp>
       <p:sp>
         <p:nvSpPr>
-          <p:cNvPr id="8" name="Text 6"/>
+          <p:cNvPr id="9" name="Text 6"/>
           <p:cNvSpPr txBox="1"/>
           <p:nvPr/>
         </p:nvSpPr>
@@ -28285,7 +28300,7 @@
       </p:sp>
       <p:sp>
         <p:nvSpPr>
-          <p:cNvPr id="9" name="Text 7"/>
+          <p:cNvPr id="10" name="Text 7"/>
           <p:cNvSpPr txBox="1"/>
           <p:nvPr/>
         </p:nvSpPr>
@@ -28379,7 +28394,7 @@
       </p:sp>
       <p:sp>
         <p:nvSpPr>
-          <p:cNvPr id="10" name="Text 8"/>
+          <p:cNvPr id="11" name="Text 8"/>
           <p:cNvSpPr txBox="1"/>
           <p:nvPr/>
         </p:nvSpPr>
@@ -28418,7 +28433,7 @@
       </p:sp>
       <p:sp>
         <p:nvSpPr>
-          <p:cNvPr id="11" name="Text 9"/>
+          <p:cNvPr id="12" name="Text 9"/>
           <p:cNvSpPr txBox="1"/>
           <p:nvPr/>
         </p:nvSpPr>
@@ -28489,7 +28504,7 @@
       </p:grpSpPr>
       <p:sp>
         <p:nvSpPr>
-          <p:cNvPr id="2" name="Shape 0"/>
+          <p:cNvPr id="3" name="Shape 0"/>
           <p:cNvSpPr/>
           <p:nvPr/>
         </p:nvSpPr>
@@ -28509,7 +28524,7 @@
       </p:sp>
       <p:sp>
         <p:nvSpPr>
-          <p:cNvPr id="3" name="Shape 1"/>
+          <p:cNvPr id="4" name="Shape 1"/>
           <p:cNvSpPr/>
           <p:nvPr/>
         </p:nvSpPr>
@@ -28534,7 +28549,7 @@
       </p:sp>
       <p:sp>
         <p:nvSpPr>
-          <p:cNvPr id="4" name="Text 2"/>
+          <p:cNvPr id="5" name="Text 2"/>
           <p:cNvSpPr txBox="1"/>
           <p:nvPr/>
         </p:nvSpPr>
@@ -28573,7 +28588,7 @@
       </p:sp>
       <p:sp>
         <p:nvSpPr>
-          <p:cNvPr id="5" name="Text 3"/>
+          <p:cNvPr id="6" name="Text 3"/>
           <p:cNvSpPr txBox="1"/>
           <p:nvPr/>
         </p:nvSpPr>
@@ -28612,7 +28627,7 @@
       </p:sp>
       <p:sp>
         <p:nvSpPr>
-          <p:cNvPr id="6" name="Text 4"/>
+          <p:cNvPr id="7" name="Text 4"/>
           <p:cNvSpPr txBox="1"/>
           <p:nvPr/>
         </p:nvSpPr>
@@ -28651,7 +28666,7 @@
       </p:sp>
       <p:sp>
         <p:nvSpPr>
-          <p:cNvPr id="7" name="Text 5"/>
+          <p:cNvPr id="8" name="Text 5"/>
           <p:cNvSpPr txBox="1"/>
           <p:nvPr/>
         </p:nvSpPr>
@@ -28690,7 +28705,7 @@
       </p:sp>
       <p:sp>
         <p:nvSpPr>
-          <p:cNvPr id="8" name="Text 6"/>
+          <p:cNvPr id="9" name="Text 6"/>
           <p:cNvSpPr txBox="1"/>
           <p:nvPr/>
         </p:nvSpPr>
@@ -28729,7 +28744,7 @@
       </p:sp>
       <p:sp>
         <p:nvSpPr>
-          <p:cNvPr id="9" name="Text 7"/>
+          <p:cNvPr id="10" name="Text 7"/>
           <p:cNvSpPr txBox="1"/>
           <p:nvPr/>
         </p:nvSpPr>
@@ -28800,7 +28815,7 @@
       </p:grpSpPr>
       <p:sp>
         <p:nvSpPr>
-          <p:cNvPr id="2" name="Text 0"/>
+          <p:cNvPr id="3" name="Text 0"/>
           <p:cNvSpPr txBox="1"/>
           <p:nvPr/>
         </p:nvSpPr>
@@ -28839,7 +28854,7 @@
       </p:sp>
       <p:sp>
         <p:nvSpPr>
-          <p:cNvPr id="3" name="Text 1"/>
+          <p:cNvPr id="4" name="Text 1"/>
           <p:cNvSpPr txBox="1"/>
           <p:nvPr/>
         </p:nvSpPr>
@@ -28878,7 +28893,7 @@
       </p:sp>
       <p:sp>
         <p:nvSpPr>
-          <p:cNvPr id="4" name="Text 2"/>
+          <p:cNvPr id="5" name="Text 2"/>
           <p:cNvSpPr txBox="1"/>
           <p:nvPr/>
         </p:nvSpPr>
@@ -28996,7 +29011,7 @@
       </p:sp>
       <p:sp>
         <p:nvSpPr>
-          <p:cNvPr id="5" name="Shape 3"/>
+          <p:cNvPr id="6" name="Shape 3"/>
           <p:cNvSpPr/>
           <p:nvPr/>
         </p:nvSpPr>
@@ -29018,7 +29033,7 @@
       </p:sp>
       <p:sp>
         <p:nvSpPr>
-          <p:cNvPr id="6" name="Text 4"/>
+          <p:cNvPr id="7" name="Text 4"/>
           <p:cNvSpPr txBox="1"/>
           <p:nvPr/>
         </p:nvSpPr>
@@ -29082,7 +29097,7 @@
       </p:sp>
       <p:sp>
         <p:nvSpPr>
-          <p:cNvPr id="7" name="Shape 5"/>
+          <p:cNvPr id="8" name="Shape 5"/>
           <p:cNvSpPr/>
           <p:nvPr/>
         </p:nvSpPr>
@@ -29104,7 +29119,7 @@
       </p:sp>
       <p:sp>
         <p:nvSpPr>
-          <p:cNvPr id="8" name="Text 6"/>
+          <p:cNvPr id="9" name="Text 6"/>
           <p:cNvSpPr txBox="1"/>
           <p:nvPr/>
         </p:nvSpPr>
@@ -29168,7 +29183,7 @@
       </p:sp>
       <p:sp>
         <p:nvSpPr>
-          <p:cNvPr id="9" name="Text 7"/>
+          <p:cNvPr id="10" name="Text 7"/>
           <p:cNvSpPr txBox="1"/>
           <p:nvPr/>
         </p:nvSpPr>
@@ -29207,7 +29222,7 @@
       </p:sp>
       <p:sp>
         <p:nvSpPr>
-          <p:cNvPr id="10" name="Text 8"/>
+          <p:cNvPr id="11" name="Text 8"/>
           <p:cNvSpPr txBox="1"/>
           <p:nvPr/>
         </p:nvSpPr>
@@ -29246,7 +29261,7 @@
       </p:sp>
       <p:sp>
         <p:nvSpPr>
-          <p:cNvPr id="11" name="Text 9"/>
+          <p:cNvPr id="12" name="Text 9"/>
           <p:cNvSpPr txBox="1"/>
           <p:nvPr/>
         </p:nvSpPr>
@@ -29317,7 +29332,7 @@
       </p:grpSpPr>
       <p:sp>
         <p:nvSpPr>
-          <p:cNvPr id="2" name="Text 0"/>
+          <p:cNvPr id="3" name="Text 0"/>
           <p:cNvSpPr txBox="1"/>
           <p:nvPr/>
         </p:nvSpPr>
@@ -29356,7 +29371,7 @@
       </p:sp>
       <p:sp>
         <p:nvSpPr>
-          <p:cNvPr id="3" name="Text 1"/>
+          <p:cNvPr id="4" name="Text 1"/>
           <p:cNvSpPr txBox="1"/>
           <p:nvPr/>
         </p:nvSpPr>
@@ -29395,7 +29410,7 @@
       </p:sp>
       <p:sp>
         <p:nvSpPr>
-          <p:cNvPr id="4" name="Text 2"/>
+          <p:cNvPr id="5" name="Text 2"/>
           <p:cNvSpPr txBox="1"/>
           <p:nvPr/>
         </p:nvSpPr>
@@ -29513,7 +29528,7 @@
       </p:sp>
       <p:sp>
         <p:nvSpPr>
-          <p:cNvPr id="5" name="Shape 3"/>
+          <p:cNvPr id="6" name="Shape 3"/>
           <p:cNvSpPr/>
           <p:nvPr/>
         </p:nvSpPr>
@@ -29535,7 +29550,7 @@
       </p:sp>
       <p:sp>
         <p:nvSpPr>
-          <p:cNvPr id="6" name="Text 4"/>
+          <p:cNvPr id="7" name="Text 4"/>
           <p:cNvSpPr txBox="1"/>
           <p:nvPr/>
         </p:nvSpPr>
@@ -29574,7 +29589,7 @@
       </p:sp>
       <p:sp>
         <p:nvSpPr>
-          <p:cNvPr id="7" name="Text 5"/>
+          <p:cNvPr id="8" name="Text 5"/>
           <p:cNvSpPr txBox="1"/>
           <p:nvPr/>
         </p:nvSpPr>
@@ -29668,7 +29683,7 @@
       </p:sp>
       <p:sp>
         <p:nvSpPr>
-          <p:cNvPr id="8" name="Text 6"/>
+          <p:cNvPr id="9" name="Text 6"/>
           <p:cNvSpPr txBox="1"/>
           <p:nvPr/>
         </p:nvSpPr>
@@ -29707,7 +29722,7 @@
       </p:sp>
       <p:sp>
         <p:nvSpPr>
-          <p:cNvPr id="9" name="Text 7"/>
+          <p:cNvPr id="10" name="Text 7"/>
           <p:cNvSpPr txBox="1"/>
           <p:nvPr/>
         </p:nvSpPr>
@@ -29746,7 +29761,7 @@
       </p:sp>
       <p:sp>
         <p:nvSpPr>
-          <p:cNvPr id="10" name="Text 8"/>
+          <p:cNvPr id="11" name="Text 8"/>
           <p:cNvSpPr txBox="1"/>
           <p:nvPr/>
         </p:nvSpPr>

</xml_diff>

<commit_message>
Rewrite the remaining stiff Greek in the presentation
</commit_message>
<xml_diff>
--- a/ensights-thesis-defense.pptx
+++ b/ensights-thesis-defense.pptx
@@ -20281,7 +20281,7 @@
                 <a:ea typeface="Calibri" pitchFamily="34" charset="-122"/>
                 <a:cs typeface="Calibri" pitchFamily="34" charset="-120"/>
               </a:rPr>
-              <a:t>Δεν υπάρχει κόστος πωληθέντων ούτε δαπάνες marketing στο dataset ⇒ κάθε απόκριση φέρει ρητή δήλωση “Scenario output, not a measurement”.</a:t>
+              <a:t>Το dataset δεν έχει κόστος πωληθέντων ούτε δαπάνες marketing, οπότε κάθε απάντηση βγαίνει με τη σήμανση “Scenario output, not a measurement”.</a:t>
             </a:r>
             <a:endParaRPr lang="en-US" sz="1200" dirty="0"/>
           </a:p>
@@ -25150,7 +25150,7 @@
                   <a:srgbClr val="6B6259"/>
                 </a:solidFill>
               </a:rPr>
-              <a:t>Χαρακτηριστικά από λέξεις-κλειδιά· 38,9% των εσόδων uncategorised, δηλωμένο ρητά.</a:t>
+              <a:t>Χαρακτηριστικά από λέξεις-κλειδιά, με το 38,9% των εσόδων uncategorised. Το λέμε ανοιχτά.</a:t>
             </a:r>
             <a:endParaRPr lang="en-US" sz="1350" dirty="0"/>
           </a:p>
@@ -26525,7 +26525,7 @@
                 <a:ea typeface="Calibri" pitchFamily="34" charset="-122"/>
                 <a:cs typeface="Calibri" pitchFamily="34" charset="-120"/>
               </a:rPr>
-              <a:t>Στην πράξη τα δεδομένα παραμένουν συχνά αναξιοποίητα: οι αποφάσεις marketing και πωλήσεων λαμβάνονται με εμπειρία και διαίσθηση.</a:t>
+              <a:t>Στην πράξη τα δεδομένα μένουν συχνά αναξιοποίητα: οι αποφάσεις marketing και πωλήσεων παίρνονται με εμπειρία και διαίσθηση.</a:t>
             </a:r>
             <a:endParaRPr lang="en-US" sz="1500" dirty="0"/>
           </a:p>
@@ -28061,7 +28061,7 @@
                 <a:ea typeface="Cambria" pitchFamily="34" charset="-122"/>
                 <a:cs typeface="Cambria" pitchFamily="34" charset="-120"/>
               </a:rPr>
-              <a:t>Δύο απαιτήσεις που διαπερνούν το σύστημα</a:t>
+              <a:t>Δύο απαιτήσεις που περνάνε παντού</a:t>
             </a:r>
             <a:endParaRPr lang="en-US" sz="3000" dirty="0"/>
           </a:p>
@@ -28371,7 +28371,7 @@
                 <a:ea typeface="Calibri" pitchFamily="34" charset="-122"/>
                 <a:cs typeface="Calibri" pitchFamily="34" charset="-120"/>
               </a:rPr>
-              <a:t>Η κερδοφορία υλοποιείται ως ρητή ανάλυση ευαισθησίας πάνω σε δηλωμένες παραδοχές, με τη δήλωση “σενάριο, όχι μέτρηση” να ταξιδεύει μαζί με κάθε απόκριση.</a:t>
+              <a:t>Η κερδοφορία βγαίνει ως ανάλυση ευαισθησίας πάνω σε παραδοχές που δηλώνονται ανοιχτά, και η σήμανση “σενάριο, όχι μέτρηση” πάει μαζί με κάθε απάντηση.</a:t>
             </a:r>
             <a:endParaRPr lang="en-US" sz="1300" dirty="0"/>
           </a:p>

</xml_diff>